<commit_message>
Edited the manuscript and flow chart based on the comments of SR,TK, and MG
</commit_message>
<xml_diff>
--- a/manuscript/figures/flowchart_GIST.pptx
+++ b/manuscript/figures/flowchart_GIST.pptx
@@ -255,7 +255,7 @@
           <a:p>
             <a:fld id="{CE335E54-2A4B-4CD0-9488-F8D5DEC3B8E4}" type="datetimeFigureOut">
               <a:rPr lang="en-US" smtClean="0"/>
-              <a:t>5/24/2025</a:t>
+              <a:t>6/5/2025</a:t>
             </a:fld>
             <a:endParaRPr lang="en-US"/>
           </a:p>
@@ -297,7 +297,7 @@
           <a:p>
             <a:fld id="{A6E23FE4-E4CE-4C11-A4DD-B8B389B3DC1D}" type="slidenum">
               <a:rPr lang="en-US" smtClean="0"/>
-              <a:t>‹Nr.›</a:t>
+              <a:t>‹#›</a:t>
             </a:fld>
             <a:endParaRPr lang="en-US"/>
           </a:p>
@@ -425,7 +425,7 @@
           <a:p>
             <a:fld id="{CE335E54-2A4B-4CD0-9488-F8D5DEC3B8E4}" type="datetimeFigureOut">
               <a:rPr lang="en-US" smtClean="0"/>
-              <a:t>5/24/2025</a:t>
+              <a:t>6/5/2025</a:t>
             </a:fld>
             <a:endParaRPr lang="en-US"/>
           </a:p>
@@ -467,7 +467,7 @@
           <a:p>
             <a:fld id="{A6E23FE4-E4CE-4C11-A4DD-B8B389B3DC1D}" type="slidenum">
               <a:rPr lang="en-US" smtClean="0"/>
-              <a:t>‹Nr.›</a:t>
+              <a:t>‹#›</a:t>
             </a:fld>
             <a:endParaRPr lang="en-US"/>
           </a:p>
@@ -605,7 +605,7 @@
           <a:p>
             <a:fld id="{CE335E54-2A4B-4CD0-9488-F8D5DEC3B8E4}" type="datetimeFigureOut">
               <a:rPr lang="en-US" smtClean="0"/>
-              <a:t>5/24/2025</a:t>
+              <a:t>6/5/2025</a:t>
             </a:fld>
             <a:endParaRPr lang="en-US"/>
           </a:p>
@@ -647,7 +647,7 @@
           <a:p>
             <a:fld id="{A6E23FE4-E4CE-4C11-A4DD-B8B389B3DC1D}" type="slidenum">
               <a:rPr lang="en-US" smtClean="0"/>
-              <a:t>‹Nr.›</a:t>
+              <a:t>‹#›</a:t>
             </a:fld>
             <a:endParaRPr lang="en-US"/>
           </a:p>
@@ -775,7 +775,7 @@
           <a:p>
             <a:fld id="{CE335E54-2A4B-4CD0-9488-F8D5DEC3B8E4}" type="datetimeFigureOut">
               <a:rPr lang="en-US" smtClean="0"/>
-              <a:t>5/24/2025</a:t>
+              <a:t>6/5/2025</a:t>
             </a:fld>
             <a:endParaRPr lang="en-US"/>
           </a:p>
@@ -817,7 +817,7 @@
           <a:p>
             <a:fld id="{A6E23FE4-E4CE-4C11-A4DD-B8B389B3DC1D}" type="slidenum">
               <a:rPr lang="en-US" smtClean="0"/>
-              <a:t>‹Nr.›</a:t>
+              <a:t>‹#›</a:t>
             </a:fld>
             <a:endParaRPr lang="en-US"/>
           </a:p>
@@ -1021,7 +1021,7 @@
           <a:p>
             <a:fld id="{CE335E54-2A4B-4CD0-9488-F8D5DEC3B8E4}" type="datetimeFigureOut">
               <a:rPr lang="en-US" smtClean="0"/>
-              <a:t>5/24/2025</a:t>
+              <a:t>6/5/2025</a:t>
             </a:fld>
             <a:endParaRPr lang="en-US"/>
           </a:p>
@@ -1063,7 +1063,7 @@
           <a:p>
             <a:fld id="{A6E23FE4-E4CE-4C11-A4DD-B8B389B3DC1D}" type="slidenum">
               <a:rPr lang="en-US" smtClean="0"/>
-              <a:t>‹Nr.›</a:t>
+              <a:t>‹#›</a:t>
             </a:fld>
             <a:endParaRPr lang="en-US"/>
           </a:p>
@@ -1253,7 +1253,7 @@
           <a:p>
             <a:fld id="{CE335E54-2A4B-4CD0-9488-F8D5DEC3B8E4}" type="datetimeFigureOut">
               <a:rPr lang="en-US" smtClean="0"/>
-              <a:t>5/24/2025</a:t>
+              <a:t>6/5/2025</a:t>
             </a:fld>
             <a:endParaRPr lang="en-US"/>
           </a:p>
@@ -1295,7 +1295,7 @@
           <a:p>
             <a:fld id="{A6E23FE4-E4CE-4C11-A4DD-B8B389B3DC1D}" type="slidenum">
               <a:rPr lang="en-US" smtClean="0"/>
-              <a:t>‹Nr.›</a:t>
+              <a:t>‹#›</a:t>
             </a:fld>
             <a:endParaRPr lang="en-US"/>
           </a:p>
@@ -1620,7 +1620,7 @@
           <a:p>
             <a:fld id="{CE335E54-2A4B-4CD0-9488-F8D5DEC3B8E4}" type="datetimeFigureOut">
               <a:rPr lang="en-US" smtClean="0"/>
-              <a:t>5/24/2025</a:t>
+              <a:t>6/5/2025</a:t>
             </a:fld>
             <a:endParaRPr lang="en-US"/>
           </a:p>
@@ -1662,7 +1662,7 @@
           <a:p>
             <a:fld id="{A6E23FE4-E4CE-4C11-A4DD-B8B389B3DC1D}" type="slidenum">
               <a:rPr lang="en-US" smtClean="0"/>
-              <a:t>‹Nr.›</a:t>
+              <a:t>‹#›</a:t>
             </a:fld>
             <a:endParaRPr lang="en-US"/>
           </a:p>
@@ -1738,7 +1738,7 @@
           <a:p>
             <a:fld id="{CE335E54-2A4B-4CD0-9488-F8D5DEC3B8E4}" type="datetimeFigureOut">
               <a:rPr lang="en-US" smtClean="0"/>
-              <a:t>5/24/2025</a:t>
+              <a:t>6/5/2025</a:t>
             </a:fld>
             <a:endParaRPr lang="en-US"/>
           </a:p>
@@ -1780,7 +1780,7 @@
           <a:p>
             <a:fld id="{A6E23FE4-E4CE-4C11-A4DD-B8B389B3DC1D}" type="slidenum">
               <a:rPr lang="en-US" smtClean="0"/>
-              <a:t>‹Nr.›</a:t>
+              <a:t>‹#›</a:t>
             </a:fld>
             <a:endParaRPr lang="en-US"/>
           </a:p>
@@ -1833,7 +1833,7 @@
           <a:p>
             <a:fld id="{CE335E54-2A4B-4CD0-9488-F8D5DEC3B8E4}" type="datetimeFigureOut">
               <a:rPr lang="en-US" smtClean="0"/>
-              <a:t>5/24/2025</a:t>
+              <a:t>6/5/2025</a:t>
             </a:fld>
             <a:endParaRPr lang="en-US"/>
           </a:p>
@@ -1875,7 +1875,7 @@
           <a:p>
             <a:fld id="{A6E23FE4-E4CE-4C11-A4DD-B8B389B3DC1D}" type="slidenum">
               <a:rPr lang="en-US" smtClean="0"/>
-              <a:t>‹Nr.›</a:t>
+              <a:t>‹#›</a:t>
             </a:fld>
             <a:endParaRPr lang="en-US"/>
           </a:p>
@@ -2110,7 +2110,7 @@
           <a:p>
             <a:fld id="{CE335E54-2A4B-4CD0-9488-F8D5DEC3B8E4}" type="datetimeFigureOut">
               <a:rPr lang="en-US" smtClean="0"/>
-              <a:t>5/24/2025</a:t>
+              <a:t>6/5/2025</a:t>
             </a:fld>
             <a:endParaRPr lang="en-US"/>
           </a:p>
@@ -2152,7 +2152,7 @@
           <a:p>
             <a:fld id="{A6E23FE4-E4CE-4C11-A4DD-B8B389B3DC1D}" type="slidenum">
               <a:rPr lang="en-US" smtClean="0"/>
-              <a:t>‹Nr.›</a:t>
+              <a:t>‹#›</a:t>
             </a:fld>
             <a:endParaRPr lang="en-US"/>
           </a:p>
@@ -2367,7 +2367,7 @@
           <a:p>
             <a:fld id="{CE335E54-2A4B-4CD0-9488-F8D5DEC3B8E4}" type="datetimeFigureOut">
               <a:rPr lang="en-US" smtClean="0"/>
-              <a:t>5/24/2025</a:t>
+              <a:t>6/5/2025</a:t>
             </a:fld>
             <a:endParaRPr lang="en-US"/>
           </a:p>
@@ -2409,7 +2409,7 @@
           <a:p>
             <a:fld id="{A6E23FE4-E4CE-4C11-A4DD-B8B389B3DC1D}" type="slidenum">
               <a:rPr lang="en-US" smtClean="0"/>
-              <a:t>‹Nr.›</a:t>
+              <a:t>‹#›</a:t>
             </a:fld>
             <a:endParaRPr lang="en-US"/>
           </a:p>
@@ -2580,7 +2580,7 @@
           <a:p>
             <a:fld id="{CE335E54-2A4B-4CD0-9488-F8D5DEC3B8E4}" type="datetimeFigureOut">
               <a:rPr lang="en-US" smtClean="0"/>
-              <a:t>5/24/2025</a:t>
+              <a:t>6/5/2025</a:t>
             </a:fld>
             <a:endParaRPr lang="en-US"/>
           </a:p>
@@ -2658,7 +2658,7 @@
           <a:p>
             <a:fld id="{A6E23FE4-E4CE-4C11-A4DD-B8B389B3DC1D}" type="slidenum">
               <a:rPr lang="en-US" smtClean="0"/>
-              <a:t>‹Nr.›</a:t>
+              <a:t>‹#›</a:t>
             </a:fld>
             <a:endParaRPr lang="en-US"/>
           </a:p>
@@ -3247,8 +3247,8 @@
           </a:p>
         </p:txBody>
       </p:sp>
-      <mc:AlternateContent xmlns:mc="http://schemas.openxmlformats.org/markup-compatibility/2006" xmlns:a14="http://schemas.microsoft.com/office/drawing/2010/main">
-        <mc:Choice Requires="a14">
+      <mc:AlternateContent xmlns:mc="http://schemas.openxmlformats.org/markup-compatibility/2006">
+        <mc:Choice xmlns:a14="http://schemas.microsoft.com/office/drawing/2010/main" Requires="a14">
           <p:sp>
             <p:nvSpPr>
               <p:cNvPr id="14" name="TextBox 13">
@@ -3264,7 +3264,7 @@
             <p:spPr>
               <a:xfrm>
                 <a:off x="4752848" y="0"/>
-                <a:ext cx="2096500" cy="9417963"/>
+                <a:ext cx="2096500" cy="8494633"/>
               </a:xfrm>
               <a:prstGeom prst="rect">
                 <a:avLst/>
@@ -3445,39 +3445,7 @@
                 </a:pPr>
                 <a:r>
                   <a:rPr lang="de-AT" sz="1200" dirty="0"/>
-                  <a:t>Optional: Remove </a:t>
-                </a:r>
-                <a:r>
-                  <a:rPr lang="de-AT" sz="1200" dirty="0" err="1"/>
-                  <a:t>solute</a:t>
-                </a:r>
-                <a:r>
-                  <a:rPr lang="de-AT" sz="1200" dirty="0"/>
-                  <a:t> </a:t>
-                </a:r>
-                <a:r>
-                  <a:rPr lang="de-AT" sz="1200" dirty="0" err="1"/>
-                  <a:t>to</a:t>
-                </a:r>
-                <a:r>
-                  <a:rPr lang="de-AT" sz="1200" dirty="0"/>
-                  <a:t> </a:t>
-                </a:r>
-                <a:r>
-                  <a:rPr lang="de-AT" sz="1200" dirty="0" err="1"/>
-                  <a:t>create</a:t>
-                </a:r>
-                <a:r>
-                  <a:rPr lang="de-AT" sz="1200" dirty="0"/>
-                  <a:t> </a:t>
-                </a:r>
-                <a:r>
-                  <a:rPr lang="de-AT" sz="1200" dirty="0" err="1"/>
-                  <a:t>bulk</a:t>
-                </a:r>
-                <a:r>
-                  <a:rPr lang="de-AT" sz="1200" dirty="0"/>
-                  <a:t> solvent box</a:t>
+                  <a:t>Optional: create neat solvent box and determine NN entropy bias</a:t>
                 </a:r>
               </a:p>
               <a:p>
@@ -3719,14 +3687,11 @@
                 </a:pPr>
                 <a:r>
                   <a:rPr lang="en-US" sz="1200" dirty="0"/>
-                  <a:t>Check RMSD of solute</a:t>
-                </a:r>
-                <a:br>
+                  <a:t>Confirm rigidity of solute heavy atoms:  Suggested RMSD </a:t>
+                </a:r>
+                <a:r>
                   <a:rPr lang="en-US" sz="1000" dirty="0"/>
-                </a:br>
-                <a:r>
-                  <a:rPr lang="en-US" sz="1000" dirty="0"/>
-                  <a:t>≤ 0.5Å ( 0.1Å or lower ideal)</a:t>
+                  <a:t>≤ 0.1Å</a:t>
                 </a:r>
                 <a:br>
                   <a:rPr lang="en-US" sz="1000" dirty="0"/>
@@ -3750,15 +3715,7 @@
                 </a:r>
                 <a:r>
                   <a:rPr lang="de-AT" sz="1200" dirty="0"/>
-                  <a:t>reference </a:t>
-                </a:r>
-                <a:r>
-                  <a:rPr lang="de-AT" sz="1200" dirty="0" err="1"/>
-                  <a:t>density</a:t>
-                </a:r>
-                <a:r>
-                  <a:rPr lang="de-AT" sz="1200" dirty="0"/>
-                  <a:t> </a:t>
+                  <a:t>reference water density </a:t>
                 </a:r>
                 <a14:m>
                   <m:oMath xmlns:m="http://schemas.openxmlformats.org/officeDocument/2006/math">
@@ -3793,108 +3750,8 @@
                   <a:rPr lang="de-AT" sz="1200" b="1" dirty="0"/>
                 </a:br>
                 <a:r>
-                  <a:rPr lang="de-AT" sz="1000" dirty="0" err="1"/>
-                  <a:t>Calculate</a:t>
-                </a:r>
-                <a:r>
                   <a:rPr lang="de-AT" sz="1000" dirty="0"/>
-                  <a:t> </a:t>
-                </a:r>
-                <a:r>
-                  <a:rPr lang="de-AT" sz="1000" dirty="0" err="1"/>
-                  <a:t>from</a:t>
-                </a:r>
-                <a:r>
-                  <a:rPr lang="de-AT" sz="1000" dirty="0"/>
-                  <a:t> </a:t>
-                </a:r>
-                <a:r>
-                  <a:rPr lang="de-AT" sz="1000" dirty="0" err="1"/>
-                  <a:t>reference</a:t>
-                </a:r>
-                <a:r>
-                  <a:rPr lang="de-AT" sz="1000" dirty="0"/>
-                  <a:t> </a:t>
-                </a:r>
-                <a:r>
-                  <a:rPr lang="de-AT" sz="1000" dirty="0" err="1"/>
-                  <a:t>bulk</a:t>
-                </a:r>
-                <a:r>
-                  <a:rPr lang="de-AT" sz="1000" dirty="0"/>
-                  <a:t> </a:t>
-                </a:r>
-                <a:r>
-                  <a:rPr lang="de-AT" sz="1000" dirty="0" err="1"/>
-                  <a:t>simulation</a:t>
-                </a:r>
-                <a:r>
-                  <a:rPr lang="de-AT" sz="1000" dirty="0"/>
-                  <a:t> </a:t>
-                </a:r>
-                <a:r>
-                  <a:rPr lang="de-AT" sz="1000" dirty="0" err="1"/>
-                  <a:t>or</a:t>
-                </a:r>
-                <a:r>
-                  <a:rPr lang="de-AT" sz="1000" dirty="0"/>
-                  <a:t> </a:t>
-                </a:r>
-                <a:r>
-                  <a:rPr lang="de-AT" sz="1000" dirty="0" err="1"/>
-                  <a:t>use</a:t>
-                </a:r>
-                <a:r>
-                  <a:rPr lang="de-AT" sz="1000" dirty="0"/>
-                  <a:t> </a:t>
-                </a:r>
-                <a:r>
-                  <a:rPr lang="de-AT" sz="1000" dirty="0" err="1"/>
-                  <a:t>tabulated</a:t>
-                </a:r>
-                <a:r>
-                  <a:rPr lang="de-AT" sz="1000" dirty="0"/>
-                  <a:t> </a:t>
-                </a:r>
-                <a:r>
-                  <a:rPr lang="de-AT" sz="1000" dirty="0" err="1"/>
-                  <a:t>value</a:t>
-                </a:r>
-                <a:r>
-                  <a:rPr lang="de-AT" sz="1000" dirty="0"/>
-                  <a:t> </a:t>
-                </a:r>
-                <a:r>
-                  <a:rPr lang="de-AT" sz="1000" dirty="0" err="1"/>
-                  <a:t>for</a:t>
-                </a:r>
-                <a:r>
-                  <a:rPr lang="de-AT" sz="1000" dirty="0"/>
-                  <a:t> </a:t>
-                </a:r>
-                <a:r>
-                  <a:rPr lang="de-AT" sz="1000" dirty="0" err="1"/>
-                  <a:t>the</a:t>
-                </a:r>
-                <a:r>
-                  <a:rPr lang="de-AT" sz="1000" dirty="0"/>
-                  <a:t> </a:t>
-                </a:r>
-                <a:r>
-                  <a:rPr lang="de-AT" sz="1000" dirty="0" err="1"/>
-                  <a:t>used</a:t>
-                </a:r>
-                <a:r>
-                  <a:rPr lang="de-AT" sz="1000" dirty="0"/>
-                  <a:t> solvent </a:t>
-                </a:r>
-                <a:r>
-                  <a:rPr lang="de-AT" sz="1000" dirty="0" err="1"/>
-                  <a:t>model</a:t>
-                </a:r>
-                <a:r>
-                  <a:rPr lang="de-AT" sz="1000" dirty="0"/>
-                  <a:t>.</a:t>
+                  <a:t>Calculate from reference from neat simulation or use tabulated value for the solvent model.</a:t>
                 </a:r>
               </a:p>
               <a:p>
@@ -3910,8 +3767,12 @@
                   <a:rPr lang="en-US" sz="1200" dirty="0"/>
                 </a:br>
                 <a:r>
+                  <a:rPr lang="en-US" sz="1200" dirty="0"/>
+                  <a:t>a) binding site                       b) full system                        c) 10 </a:t>
+                </a:r>
+                <a:r>
                   <a:rPr lang="en-US" sz="1000" dirty="0"/>
-                  <a:t>Use a small grid focused on a region of interest (e.g. the binding pocket) if interested in local solvent properties or a big grid encompassing at least 2 solvation layers or more around the solute for system properties.</a:t>
+                  <a:t>Å around region of interest </a:t>
                 </a:r>
               </a:p>
               <a:p>
@@ -3921,36 +3782,6 @@
                 </a:pPr>
                 <a:r>
                   <a:rPr lang="en-US" sz="1200" dirty="0"/>
-                  <a:t>Determine voxel length</a:t>
-                </a:r>
-                <a:br>
-                  <a:rPr lang="en-US" sz="1000" dirty="0"/>
-                </a:br>
-                <a:r>
-                  <a:rPr lang="en-US" sz="1000" dirty="0"/>
-                  <a:t>Smaller voxels provide higher fidelity but require longer simulations for converged results. 0.5</a:t>
-                </a:r>
-                <a:r>
-                  <a:rPr lang="en-150" sz="1000"/>
-                  <a:t> </a:t>
-                </a:r>
-                <a:r>
-                  <a:rPr lang="en-US" sz="1000"/>
-                  <a:t>Å </a:t>
-                </a:r>
-                <a:r>
-                  <a:rPr lang="en-US" sz="1000" dirty="0"/>
-                  <a:t>is recommended.</a:t>
-                </a:r>
-                <a:endParaRPr lang="en-US" sz="1200" dirty="0"/>
-              </a:p>
-              <a:p>
-                <a:pPr marL="171450" indent="-171450">
-                  <a:buFont typeface="Wingdings" panose="05000000000000000000" pitchFamily="2" charset="2"/>
-                  <a:buChar char="q"/>
-                </a:pPr>
-                <a:r>
-                  <a:rPr lang="en-US" sz="1200" dirty="0"/>
                   <a:t>Determine voxel number</a:t>
                 </a:r>
                 <a:br>
@@ -3970,7 +3801,7 @@
                 </a:r>
                 <a:r>
                   <a:rPr lang="en-US" sz="1000" dirty="0"/>
-                  <a:t>n direction, the number of voxels necessary is the length of the region of interest divided by the voxel side length.</a:t>
+                  <a:t>n direction, the number of voxels necessary is the length of the region of interest divided by the voxel side length (0.5 Å ).</a:t>
                 </a:r>
               </a:p>
               <a:p>
@@ -3998,7 +3829,7 @@
             </p:txBody>
           </p:sp>
         </mc:Choice>
-        <mc:Fallback xmlns="">
+        <mc:Fallback>
           <p:sp>
             <p:nvSpPr>
               <p:cNvPr id="14" name="TextBox 13">
@@ -4016,7 +3847,7 @@
             <p:spPr>
               <a:xfrm>
                 <a:off x="4752848" y="0"/>
-                <a:ext cx="2096500" cy="9417963"/>
+                <a:ext cx="2096500" cy="8494633"/>
               </a:xfrm>
               <a:prstGeom prst="rect">
                 <a:avLst/>
@@ -4024,7 +3855,7 @@
               <a:blipFill>
                 <a:blip r:embed="rId2"/>
                 <a:stretch>
-                  <a:fillRect l="-291"/>
+                  <a:fillRect l="-291" r="-1163"/>
                 </a:stretch>
               </a:blipFill>
               <a:ln>
@@ -4036,7 +3867,7 @@
               <a:lstStyle/>
               <a:p>
                 <a:r>
-                  <a:rPr lang="de-AT">
+                  <a:rPr lang="en-US">
                     <a:noFill/>
                   </a:rPr>
                   <a:t> </a:t>
@@ -4942,7 +4773,7 @@
                 </a:r>
                 <a:r>
                   <a:rPr lang="de-AT" sz="1000" dirty="0" err="1"/>
-                  <a:t>enthalpy</a:t>
+                  <a:t>energy</a:t>
                 </a:r>
                 <a:r>
                   <a:rPr lang="de-AT" sz="1000" dirty="0"/>
@@ -5187,28 +5018,12 @@
           <a:p>
             <a:pPr algn="ctr"/>
             <a:r>
-              <a:rPr lang="de-AT" sz="1000" dirty="0" err="1">
+              <a:rPr lang="de-AT" sz="1000" dirty="0">
                 <a:solidFill>
                   <a:schemeClr val="tx1"/>
                 </a:solidFill>
               </a:rPr>
-              <a:t>Minimization</a:t>
-            </a:r>
-            <a:endParaRPr lang="de-AT" sz="1000" dirty="0">
-              <a:solidFill>
-                <a:schemeClr val="tx1"/>
-              </a:solidFill>
-            </a:endParaRPr>
-          </a:p>
-          <a:p>
-            <a:pPr algn="ctr"/>
-            <a:r>
-              <a:rPr lang="de-AT" sz="1000" dirty="0" err="1">
-                <a:solidFill>
-                  <a:schemeClr val="tx1"/>
-                </a:solidFill>
-              </a:rPr>
-              <a:t>Equilibration</a:t>
+              <a:t>Minimization &amp; Equilibration</a:t>
             </a:r>
             <a:endParaRPr lang="en-US" sz="1000" dirty="0">
               <a:solidFill>
@@ -6225,15 +6040,16 @@
             </a:extLst>
           </p:cNvPr>
           <p:cNvCxnSpPr>
-            <a:stCxn id="36" idx="1"/>
+            <a:cxnSpLocks/>
+            <a:stCxn id="24" idx="1"/>
             <a:endCxn id="46" idx="0"/>
           </p:cNvCxnSpPr>
           <p:nvPr/>
         </p:nvCxnSpPr>
         <p:spPr>
           <a:xfrm rot="10800000" flipV="1">
-            <a:off x="2290669" y="5211684"/>
-            <a:ext cx="360000" cy="519272"/>
+            <a:off x="2290669" y="4409820"/>
+            <a:ext cx="360000" cy="1321136"/>
           </a:xfrm>
           <a:prstGeom prst="bentConnector2">
             <a:avLst/>
@@ -6624,6 +6440,38 @@
           </a:fontRef>
         </p:style>
       </p:cxnSp>
+      <p:sp>
+        <p:nvSpPr>
+          <p:cNvPr id="5" name="TextBox 4">
+            <a:extLst>
+              <a:ext uri="{FF2B5EF4-FFF2-40B4-BE49-F238E27FC236}">
+                <a16:creationId xmlns:a16="http://schemas.microsoft.com/office/drawing/2014/main" id="{086A3D53-BD3B-6B4B-0CA2-A572213197E1}"/>
+              </a:ext>
+            </a:extLst>
+          </p:cNvPr>
+          <p:cNvSpPr txBox="1"/>
+          <p:nvPr/>
+        </p:nvSpPr>
+        <p:spPr>
+          <a:xfrm>
+            <a:off x="-3952068" y="2169763"/>
+            <a:ext cx="184731" cy="369332"/>
+          </a:xfrm>
+          <a:prstGeom prst="rect">
+            <a:avLst/>
+          </a:prstGeom>
+          <a:noFill/>
+        </p:spPr>
+        <p:txBody>
+          <a:bodyPr wrap="none" rtlCol="0">
+            <a:spAutoFit/>
+          </a:bodyPr>
+          <a:lstStyle/>
+          <a:p>
+            <a:endParaRPr lang="en-US"/>
+          </a:p>
+        </p:txBody>
+      </p:sp>
     </p:spTree>
     <p:extLst>
       <p:ext uri="{BB962C8B-B14F-4D97-AF65-F5344CB8AC3E}">
@@ -6654,8 +6502,8 @@
           <a:chExt cx="0" cy="0"/>
         </a:xfrm>
       </p:grpSpPr>
-      <mc:AlternateContent xmlns:mc="http://schemas.openxmlformats.org/markup-compatibility/2006" xmlns:a14="http://schemas.microsoft.com/office/drawing/2010/main">
-        <mc:Choice Requires="a14">
+      <mc:AlternateContent xmlns:mc="http://schemas.openxmlformats.org/markup-compatibility/2006">
+        <mc:Choice xmlns:a14="http://schemas.microsoft.com/office/drawing/2010/main" Requires="a14">
           <p:sp>
             <p:nvSpPr>
               <p:cNvPr id="22" name="TextBox 21">
@@ -6671,7 +6519,7 @@
             <p:spPr>
               <a:xfrm>
                 <a:off x="4656316" y="764495"/>
-                <a:ext cx="2208520" cy="7093673"/>
+                <a:ext cx="2208520" cy="7524560"/>
               </a:xfrm>
               <a:prstGeom prst="rect">
                 <a:avLst/>
@@ -7079,35 +6927,7 @@
                 </a:pPr>
                 <a:r>
                   <a:rPr lang="de-AT" sz="1200" dirty="0"/>
-                  <a:t>Check </a:t>
-                </a:r>
-                <a:r>
-                  <a:rPr lang="de-AT" sz="1200" dirty="0" err="1"/>
-                  <a:t>convergence</a:t>
-                </a:r>
-                <a:r>
-                  <a:rPr lang="de-AT" sz="1200" dirty="0"/>
-                  <a:t> </a:t>
-                </a:r>
-                <a:r>
-                  <a:rPr lang="de-AT" sz="1200" dirty="0" err="1"/>
-                  <a:t>of</a:t>
-                </a:r>
-                <a:r>
-                  <a:rPr lang="de-AT" sz="1200" dirty="0"/>
-                  <a:t> </a:t>
-                </a:r>
-                <a:r>
-                  <a:rPr lang="de-AT" sz="1200" dirty="0" err="1"/>
-                  <a:t>thermodynamic</a:t>
-                </a:r>
-                <a:r>
-                  <a:rPr lang="de-AT" sz="1200" dirty="0"/>
-                  <a:t> </a:t>
-                </a:r>
-                <a:r>
-                  <a:rPr lang="de-AT" sz="1200" dirty="0" err="1"/>
-                  <a:t>properties</a:t>
+                  <a:t>Check convergence of thermodynamic properties – integrated values should approach a fixed value with distance from the region of interest (see Figure 4)</a:t>
                 </a:r>
                 <a:br>
                   <a:rPr lang="de-AT" sz="1200" dirty="0"/>
@@ -7121,182 +6941,14 @@
                 </a:pPr>
                 <a:r>
                   <a:rPr lang="de-AT" sz="1200" dirty="0"/>
-                  <a:t>Optional: </a:t>
-                </a:r>
-                <a:r>
-                  <a:rPr lang="de-AT" sz="1200" dirty="0" err="1"/>
-                  <a:t>edit</a:t>
-                </a:r>
-                <a:r>
-                  <a:rPr lang="de-AT" sz="1200" dirty="0"/>
-                  <a:t> </a:t>
-                </a:r>
-                <a:r>
-                  <a:rPr lang="de-AT" sz="1200" dirty="0" err="1"/>
-                  <a:t>voxel</a:t>
-                </a:r>
-                <a:r>
-                  <a:rPr lang="de-AT" sz="1200" dirty="0"/>
-                  <a:t> </a:t>
-                </a:r>
-                <a:r>
-                  <a:rPr lang="de-AT" sz="1200" dirty="0" err="1"/>
-                  <a:t>data</a:t>
+                  <a:t>Optional: edit voxel data</a:t>
                 </a:r>
                 <a:br>
                   <a:rPr lang="de-AT" sz="1000" dirty="0"/>
                 </a:br>
                 <a:r>
-                  <a:rPr lang="de-AT" sz="1000" dirty="0" err="1"/>
-                  <a:t>For</a:t>
-                </a:r>
-                <a:r>
                   <a:rPr lang="de-AT" sz="1000" dirty="0"/>
-                  <a:t> </a:t>
-                </a:r>
-                <a:r>
-                  <a:rPr lang="de-AT" sz="1000" dirty="0" err="1"/>
-                  <a:t>example</a:t>
-                </a:r>
-                <a:r>
-                  <a:rPr lang="de-AT" sz="1000" dirty="0"/>
-                  <a:t>, </a:t>
-                </a:r>
-                <a:r>
-                  <a:rPr lang="de-AT" sz="1000" dirty="0" err="1"/>
-                  <a:t>apply</a:t>
-                </a:r>
-                <a:r>
-                  <a:rPr lang="de-AT" sz="1000" dirty="0"/>
-                  <a:t> </a:t>
-                </a:r>
-                <a:r>
-                  <a:rPr lang="de-AT" sz="1000" dirty="0" err="1"/>
-                  <a:t>the</a:t>
-                </a:r>
-                <a:r>
-                  <a:rPr lang="de-AT" sz="1000" dirty="0"/>
-                  <a:t> </a:t>
-                </a:r>
-                <a:r>
-                  <a:rPr lang="de-AT" sz="1000" dirty="0" err="1"/>
-                  <a:t>fudge</a:t>
-                </a:r>
-                <a:r>
-                  <a:rPr lang="de-AT" sz="1000" dirty="0"/>
-                  <a:t> </a:t>
-                </a:r>
-                <a:r>
-                  <a:rPr lang="de-AT" sz="1000" dirty="0" err="1"/>
-                  <a:t>factor</a:t>
-                </a:r>
-                <a:r>
-                  <a:rPr lang="de-AT" sz="1000" dirty="0"/>
-                  <a:t> </a:t>
-                </a:r>
-                <a:r>
-                  <a:rPr lang="de-AT" sz="1000" dirty="0" err="1"/>
-                  <a:t>of</a:t>
-                </a:r>
-                <a:r>
-                  <a:rPr lang="de-AT" sz="1000" dirty="0"/>
-                  <a:t> 0.6 </a:t>
-                </a:r>
-                <a:r>
-                  <a:rPr lang="de-AT" sz="1000" dirty="0" err="1"/>
-                  <a:t>to</a:t>
-                </a:r>
-                <a:r>
-                  <a:rPr lang="de-AT" sz="1000" dirty="0"/>
-                  <a:t> </a:t>
-                </a:r>
-                <a:r>
-                  <a:rPr lang="de-AT" sz="1000" dirty="0" err="1"/>
-                  <a:t>the</a:t>
-                </a:r>
-                <a:r>
-                  <a:rPr lang="de-AT" sz="1000" dirty="0"/>
-                  <a:t> </a:t>
-                </a:r>
-                <a:r>
-                  <a:rPr lang="de-AT" sz="1000" dirty="0" err="1"/>
-                  <a:t>entropy</a:t>
-                </a:r>
-                <a:r>
-                  <a:rPr lang="de-AT" sz="1000" dirty="0"/>
-                  <a:t> </a:t>
-                </a:r>
-                <a:r>
-                  <a:rPr lang="de-AT" sz="1000" dirty="0" err="1"/>
-                  <a:t>column</a:t>
-                </a:r>
-                <a:r>
-                  <a:rPr lang="de-AT" sz="1000" dirty="0"/>
-                  <a:t> </a:t>
-                </a:r>
-                <a:r>
-                  <a:rPr lang="de-AT" sz="1000" dirty="0" err="1"/>
-                  <a:t>or</a:t>
-                </a:r>
-                <a:r>
-                  <a:rPr lang="de-AT" sz="1000" dirty="0"/>
-                  <a:t> </a:t>
-                </a:r>
-                <a:r>
-                  <a:rPr lang="de-AT" sz="1000" dirty="0" err="1"/>
-                  <a:t>set</a:t>
-                </a:r>
-                <a:r>
-                  <a:rPr lang="de-AT" sz="1000" dirty="0"/>
-                  <a:t> </a:t>
-                </a:r>
-                <a:r>
-                  <a:rPr lang="de-AT" sz="1000" dirty="0" err="1"/>
-                  <a:t>voxels</a:t>
-                </a:r>
-                <a:r>
-                  <a:rPr lang="de-AT" sz="1000" dirty="0"/>
-                  <a:t> </a:t>
-                </a:r>
-                <a:r>
-                  <a:rPr lang="de-AT" sz="1000" dirty="0" err="1"/>
-                  <a:t>far</a:t>
-                </a:r>
-                <a:r>
-                  <a:rPr lang="de-AT" sz="1000" dirty="0"/>
-                  <a:t> </a:t>
-                </a:r>
-                <a:r>
-                  <a:rPr lang="de-AT" sz="1000" dirty="0" err="1"/>
-                  <a:t>away</a:t>
-                </a:r>
-                <a:r>
-                  <a:rPr lang="de-AT" sz="1000" dirty="0"/>
-                  <a:t> </a:t>
-                </a:r>
-                <a:r>
-                  <a:rPr lang="de-AT" sz="1000" dirty="0" err="1"/>
-                  <a:t>from</a:t>
-                </a:r>
-                <a:r>
-                  <a:rPr lang="de-AT" sz="1000" dirty="0"/>
-                  <a:t> </a:t>
-                </a:r>
-                <a:r>
-                  <a:rPr lang="de-AT" sz="1000" dirty="0" err="1"/>
-                  <a:t>solute</a:t>
-                </a:r>
-                <a:r>
-                  <a:rPr lang="de-AT" sz="1000" dirty="0"/>
-                  <a:t> </a:t>
-                </a:r>
-                <a:r>
-                  <a:rPr lang="de-AT" sz="1000" dirty="0" err="1"/>
-                  <a:t>to</a:t>
-                </a:r>
-                <a:r>
-                  <a:rPr lang="de-AT" sz="1000" dirty="0"/>
-                  <a:t> 0.</a:t>
+                  <a:t>For example, apply the empirical entropy correction  factor of 0.6.</a:t>
                 </a:r>
                 <a:br>
                   <a:rPr lang="de-AT" sz="1000" dirty="0"/>
@@ -7331,53 +6983,8 @@
                 </a:pPr>
                 <a:r>
                   <a:rPr lang="de-AT" sz="1200" dirty="0"/>
-                  <a:t>Use „norm“ </a:t>
-                </a:r>
-                <a:r>
-                  <a:rPr lang="de-AT" sz="1200" dirty="0" err="1"/>
-                  <a:t>data</a:t>
-                </a:r>
-                <a:r>
-                  <a:rPr lang="de-AT" sz="1200" dirty="0"/>
-                  <a:t> </a:t>
-                </a:r>
-                <a:r>
-                  <a:rPr lang="de-AT" sz="1200" dirty="0" err="1"/>
-                  <a:t>to</a:t>
-                </a:r>
-                <a:r>
-                  <a:rPr lang="de-AT" sz="1200" dirty="0"/>
-                  <a:t> </a:t>
-                </a:r>
-                <a:r>
-                  <a:rPr lang="de-AT" sz="1200" dirty="0" err="1"/>
-                  <a:t>compare</a:t>
-                </a:r>
-                <a:r>
-                  <a:rPr lang="de-AT" sz="1200" dirty="0"/>
-                  <a:t> </a:t>
-                </a:r>
-                <a:r>
-                  <a:rPr lang="de-AT" sz="1200" dirty="0" err="1"/>
-                  <a:t>voxel</a:t>
-                </a:r>
-                <a:r>
-                  <a:rPr lang="de-AT" sz="1200" dirty="0"/>
-                  <a:t> </a:t>
-                </a:r>
-                <a:r>
-                  <a:rPr lang="de-AT" sz="1200" dirty="0" err="1"/>
-                  <a:t>to</a:t>
-                </a:r>
-                <a:r>
-                  <a:rPr lang="de-AT" sz="1200" dirty="0"/>
-                  <a:t> </a:t>
-                </a:r>
-                <a:r>
-                  <a:rPr lang="de-AT" sz="1200" dirty="0" err="1"/>
-                  <a:t>voxel</a:t>
-                </a:r>
-                <a:endParaRPr lang="de-AT" sz="1200" dirty="0"/>
+                  <a:t>Use “norm“ data to compare voxel to voxel</a:t>
+                </a:r>
               </a:p>
               <a:p>
                 <a:pPr marL="171450" indent="-171450">
@@ -7386,85 +6993,8 @@
                 </a:pPr>
                 <a:r>
                   <a:rPr lang="de-AT" sz="1200" dirty="0"/>
-                  <a:t>Use „</a:t>
-                </a:r>
-                <a:r>
-                  <a:rPr lang="de-AT" sz="1200" dirty="0" err="1"/>
-                  <a:t>dens</a:t>
-                </a:r>
-                <a:r>
-                  <a:rPr lang="de-AT" sz="1200" dirty="0"/>
-                  <a:t>“ </a:t>
-                </a:r>
-                <a:r>
-                  <a:rPr lang="de-AT" sz="1200" dirty="0" err="1"/>
-                  <a:t>data</a:t>
-                </a:r>
-                <a:r>
-                  <a:rPr lang="de-AT" sz="1200" dirty="0"/>
-                  <a:t> </a:t>
-                </a:r>
-                <a:r>
-                  <a:rPr lang="de-AT" sz="1200" dirty="0" err="1"/>
-                  <a:t>to</a:t>
-                </a:r>
-                <a:r>
-                  <a:rPr lang="de-AT" sz="1200" dirty="0"/>
-                  <a:t> </a:t>
-                </a:r>
-                <a:r>
-                  <a:rPr lang="de-AT" sz="1200" dirty="0" err="1"/>
-                  <a:t>integrate</a:t>
-                </a:r>
-                <a:r>
-                  <a:rPr lang="de-AT" sz="1200" dirty="0"/>
-                  <a:t> </a:t>
-                </a:r>
-                <a:r>
-                  <a:rPr lang="de-AT" sz="1200" dirty="0" err="1"/>
-                  <a:t>over</a:t>
-                </a:r>
-                <a:r>
-                  <a:rPr lang="de-AT" sz="1200" dirty="0"/>
-                  <a:t> </a:t>
-                </a:r>
-                <a:r>
-                  <a:rPr lang="de-AT" sz="1200" dirty="0" err="1"/>
-                  <a:t>voxels</a:t>
-                </a:r>
-                <a:r>
-                  <a:rPr lang="de-AT" sz="1200" dirty="0"/>
-                  <a:t> </a:t>
-                </a:r>
-                <a:r>
-                  <a:rPr lang="de-AT" sz="1200" dirty="0" err="1"/>
-                  <a:t>or</a:t>
-                </a:r>
-                <a:r>
-                  <a:rPr lang="de-AT" sz="1200" dirty="0"/>
-                  <a:t> </a:t>
-                </a:r>
-                <a:r>
-                  <a:rPr lang="de-AT" sz="1200" dirty="0" err="1"/>
-                  <a:t>for</a:t>
-                </a:r>
-                <a:r>
-                  <a:rPr lang="de-AT" sz="1200" dirty="0"/>
-                  <a:t> </a:t>
-                </a:r>
-                <a:r>
-                  <a:rPr lang="de-AT" sz="1200" dirty="0" err="1"/>
-                  <a:t>visualisation</a:t>
-                </a:r>
-                <a:r>
-                  <a:rPr lang="de-AT" sz="1200" dirty="0"/>
-                  <a:t> </a:t>
-                </a:r>
-                <a:r>
-                  <a:rPr lang="de-AT" sz="1200" dirty="0" err="1"/>
-                  <a:t>purposes</a:t>
-                </a:r>
-                <a:endParaRPr lang="de-AT" sz="1200" dirty="0"/>
+                  <a:t>Use “dens“ data to integrate over voxels or for visualisation purposes</a:t>
+                </a:r>
               </a:p>
               <a:p>
                 <a:pPr marL="171450" indent="-171450">
@@ -7479,15 +7009,7 @@
               <a:p>
                 <a:r>
                   <a:rPr lang="de-AT" sz="1200" b="1" dirty="0"/>
-                  <a:t>4b. </a:t>
-                </a:r>
-                <a:r>
-                  <a:rPr lang="de-AT" sz="1200" b="1" dirty="0" err="1"/>
-                  <a:t>Visualisation</a:t>
-                </a:r>
-                <a:r>
-                  <a:rPr lang="de-AT" sz="1200" b="1" dirty="0"/>
-                  <a:t> (optional)</a:t>
+                  <a:t>4b. Visualisation (optional)</a:t>
                 </a:r>
               </a:p>
               <a:p>
@@ -7644,7 +7166,7 @@
             </p:txBody>
           </p:sp>
         </mc:Choice>
-        <mc:Fallback xmlns="">
+        <mc:Fallback>
           <p:sp>
             <p:nvSpPr>
               <p:cNvPr id="22" name="TextBox 21">
@@ -7662,7 +7184,7 @@
             <p:spPr>
               <a:xfrm>
                 <a:off x="4656316" y="764495"/>
-                <a:ext cx="2208520" cy="7093673"/>
+                <a:ext cx="2208520" cy="7524560"/>
               </a:xfrm>
               <a:prstGeom prst="rect">
                 <a:avLst/>
@@ -7670,7 +7192,7 @@
               <a:blipFill>
                 <a:blip r:embed="rId2"/>
                 <a:stretch>
-                  <a:fillRect l="-276"/>
+                  <a:fillRect l="-276" r="-829"/>
                 </a:stretch>
               </a:blipFill>
               <a:ln>
@@ -8672,31 +8194,11 @@
                 </a14:m>
                 <a:r>
                   <a:rPr lang="de-AT" sz="800" dirty="0"/>
-                  <a:t>: </a:t>
-                </a:r>
-                <a:r>
-                  <a:rPr lang="de-AT" sz="800" dirty="0" err="1"/>
-                  <a:t>Increase</a:t>
-                </a:r>
-                <a:r>
-                  <a:rPr lang="de-AT" sz="800" dirty="0"/>
-                  <a:t> </a:t>
-                </a:r>
-                <a:r>
-                  <a:rPr lang="de-AT" sz="800" dirty="0" err="1"/>
-                  <a:t>grid</a:t>
-                </a:r>
-                <a:r>
-                  <a:rPr lang="de-AT" sz="800" dirty="0"/>
-                  <a:t> </a:t>
-                </a:r>
-                <a:r>
-                  <a:rPr lang="de-AT" sz="800" dirty="0" err="1"/>
-                  <a:t>size</a:t>
+                  <a:t>: More  </a:t>
                 </a:r>
                 <a:r>
                   <a:rPr lang="en-150" sz="800" dirty="0"/>
-                  <a:t> 	or sampling</a:t>
+                  <a:t>sampling</a:t>
                 </a:r>
                 <a:endParaRPr lang="en-US" sz="800" dirty="0"/>
               </a:p>
@@ -8738,7 +8240,7 @@
               <a:lstStyle/>
               <a:p>
                 <a:r>
-                  <a:rPr lang="de-AT">
+                  <a:rPr lang="en-US">
                     <a:noFill/>
                   </a:rPr>
                   <a:t> </a:t>
@@ -8814,11 +8316,7 @@
               <a:pPr algn="ctr"/>
               <a:r>
                 <a:rPr lang="de-AT" sz="1200" dirty="0"/>
-                <a:t>„norm“ </a:t>
-              </a:r>
-              <a:r>
-                <a:rPr lang="de-AT" sz="1200" dirty="0" err="1"/>
-                <a:t>data</a:t>
+                <a:t>“norm“ data</a:t>
               </a:r>
               <a:endParaRPr lang="en-US" sz="1200" dirty="0"/>
             </a:p>
@@ -8870,19 +8368,7 @@
               <a:pPr algn="ctr"/>
               <a:r>
                 <a:rPr lang="de-AT" sz="1200" dirty="0"/>
-                <a:t>„</a:t>
-              </a:r>
-              <a:r>
-                <a:rPr lang="de-AT" sz="1200" dirty="0" err="1"/>
-                <a:t>dens</a:t>
-              </a:r>
-              <a:r>
-                <a:rPr lang="de-AT" sz="1200" dirty="0"/>
-                <a:t>“ </a:t>
-              </a:r>
-              <a:r>
-                <a:rPr lang="de-AT" sz="1200" dirty="0" err="1"/>
-                <a:t>data</a:t>
+                <a:t>“dens“ data</a:t>
               </a:r>
               <a:endParaRPr lang="en-US" sz="1200" dirty="0"/>
             </a:p>

</xml_diff>

<commit_message>
Final changes to TK/MG/SR comments
- Change bulk/pure solvent to neat solvent in flowchart
- Export flowchart
- Delete .DS_Store and add it to gitignore
</commit_message>
<xml_diff>
--- a/manuscript/figures/flowchart_GIST.pptx
+++ b/manuscript/figures/flowchart_GIST.pptx
@@ -255,7 +255,7 @@
           <a:p>
             <a:fld id="{CE335E54-2A4B-4CD0-9488-F8D5DEC3B8E4}" type="datetimeFigureOut">
               <a:rPr lang="en-US" smtClean="0"/>
-              <a:t>6/5/2025</a:t>
+              <a:t>6/28/2025</a:t>
             </a:fld>
             <a:endParaRPr lang="en-US"/>
           </a:p>
@@ -425,7 +425,7 @@
           <a:p>
             <a:fld id="{CE335E54-2A4B-4CD0-9488-F8D5DEC3B8E4}" type="datetimeFigureOut">
               <a:rPr lang="en-US" smtClean="0"/>
-              <a:t>6/5/2025</a:t>
+              <a:t>6/28/2025</a:t>
             </a:fld>
             <a:endParaRPr lang="en-US"/>
           </a:p>
@@ -605,7 +605,7 @@
           <a:p>
             <a:fld id="{CE335E54-2A4B-4CD0-9488-F8D5DEC3B8E4}" type="datetimeFigureOut">
               <a:rPr lang="en-US" smtClean="0"/>
-              <a:t>6/5/2025</a:t>
+              <a:t>6/28/2025</a:t>
             </a:fld>
             <a:endParaRPr lang="en-US"/>
           </a:p>
@@ -775,7 +775,7 @@
           <a:p>
             <a:fld id="{CE335E54-2A4B-4CD0-9488-F8D5DEC3B8E4}" type="datetimeFigureOut">
               <a:rPr lang="en-US" smtClean="0"/>
-              <a:t>6/5/2025</a:t>
+              <a:t>6/28/2025</a:t>
             </a:fld>
             <a:endParaRPr lang="en-US"/>
           </a:p>
@@ -1021,7 +1021,7 @@
           <a:p>
             <a:fld id="{CE335E54-2A4B-4CD0-9488-F8D5DEC3B8E4}" type="datetimeFigureOut">
               <a:rPr lang="en-US" smtClean="0"/>
-              <a:t>6/5/2025</a:t>
+              <a:t>6/28/2025</a:t>
             </a:fld>
             <a:endParaRPr lang="en-US"/>
           </a:p>
@@ -1253,7 +1253,7 @@
           <a:p>
             <a:fld id="{CE335E54-2A4B-4CD0-9488-F8D5DEC3B8E4}" type="datetimeFigureOut">
               <a:rPr lang="en-US" smtClean="0"/>
-              <a:t>6/5/2025</a:t>
+              <a:t>6/28/2025</a:t>
             </a:fld>
             <a:endParaRPr lang="en-US"/>
           </a:p>
@@ -1620,7 +1620,7 @@
           <a:p>
             <a:fld id="{CE335E54-2A4B-4CD0-9488-F8D5DEC3B8E4}" type="datetimeFigureOut">
               <a:rPr lang="en-US" smtClean="0"/>
-              <a:t>6/5/2025</a:t>
+              <a:t>6/28/2025</a:t>
             </a:fld>
             <a:endParaRPr lang="en-US"/>
           </a:p>
@@ -1738,7 +1738,7 @@
           <a:p>
             <a:fld id="{CE335E54-2A4B-4CD0-9488-F8D5DEC3B8E4}" type="datetimeFigureOut">
               <a:rPr lang="en-US" smtClean="0"/>
-              <a:t>6/5/2025</a:t>
+              <a:t>6/28/2025</a:t>
             </a:fld>
             <a:endParaRPr lang="en-US"/>
           </a:p>
@@ -1833,7 +1833,7 @@
           <a:p>
             <a:fld id="{CE335E54-2A4B-4CD0-9488-F8D5DEC3B8E4}" type="datetimeFigureOut">
               <a:rPr lang="en-US" smtClean="0"/>
-              <a:t>6/5/2025</a:t>
+              <a:t>6/28/2025</a:t>
             </a:fld>
             <a:endParaRPr lang="en-US"/>
           </a:p>
@@ -2110,7 +2110,7 @@
           <a:p>
             <a:fld id="{CE335E54-2A4B-4CD0-9488-F8D5DEC3B8E4}" type="datetimeFigureOut">
               <a:rPr lang="en-US" smtClean="0"/>
-              <a:t>6/5/2025</a:t>
+              <a:t>6/28/2025</a:t>
             </a:fld>
             <a:endParaRPr lang="en-US"/>
           </a:p>
@@ -2367,7 +2367,7 @@
           <a:p>
             <a:fld id="{CE335E54-2A4B-4CD0-9488-F8D5DEC3B8E4}" type="datetimeFigureOut">
               <a:rPr lang="en-US" smtClean="0"/>
-              <a:t>6/5/2025</a:t>
+              <a:t>6/28/2025</a:t>
             </a:fld>
             <a:endParaRPr lang="en-US"/>
           </a:p>
@@ -2580,7 +2580,7 @@
           <a:p>
             <a:fld id="{CE335E54-2A4B-4CD0-9488-F8D5DEC3B8E4}" type="datetimeFigureOut">
               <a:rPr lang="en-US" smtClean="0"/>
-              <a:t>6/5/2025</a:t>
+              <a:t>6/28/2025</a:t>
             </a:fld>
             <a:endParaRPr lang="en-US"/>
           </a:p>
@@ -3158,7 +3158,7 @@
             <a:pPr algn="ctr"/>
             <a:r>
               <a:rPr lang="de-AT" sz="1000" dirty="0"/>
-              <a:t>Pure solvent box </a:t>
+              <a:t>Neat solvent box </a:t>
             </a:r>
             <a:r>
               <a:rPr lang="de-AT" sz="1000" dirty="0" err="1"/>
@@ -3750,8 +3750,20 @@
                   <a:rPr lang="de-AT" sz="1200" b="1" dirty="0"/>
                 </a:br>
                 <a:r>
+                  <a:rPr lang="de-AT" sz="1000" dirty="0" err="1"/>
+                  <a:t>Calculate</a:t>
+                </a:r>
+                <a:r>
                   <a:rPr lang="de-AT" sz="1000" dirty="0"/>
-                  <a:t>Calculate from reference from neat simulation or use tabulated value for the solvent model.</a:t>
+                  <a:t> </a:t>
+                </a:r>
+                <a:r>
+                  <a:rPr lang="de-AT" sz="1000" dirty="0" err="1"/>
+                  <a:t>reference</a:t>
+                </a:r>
+                <a:r>
+                  <a:rPr lang="de-AT" sz="1000" dirty="0"/>
+                  <a:t> from neat simulation or use tabulated value for the solvent model.</a:t>
                 </a:r>
               </a:p>
               <a:p>
@@ -4161,8 +4173,8 @@
           </a:p>
         </p:txBody>
       </p:sp>
-      <mc:AlternateContent xmlns:mc="http://schemas.openxmlformats.org/markup-compatibility/2006" xmlns:a14="http://schemas.microsoft.com/office/drawing/2010/main">
-        <mc:Choice Requires="a14">
+      <mc:AlternateContent xmlns:mc="http://schemas.openxmlformats.org/markup-compatibility/2006">
+        <mc:Choice xmlns:a14="http://schemas.microsoft.com/office/drawing/2010/main" Requires="a14">
           <p:sp>
             <p:nvSpPr>
               <p:cNvPr id="24" name="Rectangle: Rounded Corners 23">
@@ -4269,7 +4281,7 @@
                 </a:r>
                 <a:r>
                   <a:rPr lang="de-AT" sz="1000" dirty="0" err="1"/>
-                  <a:t>bulk</a:t>
+                  <a:t>neat</a:t>
                 </a:r>
                 <a:r>
                   <a:rPr lang="de-AT" sz="1000" dirty="0"/>
@@ -4280,7 +4292,7 @@
             </p:txBody>
           </p:sp>
         </mc:Choice>
-        <mc:Fallback xmlns="">
+        <mc:Fallback>
           <p:sp>
             <p:nvSpPr>
               <p:cNvPr id="24" name="Rectangle: Rounded Corners 23">
@@ -4959,12 +4971,8 @@
           <a:p>
             <a:pPr algn="ctr"/>
             <a:r>
-              <a:rPr lang="de-AT" sz="1200" dirty="0" err="1"/>
-              <a:t>Bulk</a:t>
-            </a:r>
-            <a:r>
               <a:rPr lang="de-AT" sz="1200" dirty="0"/>
-              <a:t> Solvent </a:t>
+              <a:t>Neat Solvent </a:t>
             </a:r>
             <a:r>
               <a:rPr lang="de-AT" sz="1200" dirty="0" err="1"/>
@@ -6502,8 +6510,8 @@
           <a:chExt cx="0" cy="0"/>
         </a:xfrm>
       </p:grpSpPr>
-      <mc:AlternateContent xmlns:mc="http://schemas.openxmlformats.org/markup-compatibility/2006">
-        <mc:Choice xmlns:a14="http://schemas.microsoft.com/office/drawing/2010/main" Requires="a14">
+      <mc:AlternateContent xmlns:mc="http://schemas.openxmlformats.org/markup-compatibility/2006" xmlns:a14="http://schemas.microsoft.com/office/drawing/2010/main">
+        <mc:Choice Requires="a14">
           <p:sp>
             <p:nvSpPr>
               <p:cNvPr id="22" name="TextBox 21">
@@ -7166,7 +7174,7 @@
             </p:txBody>
           </p:sp>
         </mc:Choice>
-        <mc:Fallback>
+        <mc:Fallback xmlns="">
           <p:sp>
             <p:nvSpPr>
               <p:cNvPr id="22" name="TextBox 21">
@@ -7937,8 +7945,8 @@
           </a:fontRef>
         </p:style>
       </p:cxnSp>
-      <mc:AlternateContent xmlns:mc="http://schemas.openxmlformats.org/markup-compatibility/2006">
-        <mc:Choice xmlns:a14="http://schemas.microsoft.com/office/drawing/2010/main" Requires="a14">
+      <mc:AlternateContent xmlns:mc="http://schemas.openxmlformats.org/markup-compatibility/2006" xmlns:a14="http://schemas.microsoft.com/office/drawing/2010/main">
+        <mc:Choice Requires="a14">
           <p:sp>
             <p:nvSpPr>
               <p:cNvPr id="17" name="Rectangle: Rounded Corners 16">
@@ -8205,7 +8213,7 @@
             </p:txBody>
           </p:sp>
         </mc:Choice>
-        <mc:Fallback>
+        <mc:Fallback xmlns="">
           <p:sp>
             <p:nvSpPr>
               <p:cNvPr id="17" name="Rectangle: Rounded Corners 16">

</xml_diff>

<commit_message>
Editiorial Comments and Affilliations
Corrects spelling in flowchart,
adresses editorial comments (typos),
fixes affiliations
</commit_message>
<xml_diff>
--- a/manuscript/figures/flowchart_GIST.pptx
+++ b/manuscript/figures/flowchart_GIST.pptx
@@ -255,9 +255,9 @@
           <a:p>
             <a:fld id="{CE335E54-2A4B-4CD0-9488-F8D5DEC3B8E4}" type="datetimeFigureOut">
               <a:rPr lang="en-US" smtClean="0"/>
-              <a:t>6/28/2025</a:t>
+              <a:t>7/16/2025</a:t>
             </a:fld>
-            <a:endParaRPr lang="en-US"/>
+            <a:endParaRPr lang="en-US" dirty="0"/>
           </a:p>
         </p:txBody>
       </p:sp>
@@ -276,7 +276,7 @@
           <a:bodyPr/>
           <a:lstStyle/>
           <a:p>
-            <a:endParaRPr lang="en-US"/>
+            <a:endParaRPr lang="en-US" dirty="0"/>
           </a:p>
         </p:txBody>
       </p:sp>
@@ -299,7 +299,7 @@
               <a:rPr lang="en-US" smtClean="0"/>
               <a:t>‹#›</a:t>
             </a:fld>
-            <a:endParaRPr lang="en-US"/>
+            <a:endParaRPr lang="en-US" dirty="0"/>
           </a:p>
         </p:txBody>
       </p:sp>
@@ -425,9 +425,9 @@
           <a:p>
             <a:fld id="{CE335E54-2A4B-4CD0-9488-F8D5DEC3B8E4}" type="datetimeFigureOut">
               <a:rPr lang="en-US" smtClean="0"/>
-              <a:t>6/28/2025</a:t>
+              <a:t>7/16/2025</a:t>
             </a:fld>
-            <a:endParaRPr lang="en-US"/>
+            <a:endParaRPr lang="en-US" dirty="0"/>
           </a:p>
         </p:txBody>
       </p:sp>
@@ -446,7 +446,7 @@
           <a:bodyPr/>
           <a:lstStyle/>
           <a:p>
-            <a:endParaRPr lang="en-US"/>
+            <a:endParaRPr lang="en-US" dirty="0"/>
           </a:p>
         </p:txBody>
       </p:sp>
@@ -469,7 +469,7 @@
               <a:rPr lang="en-US" smtClean="0"/>
               <a:t>‹#›</a:t>
             </a:fld>
-            <a:endParaRPr lang="en-US"/>
+            <a:endParaRPr lang="en-US" dirty="0"/>
           </a:p>
         </p:txBody>
       </p:sp>
@@ -605,9 +605,9 @@
           <a:p>
             <a:fld id="{CE335E54-2A4B-4CD0-9488-F8D5DEC3B8E4}" type="datetimeFigureOut">
               <a:rPr lang="en-US" smtClean="0"/>
-              <a:t>6/28/2025</a:t>
+              <a:t>7/16/2025</a:t>
             </a:fld>
-            <a:endParaRPr lang="en-US"/>
+            <a:endParaRPr lang="en-US" dirty="0"/>
           </a:p>
         </p:txBody>
       </p:sp>
@@ -626,7 +626,7 @@
           <a:bodyPr/>
           <a:lstStyle/>
           <a:p>
-            <a:endParaRPr lang="en-US"/>
+            <a:endParaRPr lang="en-US" dirty="0"/>
           </a:p>
         </p:txBody>
       </p:sp>
@@ -649,7 +649,7 @@
               <a:rPr lang="en-US" smtClean="0"/>
               <a:t>‹#›</a:t>
             </a:fld>
-            <a:endParaRPr lang="en-US"/>
+            <a:endParaRPr lang="en-US" dirty="0"/>
           </a:p>
         </p:txBody>
       </p:sp>
@@ -775,9 +775,9 @@
           <a:p>
             <a:fld id="{CE335E54-2A4B-4CD0-9488-F8D5DEC3B8E4}" type="datetimeFigureOut">
               <a:rPr lang="en-US" smtClean="0"/>
-              <a:t>6/28/2025</a:t>
+              <a:t>7/16/2025</a:t>
             </a:fld>
-            <a:endParaRPr lang="en-US"/>
+            <a:endParaRPr lang="en-US" dirty="0"/>
           </a:p>
         </p:txBody>
       </p:sp>
@@ -796,7 +796,7 @@
           <a:bodyPr/>
           <a:lstStyle/>
           <a:p>
-            <a:endParaRPr lang="en-US"/>
+            <a:endParaRPr lang="en-US" dirty="0"/>
           </a:p>
         </p:txBody>
       </p:sp>
@@ -819,7 +819,7 @@
               <a:rPr lang="en-US" smtClean="0"/>
               <a:t>‹#›</a:t>
             </a:fld>
-            <a:endParaRPr lang="en-US"/>
+            <a:endParaRPr lang="en-US" dirty="0"/>
           </a:p>
         </p:txBody>
       </p:sp>
@@ -1021,9 +1021,9 @@
           <a:p>
             <a:fld id="{CE335E54-2A4B-4CD0-9488-F8D5DEC3B8E4}" type="datetimeFigureOut">
               <a:rPr lang="en-US" smtClean="0"/>
-              <a:t>6/28/2025</a:t>
+              <a:t>7/16/2025</a:t>
             </a:fld>
-            <a:endParaRPr lang="en-US"/>
+            <a:endParaRPr lang="en-US" dirty="0"/>
           </a:p>
         </p:txBody>
       </p:sp>
@@ -1042,7 +1042,7 @@
           <a:bodyPr/>
           <a:lstStyle/>
           <a:p>
-            <a:endParaRPr lang="en-US"/>
+            <a:endParaRPr lang="en-US" dirty="0"/>
           </a:p>
         </p:txBody>
       </p:sp>
@@ -1065,7 +1065,7 @@
               <a:rPr lang="en-US" smtClean="0"/>
               <a:t>‹#›</a:t>
             </a:fld>
-            <a:endParaRPr lang="en-US"/>
+            <a:endParaRPr lang="en-US" dirty="0"/>
           </a:p>
         </p:txBody>
       </p:sp>
@@ -1253,9 +1253,9 @@
           <a:p>
             <a:fld id="{CE335E54-2A4B-4CD0-9488-F8D5DEC3B8E4}" type="datetimeFigureOut">
               <a:rPr lang="en-US" smtClean="0"/>
-              <a:t>6/28/2025</a:t>
+              <a:t>7/16/2025</a:t>
             </a:fld>
-            <a:endParaRPr lang="en-US"/>
+            <a:endParaRPr lang="en-US" dirty="0"/>
           </a:p>
         </p:txBody>
       </p:sp>
@@ -1274,7 +1274,7 @@
           <a:bodyPr/>
           <a:lstStyle/>
           <a:p>
-            <a:endParaRPr lang="en-US"/>
+            <a:endParaRPr lang="en-US" dirty="0"/>
           </a:p>
         </p:txBody>
       </p:sp>
@@ -1297,7 +1297,7 @@
               <a:rPr lang="en-US" smtClean="0"/>
               <a:t>‹#›</a:t>
             </a:fld>
-            <a:endParaRPr lang="en-US"/>
+            <a:endParaRPr lang="en-US" dirty="0"/>
           </a:p>
         </p:txBody>
       </p:sp>
@@ -1620,9 +1620,9 @@
           <a:p>
             <a:fld id="{CE335E54-2A4B-4CD0-9488-F8D5DEC3B8E4}" type="datetimeFigureOut">
               <a:rPr lang="en-US" smtClean="0"/>
-              <a:t>6/28/2025</a:t>
+              <a:t>7/16/2025</a:t>
             </a:fld>
-            <a:endParaRPr lang="en-US"/>
+            <a:endParaRPr lang="en-US" dirty="0"/>
           </a:p>
         </p:txBody>
       </p:sp>
@@ -1641,7 +1641,7 @@
           <a:bodyPr/>
           <a:lstStyle/>
           <a:p>
-            <a:endParaRPr lang="en-US"/>
+            <a:endParaRPr lang="en-US" dirty="0"/>
           </a:p>
         </p:txBody>
       </p:sp>
@@ -1664,7 +1664,7 @@
               <a:rPr lang="en-US" smtClean="0"/>
               <a:t>‹#›</a:t>
             </a:fld>
-            <a:endParaRPr lang="en-US"/>
+            <a:endParaRPr lang="en-US" dirty="0"/>
           </a:p>
         </p:txBody>
       </p:sp>
@@ -1738,9 +1738,9 @@
           <a:p>
             <a:fld id="{CE335E54-2A4B-4CD0-9488-F8D5DEC3B8E4}" type="datetimeFigureOut">
               <a:rPr lang="en-US" smtClean="0"/>
-              <a:t>6/28/2025</a:t>
+              <a:t>7/16/2025</a:t>
             </a:fld>
-            <a:endParaRPr lang="en-US"/>
+            <a:endParaRPr lang="en-US" dirty="0"/>
           </a:p>
         </p:txBody>
       </p:sp>
@@ -1759,7 +1759,7 @@
           <a:bodyPr/>
           <a:lstStyle/>
           <a:p>
-            <a:endParaRPr lang="en-US"/>
+            <a:endParaRPr lang="en-US" dirty="0"/>
           </a:p>
         </p:txBody>
       </p:sp>
@@ -1782,7 +1782,7 @@
               <a:rPr lang="en-US" smtClean="0"/>
               <a:t>‹#›</a:t>
             </a:fld>
-            <a:endParaRPr lang="en-US"/>
+            <a:endParaRPr lang="en-US" dirty="0"/>
           </a:p>
         </p:txBody>
       </p:sp>
@@ -1833,9 +1833,9 @@
           <a:p>
             <a:fld id="{CE335E54-2A4B-4CD0-9488-F8D5DEC3B8E4}" type="datetimeFigureOut">
               <a:rPr lang="en-US" smtClean="0"/>
-              <a:t>6/28/2025</a:t>
+              <a:t>7/16/2025</a:t>
             </a:fld>
-            <a:endParaRPr lang="en-US"/>
+            <a:endParaRPr lang="en-US" dirty="0"/>
           </a:p>
         </p:txBody>
       </p:sp>
@@ -1854,7 +1854,7 @@
           <a:bodyPr/>
           <a:lstStyle/>
           <a:p>
-            <a:endParaRPr lang="en-US"/>
+            <a:endParaRPr lang="en-US" dirty="0"/>
           </a:p>
         </p:txBody>
       </p:sp>
@@ -1877,7 +1877,7 @@
               <a:rPr lang="en-US" smtClean="0"/>
               <a:t>‹#›</a:t>
             </a:fld>
-            <a:endParaRPr lang="en-US"/>
+            <a:endParaRPr lang="en-US" dirty="0"/>
           </a:p>
         </p:txBody>
       </p:sp>
@@ -2110,9 +2110,9 @@
           <a:p>
             <a:fld id="{CE335E54-2A4B-4CD0-9488-F8D5DEC3B8E4}" type="datetimeFigureOut">
               <a:rPr lang="en-US" smtClean="0"/>
-              <a:t>6/28/2025</a:t>
+              <a:t>7/16/2025</a:t>
             </a:fld>
-            <a:endParaRPr lang="en-US"/>
+            <a:endParaRPr lang="en-US" dirty="0"/>
           </a:p>
         </p:txBody>
       </p:sp>
@@ -2131,7 +2131,7 @@
           <a:bodyPr/>
           <a:lstStyle/>
           <a:p>
-            <a:endParaRPr lang="en-US"/>
+            <a:endParaRPr lang="en-US" dirty="0"/>
           </a:p>
         </p:txBody>
       </p:sp>
@@ -2154,7 +2154,7 @@
               <a:rPr lang="en-US" smtClean="0"/>
               <a:t>‹#›</a:t>
             </a:fld>
-            <a:endParaRPr lang="en-US"/>
+            <a:endParaRPr lang="en-US" dirty="0"/>
           </a:p>
         </p:txBody>
       </p:sp>
@@ -2278,10 +2278,9 @@
           </a:lstStyle>
           <a:p>
             <a:r>
-              <a:rPr lang="en-US"/>
+              <a:rPr lang="en-US" dirty="0"/>
               <a:t>Click icon to add picture</a:t>
             </a:r>
-            <a:endParaRPr lang="en-US" dirty="0"/>
           </a:p>
         </p:txBody>
       </p:sp>
@@ -2367,9 +2366,9 @@
           <a:p>
             <a:fld id="{CE335E54-2A4B-4CD0-9488-F8D5DEC3B8E4}" type="datetimeFigureOut">
               <a:rPr lang="en-US" smtClean="0"/>
-              <a:t>6/28/2025</a:t>
+              <a:t>7/16/2025</a:t>
             </a:fld>
-            <a:endParaRPr lang="en-US"/>
+            <a:endParaRPr lang="en-US" dirty="0"/>
           </a:p>
         </p:txBody>
       </p:sp>
@@ -2388,7 +2387,7 @@
           <a:bodyPr/>
           <a:lstStyle/>
           <a:p>
-            <a:endParaRPr lang="en-US"/>
+            <a:endParaRPr lang="en-US" dirty="0"/>
           </a:p>
         </p:txBody>
       </p:sp>
@@ -2411,7 +2410,7 @@
               <a:rPr lang="en-US" smtClean="0"/>
               <a:t>‹#›</a:t>
             </a:fld>
-            <a:endParaRPr lang="en-US"/>
+            <a:endParaRPr lang="en-US" dirty="0"/>
           </a:p>
         </p:txBody>
       </p:sp>
@@ -2580,9 +2579,9 @@
           <a:p>
             <a:fld id="{CE335E54-2A4B-4CD0-9488-F8D5DEC3B8E4}" type="datetimeFigureOut">
               <a:rPr lang="en-US" smtClean="0"/>
-              <a:t>6/28/2025</a:t>
+              <a:t>7/16/2025</a:t>
             </a:fld>
-            <a:endParaRPr lang="en-US"/>
+            <a:endParaRPr lang="en-US" dirty="0"/>
           </a:p>
         </p:txBody>
       </p:sp>
@@ -2619,7 +2618,7 @@
             </a:lvl1pPr>
           </a:lstStyle>
           <a:p>
-            <a:endParaRPr lang="en-US"/>
+            <a:endParaRPr lang="en-US" dirty="0"/>
           </a:p>
         </p:txBody>
       </p:sp>
@@ -2660,7 +2659,7 @@
               <a:rPr lang="en-US" smtClean="0"/>
               <a:t>‹#›</a:t>
             </a:fld>
-            <a:endParaRPr lang="en-US"/>
+            <a:endParaRPr lang="en-US" dirty="0"/>
           </a:p>
         </p:txBody>
       </p:sp>
@@ -3026,30 +3025,9 @@
           <a:p>
             <a:pPr algn="ctr"/>
             <a:r>
-              <a:rPr lang="de-AT" sz="1000" dirty="0" err="1"/>
-              <a:t>Prepare</a:t>
-            </a:r>
-            <a:r>
-              <a:rPr lang="de-AT" sz="1000" dirty="0"/>
-              <a:t> </a:t>
-            </a:r>
-            <a:r>
-              <a:rPr lang="de-AT" sz="1000" dirty="0" err="1"/>
-              <a:t>solvated</a:t>
-            </a:r>
-            <a:r>
-              <a:rPr lang="de-AT" sz="1000" dirty="0"/>
-              <a:t> </a:t>
-            </a:r>
-            <a:r>
-              <a:rPr lang="de-AT" sz="1000" dirty="0" err="1"/>
-              <a:t>solute</a:t>
-            </a:r>
-            <a:r>
-              <a:rPr lang="de-AT" sz="1000" dirty="0"/>
-              <a:t> box</a:t>
-            </a:r>
-            <a:endParaRPr lang="en-US" sz="1000" dirty="0"/>
+              <a:rPr lang="en-US" sz="1000" noProof="0" dirty="0"/>
+              <a:t>Prepare solvated solute box</a:t>
+            </a:r>
           </a:p>
         </p:txBody>
       </p:sp>
@@ -3094,22 +3072,9 @@
           <a:p>
             <a:pPr algn="ctr"/>
             <a:r>
-              <a:rPr lang="de-AT" sz="1000" dirty="0"/>
-              <a:t>Run </a:t>
-            </a:r>
-            <a:r>
-              <a:rPr lang="de-AT" sz="1000" dirty="0" err="1"/>
-              <a:t>restrained</a:t>
-            </a:r>
-            <a:r>
-              <a:rPr lang="de-AT" sz="1000" dirty="0"/>
-              <a:t> MD </a:t>
-            </a:r>
-            <a:r>
-              <a:rPr lang="de-AT" sz="1000" dirty="0" err="1"/>
-              <a:t>simulation</a:t>
-            </a:r>
-            <a:endParaRPr lang="en-US" sz="1000" dirty="0"/>
+              <a:rPr lang="en-US" sz="1000" noProof="0" dirty="0"/>
+              <a:t>Run restrained MD simulation</a:t>
+            </a:r>
           </a:p>
         </p:txBody>
       </p:sp>
@@ -3157,30 +3122,9 @@
           <a:p>
             <a:pPr algn="ctr"/>
             <a:r>
-              <a:rPr lang="de-AT" sz="1000" dirty="0"/>
-              <a:t>Neat solvent box </a:t>
-            </a:r>
-            <a:r>
-              <a:rPr lang="de-AT" sz="1000" dirty="0" err="1"/>
-              <a:t>for</a:t>
-            </a:r>
-            <a:r>
-              <a:rPr lang="de-AT" sz="1000" dirty="0"/>
-              <a:t> </a:t>
-            </a:r>
-            <a:r>
-              <a:rPr lang="de-AT" sz="1000" dirty="0" err="1"/>
-              <a:t>accurate</a:t>
-            </a:r>
-            <a:r>
-              <a:rPr lang="de-AT" sz="1000" dirty="0"/>
-              <a:t> </a:t>
-            </a:r>
-            <a:r>
-              <a:rPr lang="de-AT" sz="1000" dirty="0" err="1"/>
-              <a:t>referencing</a:t>
-            </a:r>
-            <a:endParaRPr lang="en-US" sz="1000" dirty="0"/>
+              <a:rPr lang="en-US" sz="1000" noProof="0" dirty="0"/>
+              <a:t>Neat solvent box for accurate referencing</a:t>
+            </a:r>
           </a:p>
         </p:txBody>
       </p:sp>
@@ -3228,22 +3172,9 @@
           <a:p>
             <a:pPr algn="ctr"/>
             <a:r>
-              <a:rPr lang="de-AT" sz="1000" dirty="0"/>
-              <a:t>Run </a:t>
-            </a:r>
-            <a:r>
-              <a:rPr lang="de-AT" sz="1000" dirty="0" err="1"/>
-              <a:t>unrestrained</a:t>
-            </a:r>
-            <a:r>
-              <a:rPr lang="de-AT" sz="1000" dirty="0"/>
-              <a:t> MD </a:t>
-            </a:r>
-            <a:r>
-              <a:rPr lang="de-AT" sz="1000" dirty="0" err="1"/>
-              <a:t>simulation</a:t>
-            </a:r>
-            <a:endParaRPr lang="en-US" sz="1000" dirty="0"/>
+              <a:rPr lang="en-US" sz="1000" noProof="0" dirty="0"/>
+              <a:t>Run unrestrained MD simulation</a:t>
+            </a:r>
           </a:p>
         </p:txBody>
       </p:sp>
@@ -3294,10 +3225,10 @@
               <a:lstStyle/>
               <a:p>
                 <a:r>
-                  <a:rPr lang="de-AT" sz="1200" b="1" dirty="0"/>
+                  <a:rPr lang="en-US" sz="1200" b="1" noProof="0" dirty="0"/>
                   <a:t>1. MD Simulation</a:t>
                 </a:r>
-                <a:endParaRPr lang="de-AT" sz="1200" dirty="0"/>
+                <a:endParaRPr lang="en-US" sz="1200" noProof="0" dirty="0"/>
               </a:p>
               <a:p>
                 <a:pPr marL="171450" indent="-171450">
@@ -3305,137 +3236,8 @@
                   <a:buChar char="q"/>
                 </a:pPr>
                 <a:r>
-                  <a:rPr lang="de-AT" sz="1200" dirty="0"/>
-                  <a:t>Add </a:t>
-                </a:r>
-                <a:r>
-                  <a:rPr lang="de-AT" sz="1200" dirty="0" err="1"/>
-                  <a:t>missing</a:t>
-                </a:r>
-                <a:r>
-                  <a:rPr lang="de-AT" sz="1200" dirty="0"/>
-                  <a:t> </a:t>
-                </a:r>
-                <a:r>
-                  <a:rPr lang="de-AT" sz="1200" dirty="0" err="1"/>
-                  <a:t>atoms</a:t>
-                </a:r>
-                <a:endParaRPr lang="de-AT" sz="1200" dirty="0"/>
-              </a:p>
-              <a:p>
-                <a:pPr marL="171450" indent="-171450">
-                  <a:buFont typeface="Wingdings" panose="05000000000000000000" pitchFamily="2" charset="2"/>
-                  <a:buChar char="q"/>
-                </a:pPr>
-                <a:r>
-                  <a:rPr lang="de-AT" sz="1200" dirty="0"/>
-                  <a:t>Check </a:t>
-                </a:r>
-                <a:r>
-                  <a:rPr lang="de-AT" sz="1200" dirty="0" err="1"/>
-                  <a:t>protonation</a:t>
-                </a:r>
-                <a:r>
-                  <a:rPr lang="de-AT" sz="1200" dirty="0"/>
-                  <a:t> </a:t>
-                </a:r>
-                <a:r>
-                  <a:rPr lang="de-AT" sz="1200" dirty="0" err="1"/>
-                  <a:t>states</a:t>
-                </a:r>
-                <a:endParaRPr lang="de-AT" sz="1200" dirty="0"/>
-              </a:p>
-              <a:p>
-                <a:br>
-                  <a:rPr lang="de-AT" sz="1200" dirty="0"/>
-                </a:br>
-                <a:endParaRPr lang="de-AT" sz="1200" dirty="0"/>
-              </a:p>
-              <a:p>
-                <a:pPr marL="171450" indent="-171450">
-                  <a:buFont typeface="Wingdings" panose="05000000000000000000" pitchFamily="2" charset="2"/>
-                  <a:buChar char="q"/>
-                </a:pPr>
-                <a:r>
-                  <a:rPr lang="de-AT" sz="1200" dirty="0"/>
-                  <a:t>Select </a:t>
-                </a:r>
-                <a:r>
-                  <a:rPr lang="de-AT" sz="1200" dirty="0" err="1"/>
-                  <a:t>force</a:t>
-                </a:r>
-                <a:r>
-                  <a:rPr lang="de-AT" sz="1200" dirty="0"/>
-                  <a:t> </a:t>
-                </a:r>
-                <a:r>
-                  <a:rPr lang="de-AT" sz="1200" dirty="0" err="1"/>
-                  <a:t>field</a:t>
-                </a:r>
-                <a:endParaRPr lang="de-AT" sz="1200" dirty="0"/>
-              </a:p>
-              <a:p>
-                <a:pPr marL="171450" indent="-171450">
-                  <a:buFont typeface="Wingdings" panose="05000000000000000000" pitchFamily="2" charset="2"/>
-                  <a:buChar char="q"/>
-                </a:pPr>
-                <a:r>
-                  <a:rPr lang="de-AT" sz="1200" dirty="0"/>
-                  <a:t>Add solvent </a:t>
-                </a:r>
-                <a:br>
-                  <a:rPr lang="de-AT" sz="1200" dirty="0"/>
-                </a:br>
-                <a:r>
-                  <a:rPr lang="de-AT" sz="1000" dirty="0"/>
-                  <a:t>At least 10-15Å </a:t>
-                </a:r>
-                <a:r>
-                  <a:rPr lang="de-AT" sz="1000" dirty="0" err="1"/>
-                  <a:t>buffer</a:t>
-                </a:r>
-                <a:r>
-                  <a:rPr lang="de-AT" sz="1000" dirty="0"/>
-                  <a:t> </a:t>
-                </a:r>
-                <a:r>
-                  <a:rPr lang="de-AT" sz="1000" dirty="0" err="1"/>
-                  <a:t>or</a:t>
-                </a:r>
-                <a:r>
-                  <a:rPr lang="de-AT" sz="1000" dirty="0"/>
-                  <a:t> </a:t>
-                </a:r>
-                <a:br>
-                  <a:rPr lang="de-AT" sz="1000" dirty="0"/>
-                </a:br>
-                <a:r>
-                  <a:rPr lang="de-AT" sz="1000" dirty="0"/>
-                  <a:t>3 </a:t>
-                </a:r>
-                <a:r>
-                  <a:rPr lang="de-AT" sz="1000" dirty="0" err="1"/>
-                  <a:t>solvation</a:t>
-                </a:r>
-                <a:r>
-                  <a:rPr lang="de-AT" sz="1000" dirty="0"/>
-                  <a:t> </a:t>
-                </a:r>
-                <a:r>
-                  <a:rPr lang="de-AT" sz="1000" dirty="0" err="1"/>
-                  <a:t>layers</a:t>
-                </a:r>
-                <a:r>
-                  <a:rPr lang="de-AT" sz="1000" dirty="0"/>
-                  <a:t> </a:t>
-                </a:r>
-                <a:r>
-                  <a:rPr lang="de-AT" sz="1000" dirty="0" err="1"/>
-                  <a:t>depending</a:t>
-                </a:r>
-                <a:r>
-                  <a:rPr lang="de-AT" sz="1000" dirty="0"/>
-                  <a:t> on solvent</a:t>
+                  <a:rPr lang="en-US" sz="1200" noProof="0" dirty="0"/>
+                  <a:t>Add missing atoms</a:t>
                 </a:r>
               </a:p>
               <a:p>
@@ -3444,15 +3246,15 @@
                   <a:buChar char="q"/>
                 </a:pPr>
                 <a:r>
-                  <a:rPr lang="de-AT" sz="1200" dirty="0"/>
-                  <a:t>Optional: create neat solvent box and determine NN entropy bias</a:t>
+                  <a:rPr lang="en-US" sz="1200" noProof="0" dirty="0"/>
+                  <a:t>Check protonation states</a:t>
                 </a:r>
               </a:p>
               <a:p>
                 <a:br>
-                  <a:rPr lang="de-AT" sz="1200" dirty="0"/>
+                  <a:rPr lang="en-US" sz="1200" noProof="0" dirty="0"/>
                 </a:br>
-                <a:endParaRPr lang="de-AT" sz="1200" dirty="0"/>
+                <a:endParaRPr lang="en-US" sz="1200" noProof="0" dirty="0"/>
               </a:p>
               <a:p>
                 <a:pPr marL="171450" indent="-171450">
@@ -3460,50 +3262,64 @@
                   <a:buChar char="q"/>
                 </a:pPr>
                 <a:r>
-                  <a:rPr lang="de-AT" sz="1200" dirty="0" err="1"/>
-                  <a:t>Restrain</a:t>
+                  <a:rPr lang="en-US" sz="1200" noProof="0" dirty="0"/>
+                  <a:t>Select force field</a:t>
                 </a:r>
+              </a:p>
+              <a:p>
+                <a:pPr marL="171450" indent="-171450">
+                  <a:buFont typeface="Wingdings" panose="05000000000000000000" pitchFamily="2" charset="2"/>
+                  <a:buChar char="q"/>
+                </a:pPr>
                 <a:r>
-                  <a:rPr lang="de-AT" sz="1200" dirty="0"/>
-                  <a:t> heavy </a:t>
-                </a:r>
-                <a:r>
-                  <a:rPr lang="de-AT" sz="1200" dirty="0" err="1"/>
-                  <a:t>atoms</a:t>
-                </a:r>
-                <a:r>
-                  <a:rPr lang="de-AT" sz="1200" dirty="0"/>
-                  <a:t> </a:t>
-                </a:r>
-                <a:r>
-                  <a:rPr lang="de-AT" sz="1200" dirty="0" err="1"/>
-                  <a:t>for</a:t>
-                </a:r>
-                <a:r>
-                  <a:rPr lang="de-AT" sz="1200" dirty="0"/>
-                  <a:t> </a:t>
-                </a:r>
-                <a:r>
-                  <a:rPr lang="de-AT" sz="1200" dirty="0" err="1"/>
-                  <a:t>solute</a:t>
-                </a:r>
-                <a:r>
-                  <a:rPr lang="de-AT" sz="1200" dirty="0"/>
-                  <a:t> </a:t>
-                </a:r>
-                <a:r>
-                  <a:rPr lang="de-AT" sz="1200" dirty="0" err="1"/>
-                  <a:t>simulation</a:t>
-                </a:r>
-                <a:r>
-                  <a:rPr lang="de-AT" sz="1200" dirty="0"/>
-                  <a:t> </a:t>
+                  <a:rPr lang="en-US" sz="1200" noProof="0" dirty="0"/>
+                  <a:t>Add solvent </a:t>
                 </a:r>
                 <a:br>
-                  <a:rPr lang="de-AT" sz="1200" dirty="0"/>
+                  <a:rPr lang="en-US" sz="1200" noProof="0" dirty="0"/>
                 </a:br>
                 <a:r>
-                  <a:rPr lang="en-US" sz="1000" dirty="0"/>
+                  <a:rPr lang="en-US" sz="1000" noProof="0" dirty="0"/>
+                  <a:t>At least 10-15Å buffer or </a:t>
+                </a:r>
+                <a:br>
+                  <a:rPr lang="en-US" sz="1000" noProof="0" dirty="0"/>
+                </a:br>
+                <a:r>
+                  <a:rPr lang="en-US" sz="1000" noProof="0" dirty="0"/>
+                  <a:t>3 solvation layers depending on solvent</a:t>
+                </a:r>
+              </a:p>
+              <a:p>
+                <a:pPr marL="171450" indent="-171450">
+                  <a:buFont typeface="Wingdings" panose="05000000000000000000" pitchFamily="2" charset="2"/>
+                  <a:buChar char="q"/>
+                </a:pPr>
+                <a:r>
+                  <a:rPr lang="en-US" sz="1200" noProof="0" dirty="0"/>
+                  <a:t>Optional: create neat solvent box and determine NN entropy bias</a:t>
+                </a:r>
+              </a:p>
+              <a:p>
+                <a:br>
+                  <a:rPr lang="en-US" sz="1200" noProof="0" dirty="0"/>
+                </a:br>
+                <a:endParaRPr lang="en-US" sz="1200" noProof="0" dirty="0"/>
+              </a:p>
+              <a:p>
+                <a:pPr marL="171450" indent="-171450">
+                  <a:buFont typeface="Wingdings" panose="05000000000000000000" pitchFamily="2" charset="2"/>
+                  <a:buChar char="q"/>
+                </a:pPr>
+                <a:r>
+                  <a:rPr lang="en-US" sz="1200" noProof="0" dirty="0"/>
+                  <a:t>Restrain heavy atoms for solute simulation </a:t>
+                </a:r>
+                <a:br>
+                  <a:rPr lang="en-US" sz="1200" noProof="0" dirty="0"/>
+                </a:br>
+                <a:r>
+                  <a:rPr lang="en-US" sz="1000" noProof="0" dirty="0"/>
                   <a:t>Harmonic restraint potential  </a:t>
                 </a:r>
                 <a14:m>
@@ -3511,14 +3327,14 @@
                     <m:sSub>
                       <m:sSubPr>
                         <m:ctrlPr>
-                          <a:rPr lang="de-AT" sz="1000" b="0" i="1" smtClean="0">
+                          <a:rPr lang="en-US" sz="1000" b="0" i="1" noProof="0" smtClean="0">
                             <a:latin typeface="Cambria Math" panose="02040503050406030204" pitchFamily="18" charset="0"/>
                           </a:rPr>
                         </m:ctrlPr>
                       </m:sSubPr>
                       <m:e>
                         <m:r>
-                          <a:rPr lang="de-AT" sz="1000" b="0" i="1" smtClean="0">
+                          <a:rPr lang="en-US" sz="1000" b="0" i="1" noProof="0" smtClean="0">
                             <a:latin typeface="Cambria Math" panose="02040503050406030204" pitchFamily="18" charset="0"/>
                           </a:rPr>
                           <m:t>𝑉</m:t>
@@ -3526,7 +3342,7 @@
                       </m:e>
                       <m:sub>
                         <m:r>
-                          <a:rPr lang="de-AT" sz="1000" b="0" i="1" smtClean="0">
+                          <a:rPr lang="en-US" sz="1000" b="0" i="1" noProof="0" smtClean="0">
                             <a:latin typeface="Cambria Math" panose="02040503050406030204" pitchFamily="18" charset="0"/>
                           </a:rPr>
                           <m:t>𝑟</m:t>
@@ -3536,14 +3352,14 @@
                     <m:d>
                       <m:dPr>
                         <m:ctrlPr>
-                          <a:rPr lang="de-AT" sz="1000" b="0" i="1" smtClean="0">
+                          <a:rPr lang="en-US" sz="1000" b="0" i="1" noProof="0" smtClean="0">
                             <a:latin typeface="Cambria Math" panose="02040503050406030204" pitchFamily="18" charset="0"/>
                           </a:rPr>
                         </m:ctrlPr>
                       </m:dPr>
                       <m:e>
                         <m:r>
-                          <a:rPr lang="de-AT" sz="1000" b="0" i="1" smtClean="0">
+                          <a:rPr lang="en-US" sz="1000" b="0" i="1" noProof="0" smtClean="0">
                             <a:latin typeface="Cambria Math" panose="02040503050406030204" pitchFamily="18" charset="0"/>
                           </a:rPr>
                           <m:t>𝑥</m:t>
@@ -3551,7 +3367,7 @@
                       </m:e>
                     </m:d>
                     <m:r>
-                      <a:rPr lang="de-AT" sz="1000" b="0" i="1" smtClean="0">
+                      <a:rPr lang="en-US" sz="1000" b="0" i="1" noProof="0" smtClean="0">
                         <a:latin typeface="Cambria Math" panose="02040503050406030204" pitchFamily="18" charset="0"/>
                       </a:rPr>
                       <m:t>=</m:t>
@@ -3559,14 +3375,14 @@
                     <m:sSub>
                       <m:sSubPr>
                         <m:ctrlPr>
-                          <a:rPr lang="de-AT" sz="1000" b="0" i="1" smtClean="0">
+                          <a:rPr lang="en-US" sz="1000" b="0" i="1" noProof="0" smtClean="0">
                             <a:latin typeface="Cambria Math" panose="02040503050406030204" pitchFamily="18" charset="0"/>
                           </a:rPr>
                         </m:ctrlPr>
                       </m:sSubPr>
                       <m:e>
                         <m:r>
-                          <a:rPr lang="de-AT" sz="1000" b="0" i="1" smtClean="0">
+                          <a:rPr lang="en-US" sz="1000" b="0" i="1" noProof="0" smtClean="0">
                             <a:latin typeface="Cambria Math" panose="02040503050406030204" pitchFamily="18" charset="0"/>
                           </a:rPr>
                           <m:t>𝑘</m:t>
@@ -3574,7 +3390,7 @@
                       </m:e>
                       <m:sub>
                         <m:r>
-                          <a:rPr lang="de-AT" sz="1000" b="0" i="1" smtClean="0">
+                          <a:rPr lang="en-US" sz="1000" b="0" i="1" noProof="0" smtClean="0">
                             <a:latin typeface="Cambria Math" panose="02040503050406030204" pitchFamily="18" charset="0"/>
                           </a:rPr>
                           <m:t>𝑟</m:t>
@@ -3582,7 +3398,7 @@
                       </m:sub>
                     </m:sSub>
                     <m:r>
-                      <a:rPr lang="de-AT" sz="1000" b="0" i="1" smtClean="0">
+                      <a:rPr lang="en-US" sz="1000" b="0" i="1" noProof="0" smtClean="0">
                         <a:latin typeface="Cambria Math" panose="02040503050406030204" pitchFamily="18" charset="0"/>
                       </a:rPr>
                       <m:t>⋅</m:t>
@@ -3591,7 +3407,7 @@
                       <m:rPr>
                         <m:sty m:val="p"/>
                       </m:rPr>
-                      <a:rPr lang="de-AT" sz="1000" b="0" i="0" smtClean="0">
+                      <a:rPr lang="en-US" sz="1000" b="0" i="0" noProof="0" smtClean="0">
                         <a:latin typeface="Cambria Math" panose="02040503050406030204" pitchFamily="18" charset="0"/>
                       </a:rPr>
                       <m:t>Δ</m:t>
@@ -3599,14 +3415,14 @@
                     <m:sSup>
                       <m:sSupPr>
                         <m:ctrlPr>
-                          <a:rPr lang="de-AT" sz="1000" b="0" i="1" smtClean="0">
+                          <a:rPr lang="en-US" sz="1000" b="0" i="1" noProof="0" smtClean="0">
                             <a:latin typeface="Cambria Math" panose="02040503050406030204" pitchFamily="18" charset="0"/>
                           </a:rPr>
                         </m:ctrlPr>
                       </m:sSupPr>
                       <m:e>
                         <m:r>
-                          <a:rPr lang="de-AT" sz="1000" b="0" i="1" smtClean="0">
+                          <a:rPr lang="en-US" sz="1000" b="0" i="1" noProof="0" smtClean="0">
                             <a:latin typeface="Cambria Math" panose="02040503050406030204" pitchFamily="18" charset="0"/>
                           </a:rPr>
                           <m:t>𝑥</m:t>
@@ -3614,7 +3430,7 @@
                       </m:e>
                       <m:sup>
                         <m:r>
-                          <a:rPr lang="de-AT" sz="1000" b="0" i="1" smtClean="0">
+                          <a:rPr lang="en-US" sz="1000" b="0" i="1" noProof="0" smtClean="0">
                             <a:latin typeface="Cambria Math" panose="02040503050406030204" pitchFamily="18" charset="0"/>
                           </a:rPr>
                           <m:t>2</m:t>
@@ -3624,37 +3440,33 @@
                   </m:oMath>
                 </a14:m>
                 <a:br>
-                  <a:rPr lang="de-AT" sz="1000" dirty="0"/>
+                  <a:rPr lang="en-US" sz="1000" noProof="0" dirty="0"/>
                 </a:br>
                 <a:r>
-                  <a:rPr lang="en-US" sz="1000" dirty="0"/>
-                  <a:t>with </a:t>
+                  <a:rPr lang="en-US" sz="1000" noProof="0" dirty="0"/>
+                  <a:t>with k</a:t>
                 </a:r>
                 <a:r>
-                  <a:rPr lang="en-US" sz="1000" dirty="0" err="1"/>
-                  <a:t>k</a:t>
-                </a:r>
-                <a:r>
-                  <a:rPr lang="en-US" sz="1000" baseline="-25000" dirty="0" err="1"/>
+                  <a:rPr lang="en-US" sz="1000" baseline="-25000" noProof="0" dirty="0"/>
                   <a:t>r</a:t>
                 </a:r>
                 <a:r>
-                  <a:rPr lang="en-US" sz="1000" dirty="0"/>
+                  <a:rPr lang="en-US" sz="1000" noProof="0" dirty="0"/>
                   <a:t> =10 - 100 kcal mol</a:t>
                 </a:r>
                 <a:r>
-                  <a:rPr lang="en-US" sz="1000" baseline="30000" dirty="0"/>
+                  <a:rPr lang="en-US" sz="1000" baseline="30000" noProof="0" dirty="0"/>
                   <a:t>-1</a:t>
                 </a:r>
                 <a:r>
-                  <a:rPr lang="en-US" sz="1000" dirty="0"/>
+                  <a:rPr lang="en-US" sz="1000" noProof="0" dirty="0"/>
                   <a:t> Å</a:t>
                 </a:r>
                 <a:r>
-                  <a:rPr lang="en-US" sz="1000" baseline="30000" dirty="0"/>
+                  <a:rPr lang="en-US" sz="1000" baseline="30000" noProof="0" dirty="0"/>
                   <a:t>-2</a:t>
                 </a:r>
-                <a:endParaRPr lang="en-US" sz="1000" dirty="0"/>
+                <a:endParaRPr lang="en-US" sz="1000" noProof="0" dirty="0"/>
               </a:p>
               <a:p>
                 <a:pPr marL="171450" indent="-171450">
@@ -3662,21 +3474,21 @@
                   <a:buChar char="q"/>
                 </a:pPr>
                 <a:r>
-                  <a:rPr lang="en-US" sz="1200" dirty="0"/>
+                  <a:rPr lang="en-US" sz="1200" noProof="0" dirty="0"/>
                   <a:t>Run simulation</a:t>
                 </a:r>
                 <a:br>
-                  <a:rPr lang="en-US" sz="1200" dirty="0"/>
+                  <a:rPr lang="en-US" sz="1200" noProof="0" dirty="0"/>
                 </a:br>
                 <a:r>
-                  <a:rPr lang="en-US" sz="1000" dirty="0"/>
+                  <a:rPr lang="en-US" sz="1000" noProof="0" dirty="0"/>
                   <a:t>≥10 ns (100 ns ideal)</a:t>
                 </a:r>
                 <a:br>
-                  <a:rPr lang="en-US" sz="1000" dirty="0"/>
+                  <a:rPr lang="en-US" sz="1000" noProof="0" dirty="0"/>
                 </a:br>
                 <a:r>
-                  <a:rPr lang="en-US" sz="1000" dirty="0"/>
+                  <a:rPr lang="en-US" sz="1000" noProof="0" dirty="0"/>
                   <a:t>≥ 10 000 frames (100 000 ideal)</a:t>
                 </a:r>
               </a:p>
@@ -3686,21 +3498,21 @@
                   <a:buChar char="q"/>
                 </a:pPr>
                 <a:r>
-                  <a:rPr lang="en-US" sz="1200" dirty="0"/>
+                  <a:rPr lang="en-US" sz="1200" noProof="0" dirty="0"/>
                   <a:t>Confirm rigidity of solute heavy atoms:  Suggested RMSD </a:t>
                 </a:r>
                 <a:r>
-                  <a:rPr lang="en-US" sz="1000" dirty="0"/>
+                  <a:rPr lang="en-US" sz="1000" noProof="0" dirty="0"/>
                   <a:t>≤ 0.1Å</a:t>
                 </a:r>
                 <a:br>
-                  <a:rPr lang="en-US" sz="1000" dirty="0"/>
+                  <a:rPr lang="en-US" sz="1000" noProof="0" dirty="0"/>
                 </a:br>
-                <a:endParaRPr lang="en-US" sz="1000" dirty="0"/>
+                <a:endParaRPr lang="en-US" sz="1000" noProof="0" dirty="0"/>
               </a:p>
               <a:p>
                 <a:r>
-                  <a:rPr lang="en-US" sz="1200" b="1" dirty="0"/>
+                  <a:rPr lang="en-US" sz="1200" b="1" noProof="0" dirty="0"/>
                   <a:t>2. Prepare GIST settings</a:t>
                 </a:r>
               </a:p>
@@ -3710,26 +3522,22 @@
                   <a:buChar char="q"/>
                 </a:pPr>
                 <a:r>
-                  <a:rPr lang="en-US" sz="1200" dirty="0"/>
-                  <a:t>Determine </a:t>
-                </a:r>
-                <a:r>
-                  <a:rPr lang="de-AT" sz="1200" dirty="0"/>
-                  <a:t>reference water density </a:t>
+                  <a:rPr lang="en-US" sz="1200" noProof="0" dirty="0"/>
+                  <a:t>Determine reference water density </a:t>
                 </a:r>
                 <a14:m>
                   <m:oMath xmlns:m="http://schemas.openxmlformats.org/officeDocument/2006/math">
                     <m:sSub>
                       <m:sSubPr>
                         <m:ctrlPr>
-                          <a:rPr lang="de-AT" sz="1200" b="0" i="1" smtClean="0">
+                          <a:rPr lang="en-US" sz="1200" b="0" i="1" noProof="0" smtClean="0">
                             <a:latin typeface="Cambria Math" panose="02040503050406030204" pitchFamily="18" charset="0"/>
                           </a:rPr>
                         </m:ctrlPr>
                       </m:sSubPr>
                       <m:e>
                         <m:r>
-                          <a:rPr lang="de-AT" sz="1200" b="0" i="1" smtClean="0">
+                          <a:rPr lang="en-US" sz="1200" b="0" i="1" noProof="0" smtClean="0">
                             <a:latin typeface="Cambria Math" panose="02040503050406030204" pitchFamily="18" charset="0"/>
                           </a:rPr>
                           <m:t>𝜌</m:t>
@@ -3737,7 +3545,7 @@
                       </m:e>
                       <m:sub>
                         <m:r>
-                          <a:rPr lang="de-AT" sz="1200" b="0" i="1" smtClean="0">
+                          <a:rPr lang="en-US" sz="1200" b="0" i="1" noProof="0" smtClean="0">
                             <a:latin typeface="Cambria Math" panose="02040503050406030204" pitchFamily="18" charset="0"/>
                           </a:rPr>
                           <m:t>0</m:t>
@@ -3747,23 +3555,11 @@
                   </m:oMath>
                 </a14:m>
                 <a:br>
-                  <a:rPr lang="de-AT" sz="1200" b="1" dirty="0"/>
+                  <a:rPr lang="en-US" sz="1200" b="1" noProof="0" dirty="0"/>
                 </a:br>
                 <a:r>
-                  <a:rPr lang="de-AT" sz="1000" dirty="0" err="1"/>
-                  <a:t>Calculate</a:t>
-                </a:r>
-                <a:r>
-                  <a:rPr lang="de-AT" sz="1000" dirty="0"/>
-                  <a:t> </a:t>
-                </a:r>
-                <a:r>
-                  <a:rPr lang="de-AT" sz="1000" dirty="0" err="1"/>
-                  <a:t>reference</a:t>
-                </a:r>
-                <a:r>
-                  <a:rPr lang="de-AT" sz="1000" dirty="0"/>
-                  <a:t> from neat simulation or use tabulated value for the solvent model.</a:t>
+                  <a:rPr lang="en-US" sz="1000" noProof="0" dirty="0"/>
+                  <a:t>Calculate reference from neat simulation or use tabulated value for the solvent model.</a:t>
                 </a:r>
               </a:p>
               <a:p>
@@ -3772,18 +3568,18 @@
                   <a:buChar char="q"/>
                 </a:pPr>
                 <a:r>
-                  <a:rPr lang="en-US" sz="1200" dirty="0"/>
+                  <a:rPr lang="en-US" sz="1200" noProof="0" dirty="0"/>
                   <a:t>Determine grid size</a:t>
                 </a:r>
                 <a:br>
-                  <a:rPr lang="en-US" sz="1200" dirty="0"/>
+                  <a:rPr lang="en-US" sz="1200" noProof="0" dirty="0"/>
                 </a:br>
                 <a:r>
-                  <a:rPr lang="en-US" sz="1200" dirty="0"/>
+                  <a:rPr lang="en-US" sz="1200" noProof="0" dirty="0"/>
                   <a:t>a) binding site                       b) full system                        c) 10 </a:t>
                 </a:r>
                 <a:r>
-                  <a:rPr lang="en-US" sz="1000" dirty="0"/>
+                  <a:rPr lang="en-US" sz="1000" noProof="0" dirty="0"/>
                   <a:t>Å around region of interest </a:t>
                 </a:r>
               </a:p>
@@ -3793,50 +3589,34 @@
                   <a:buChar char="q"/>
                 </a:pPr>
                 <a:r>
-                  <a:rPr lang="en-US" sz="1200" dirty="0"/>
+                  <a:rPr lang="en-US" sz="1200" noProof="0" dirty="0"/>
                   <a:t>Determine voxel number</a:t>
                 </a:r>
                 <a:br>
-                  <a:rPr lang="en-US" sz="1200" dirty="0"/>
+                  <a:rPr lang="en-US" sz="1200" noProof="0" dirty="0"/>
                 </a:br>
                 <a:r>
-                  <a:rPr lang="en-US" sz="1000" dirty="0"/>
-                  <a:t>For each </a:t>
-                </a:r>
-                <a:r>
-                  <a:rPr lang="en-US" sz="1000" dirty="0" err="1"/>
-                  <a:t>cartesi</a:t>
-                </a:r>
-                <a:r>
-                  <a:rPr lang="en-150" sz="1000" dirty="0"/>
-                  <a:t>a</a:t>
-                </a:r>
-                <a:r>
-                  <a:rPr lang="en-US" sz="1000" dirty="0"/>
-                  <a:t>n direction, the number of voxels necessary is the length of the region of interest divided by the voxel side length (0.5 Å ).</a:t>
+                  <a:rPr lang="en-US" sz="1000" noProof="0" dirty="0"/>
+                  <a:t>For each cartesian direction, the number of voxels necessary is the length of the region of interest divided by the voxel side length (0.5 Å ).</a:t>
                 </a:r>
               </a:p>
               <a:p>
-                <a:endParaRPr lang="en-US" sz="1200" dirty="0"/>
+                <a:endParaRPr lang="en-US" sz="1200" noProof="0" dirty="0"/>
               </a:p>
               <a:p>
-                <a:endParaRPr lang="en-US" sz="1200" b="1" dirty="0"/>
+                <a:endParaRPr lang="en-US" sz="1200" b="1" noProof="0" dirty="0"/>
               </a:p>
               <a:p>
                 <a:r>
-                  <a:rPr lang="en-US" sz="1200" b="1" dirty="0"/>
-                  <a:t>3. Run GIST in </a:t>
-                </a:r>
-                <a:r>
-                  <a:rPr lang="en-US" sz="1200" b="1" dirty="0" err="1"/>
-                  <a:t>cpptraj</a:t>
+                  <a:rPr lang="en-US" sz="1200" b="1" noProof="0" dirty="0"/>
+                  <a:t>3. Run GIST in cpptraj</a:t>
                 </a:r>
                 <a:br>
-                  <a:rPr lang="en-US" sz="1000" b="0" i="0" u="none" strike="noStrike" baseline="0" dirty="0">
+                  <a:rPr lang="en-US" sz="1000" b="0" i="0" u="none" strike="noStrike" baseline="0" noProof="0" dirty="0">
                     <a:latin typeface="LMMono8-Regular"/>
                   </a:rPr>
                 </a:br>
-                <a:endParaRPr lang="en-US" sz="800" dirty="0"/>
+                <a:endParaRPr lang="en-US" sz="800" noProof="0" dirty="0"/>
               </a:p>
             </p:txBody>
           </p:sp>
@@ -3930,34 +3710,9 @@
           <a:p>
             <a:pPr algn="ctr"/>
             <a:r>
-              <a:rPr lang="de-AT" sz="1000" dirty="0" err="1"/>
-              <a:t>Define</a:t>
-            </a:r>
-            <a:r>
-              <a:rPr lang="de-AT" sz="1000" dirty="0"/>
-              <a:t> </a:t>
-            </a:r>
-            <a:r>
-              <a:rPr lang="de-AT" sz="1000" dirty="0" err="1"/>
-              <a:t>region</a:t>
-            </a:r>
-            <a:r>
-              <a:rPr lang="de-AT" sz="1000" dirty="0"/>
-              <a:t> </a:t>
-            </a:r>
-            <a:r>
-              <a:rPr lang="de-AT" sz="1000" dirty="0" err="1"/>
-              <a:t>of</a:t>
-            </a:r>
-            <a:r>
-              <a:rPr lang="de-AT" sz="1000" dirty="0"/>
-              <a:t> </a:t>
-            </a:r>
-            <a:r>
-              <a:rPr lang="de-AT" sz="1000" dirty="0" err="1"/>
-              <a:t>interest</a:t>
-            </a:r>
-            <a:endParaRPr lang="en-US" sz="1000" dirty="0"/>
+              <a:rPr lang="en-US" sz="1000" noProof="0" dirty="0"/>
+              <a:t>Define region of interest</a:t>
+            </a:r>
           </a:p>
         </p:txBody>
       </p:sp>
@@ -4002,42 +3757,9 @@
           <a:p>
             <a:pPr algn="ctr"/>
             <a:r>
-              <a:rPr lang="de-AT" sz="1000" dirty="0" err="1"/>
-              <a:t>Calculate</a:t>
-            </a:r>
-            <a:r>
-              <a:rPr lang="de-AT" sz="1000" dirty="0"/>
-              <a:t> </a:t>
-            </a:r>
-            <a:r>
-              <a:rPr lang="de-AT" sz="1000" dirty="0" err="1"/>
-              <a:t>number</a:t>
-            </a:r>
-            <a:r>
-              <a:rPr lang="de-AT" sz="1000" dirty="0"/>
-              <a:t> </a:t>
-            </a:r>
-            <a:r>
-              <a:rPr lang="de-AT" sz="1000" dirty="0" err="1"/>
-              <a:t>of</a:t>
-            </a:r>
-            <a:r>
-              <a:rPr lang="de-AT" sz="1000" dirty="0"/>
-              <a:t> </a:t>
-            </a:r>
-            <a:r>
-              <a:rPr lang="de-AT" sz="1000" dirty="0" err="1"/>
-              <a:t>voxels</a:t>
-            </a:r>
-            <a:r>
-              <a:rPr lang="de-AT" sz="1000" dirty="0"/>
-              <a:t> </a:t>
-            </a:r>
-            <a:r>
-              <a:rPr lang="de-AT" sz="1000" dirty="0" err="1"/>
-              <a:t>necessary</a:t>
-            </a:r>
-            <a:endParaRPr lang="en-US" sz="1000" dirty="0"/>
+              <a:rPr lang="en-US" sz="1000" noProof="0" dirty="0"/>
+              <a:t>Calculate number of voxels necessary</a:t>
+            </a:r>
           </a:p>
         </p:txBody>
       </p:sp>
@@ -4082,26 +3804,9 @@
           <a:p>
             <a:pPr algn="ctr"/>
             <a:r>
-              <a:rPr lang="de-AT" sz="1000" dirty="0" err="1"/>
-              <a:t>Reimage</a:t>
-            </a:r>
-            <a:r>
-              <a:rPr lang="de-AT" sz="1000" dirty="0"/>
-              <a:t> and </a:t>
-            </a:r>
-            <a:r>
-              <a:rPr lang="de-AT" sz="1000" dirty="0" err="1"/>
-              <a:t>center</a:t>
-            </a:r>
-            <a:r>
-              <a:rPr lang="de-AT" sz="1000" dirty="0"/>
-              <a:t> MD </a:t>
-            </a:r>
-            <a:r>
-              <a:rPr lang="de-AT" sz="1000" dirty="0" err="1"/>
-              <a:t>trajectory</a:t>
-            </a:r>
-            <a:endParaRPr lang="en-US" sz="1000" dirty="0"/>
+              <a:rPr lang="en-US" sz="1000" noProof="0" dirty="0"/>
+              <a:t>Reimage and center MD trajectory</a:t>
+            </a:r>
           </a:p>
         </p:txBody>
       </p:sp>
@@ -4146,30 +3851,9 @@
           <a:p>
             <a:pPr algn="ctr"/>
             <a:r>
-              <a:rPr lang="de-AT" sz="1000" dirty="0"/>
-              <a:t>Set </a:t>
-            </a:r>
-            <a:r>
-              <a:rPr lang="de-AT" sz="1000" dirty="0" err="1"/>
-              <a:t>voxel</a:t>
-            </a:r>
-            <a:r>
-              <a:rPr lang="de-AT" sz="1000" dirty="0"/>
-              <a:t> </a:t>
-            </a:r>
-            <a:r>
-              <a:rPr lang="de-AT" sz="1000" dirty="0" err="1"/>
-              <a:t>number</a:t>
-            </a:r>
-            <a:r>
-              <a:rPr lang="de-AT" sz="1000" dirty="0"/>
-              <a:t> per </a:t>
-            </a:r>
-            <a:r>
-              <a:rPr lang="de-AT" sz="1000" dirty="0" err="1"/>
-              <a:t>axis</a:t>
-            </a:r>
-            <a:endParaRPr lang="en-US" sz="1000" dirty="0"/>
+              <a:rPr lang="en-US" sz="1000" noProof="0" dirty="0"/>
+              <a:t>Set voxel number per axis</a:t>
+            </a:r>
           </a:p>
         </p:txBody>
       </p:sp>
@@ -4219,38 +3903,22 @@
               <a:p>
                 <a:pPr algn="ctr"/>
                 <a:r>
-                  <a:rPr lang="de-AT" sz="1000" dirty="0"/>
-                  <a:t>Calculate </a:t>
-                </a:r>
-                <a:r>
-                  <a:rPr lang="de-AT" sz="1000" dirty="0" err="1"/>
-                  <a:t>reference</a:t>
-                </a:r>
-                <a:r>
-                  <a:rPr lang="de-AT" sz="1000" dirty="0"/>
-                  <a:t> </a:t>
-                </a:r>
-                <a:r>
-                  <a:rPr lang="de-AT" sz="1000" dirty="0" err="1"/>
-                  <a:t>density</a:t>
-                </a:r>
-                <a:r>
-                  <a:rPr lang="de-AT" sz="1000" dirty="0"/>
-                  <a:t> </a:t>
+                  <a:rPr lang="en-US" sz="1000" noProof="0" dirty="0"/>
+                  <a:t>Calculate reference density </a:t>
                 </a:r>
                 <a14:m>
                   <m:oMath xmlns:m="http://schemas.openxmlformats.org/officeDocument/2006/math">
                     <m:sSub>
                       <m:sSubPr>
                         <m:ctrlPr>
-                          <a:rPr lang="de-AT" sz="1000" b="0" i="1" smtClean="0">
+                          <a:rPr lang="en-US" sz="1000" b="0" i="1" noProof="0" smtClean="0">
                             <a:latin typeface="Cambria Math" panose="02040503050406030204" pitchFamily="18" charset="0"/>
                           </a:rPr>
                         </m:ctrlPr>
                       </m:sSubPr>
                       <m:e>
                         <m:r>
-                          <a:rPr lang="de-AT" sz="1000" b="0" i="1" smtClean="0">
+                          <a:rPr lang="en-US" sz="1000" b="0" i="1" noProof="0" smtClean="0">
                             <a:latin typeface="Cambria Math" panose="02040503050406030204" pitchFamily="18" charset="0"/>
                           </a:rPr>
                           <m:t>𝜌</m:t>
@@ -4258,7 +3926,7 @@
                       </m:e>
                       <m:sub>
                         <m:r>
-                          <a:rPr lang="de-AT" sz="1000" b="0" i="1" smtClean="0">
+                          <a:rPr lang="en-US" sz="1000" b="0" i="1" noProof="0" smtClean="0">
                             <a:latin typeface="Cambria Math" panose="02040503050406030204" pitchFamily="18" charset="0"/>
                           </a:rPr>
                           <m:t>0</m:t>
@@ -4268,26 +3936,9 @@
                   </m:oMath>
                 </a14:m>
                 <a:r>
-                  <a:rPr lang="de-AT" sz="1000" dirty="0"/>
-                  <a:t> </a:t>
+                  <a:rPr lang="en-US" sz="1000" noProof="0" dirty="0"/>
+                  <a:t> of neat solvent</a:t>
                 </a:r>
-                <a:r>
-                  <a:rPr lang="de-AT" sz="1000" dirty="0" err="1"/>
-                  <a:t>of</a:t>
-                </a:r>
-                <a:r>
-                  <a:rPr lang="de-AT" sz="1000" dirty="0"/>
-                  <a:t> </a:t>
-                </a:r>
-                <a:r>
-                  <a:rPr lang="de-AT" sz="1000" dirty="0" err="1"/>
-                  <a:t>neat</a:t>
-                </a:r>
-                <a:r>
-                  <a:rPr lang="de-AT" sz="1000" dirty="0"/>
-                  <a:t> solvent</a:t>
-                </a:r>
-                <a:endParaRPr lang="en-US" sz="1000" dirty="0"/>
               </a:p>
             </p:txBody>
           </p:sp>
@@ -4381,10 +4032,9 @@
           <a:p>
             <a:pPr algn="ctr"/>
             <a:r>
-              <a:rPr lang="de-AT" sz="1000" dirty="0"/>
+              <a:rPr lang="en-US" sz="1000" noProof="0" dirty="0"/>
               <a:t>Run GIST</a:t>
             </a:r>
-            <a:endParaRPr lang="en-US" sz="1000" dirty="0"/>
           </a:p>
         </p:txBody>
       </p:sp>
@@ -4429,26 +4079,9 @@
           <a:p>
             <a:pPr algn="ctr"/>
             <a:r>
-              <a:rPr lang="de-AT" sz="1000" dirty="0" err="1"/>
-              <a:t>Prepare</a:t>
-            </a:r>
-            <a:r>
-              <a:rPr lang="de-AT" sz="1000" dirty="0"/>
-              <a:t> </a:t>
-            </a:r>
-            <a:r>
-              <a:rPr lang="de-AT" sz="1000" dirty="0" err="1"/>
-              <a:t>solute</a:t>
-            </a:r>
-            <a:r>
-              <a:rPr lang="de-AT" sz="1000" dirty="0"/>
-              <a:t> </a:t>
-            </a:r>
-            <a:r>
-              <a:rPr lang="de-AT" sz="1000" dirty="0" err="1"/>
-              <a:t>structure</a:t>
-            </a:r>
-            <a:endParaRPr lang="en-US" sz="1000" dirty="0"/>
+              <a:rPr lang="en-US" sz="1000" noProof="0" dirty="0"/>
+              <a:t>Prepare solute structure</a:t>
+            </a:r>
           </a:p>
         </p:txBody>
       </p:sp>
@@ -4703,23 +4336,14 @@
           <a:p>
             <a:pPr algn="ctr"/>
             <a:r>
-              <a:rPr lang="de-AT" sz="1200" dirty="0" err="1"/>
-              <a:t>Solute</a:t>
-            </a:r>
-            <a:r>
-              <a:rPr lang="de-AT" sz="1200" dirty="0"/>
-              <a:t> </a:t>
-            </a:r>
-            <a:r>
-              <a:rPr lang="de-AT" sz="1200" dirty="0" err="1"/>
-              <a:t>Trajectory</a:t>
-            </a:r>
-            <a:endParaRPr lang="en-US" sz="1200" dirty="0"/>
-          </a:p>
-        </p:txBody>
-      </p:sp>
-      <mc:AlternateContent xmlns:mc="http://schemas.openxmlformats.org/markup-compatibility/2006" xmlns:a14="http://schemas.microsoft.com/office/drawing/2010/main">
-        <mc:Choice Requires="a14">
+              <a:rPr lang="en-US" sz="1200" noProof="0" dirty="0"/>
+              <a:t>Solute Trajectory</a:t>
+            </a:r>
+          </a:p>
+        </p:txBody>
+      </p:sp>
+      <mc:AlternateContent xmlns:mc="http://schemas.openxmlformats.org/markup-compatibility/2006">
+        <mc:Choice xmlns:a14="http://schemas.microsoft.com/office/drawing/2010/main" Requires="a14">
           <p:sp>
             <p:nvSpPr>
               <p:cNvPr id="36" name="Rectangle: Rounded Corners 35">
@@ -4764,46 +4388,22 @@
               <a:p>
                 <a:pPr algn="ctr"/>
                 <a:r>
-                  <a:rPr lang="de-AT" sz="1000" dirty="0"/>
-                  <a:t>Calculate </a:t>
-                </a:r>
-                <a:r>
-                  <a:rPr lang="de-AT" sz="1000" dirty="0" err="1"/>
-                  <a:t>reference</a:t>
-                </a:r>
-                <a:r>
-                  <a:rPr lang="de-AT" sz="1000" dirty="0"/>
-                  <a:t> </a:t>
-                </a:r>
-                <a:r>
-                  <a:rPr lang="de-AT" sz="1000" dirty="0" err="1"/>
-                  <a:t>water-water</a:t>
-                </a:r>
-                <a:r>
-                  <a:rPr lang="de-AT" sz="1000" dirty="0"/>
-                  <a:t> </a:t>
-                </a:r>
-                <a:r>
-                  <a:rPr lang="de-AT" sz="1000" dirty="0" err="1"/>
-                  <a:t>energy</a:t>
-                </a:r>
-                <a:r>
-                  <a:rPr lang="de-AT" sz="1000" dirty="0"/>
-                  <a:t> </a:t>
+                  <a:rPr lang="en-US" sz="1000" noProof="0" dirty="0"/>
+                  <a:t>Calculate reference water-water energy </a:t>
                 </a:r>
                 <a14:m>
                   <m:oMath xmlns:m="http://schemas.openxmlformats.org/officeDocument/2006/math">
                     <m:sSub>
                       <m:sSubPr>
                         <m:ctrlPr>
-                          <a:rPr lang="de-AT" sz="1000" b="0" i="1" smtClean="0">
+                          <a:rPr lang="en-US" sz="1000" b="0" i="1" noProof="0" smtClean="0">
                             <a:latin typeface="Cambria Math" panose="02040503050406030204" pitchFamily="18" charset="0"/>
                           </a:rPr>
                         </m:ctrlPr>
                       </m:sSubPr>
                       <m:e>
                         <m:r>
-                          <a:rPr lang="de-AT" sz="1000" b="0" i="1" smtClean="0">
+                          <a:rPr lang="en-US" sz="1000" b="0" i="1" noProof="0" smtClean="0">
                             <a:latin typeface="Cambria Math" panose="02040503050406030204" pitchFamily="18" charset="0"/>
                           </a:rPr>
                           <m:t>𝐸</m:t>
@@ -4811,7 +4411,7 @@
                       </m:e>
                       <m:sub>
                         <m:r>
-                          <a:rPr lang="de-AT" sz="1000" b="0" i="1" smtClean="0">
+                          <a:rPr lang="en-US" sz="1000" b="0" i="1" noProof="0" smtClean="0">
                             <a:latin typeface="Cambria Math" panose="02040503050406030204" pitchFamily="18" charset="0"/>
                           </a:rPr>
                           <m:t>𝑤𝑤</m:t>
@@ -4820,12 +4420,12 @@
                     </m:sSub>
                   </m:oMath>
                 </a14:m>
-                <a:endParaRPr lang="en-US" sz="1000" dirty="0"/>
+                <a:endParaRPr lang="en-US" sz="1000" noProof="0" dirty="0"/>
               </a:p>
             </p:txBody>
           </p:sp>
         </mc:Choice>
-        <mc:Fallback xmlns="">
+        <mc:Fallback>
           <p:sp>
             <p:nvSpPr>
               <p:cNvPr id="36" name="Rectangle: Rounded Corners 35">
@@ -4918,10 +4518,9 @@
           <a:p>
             <a:pPr algn="ctr"/>
             <a:r>
-              <a:rPr lang="de-AT" dirty="0"/>
+              <a:rPr lang="en-US" noProof="0" dirty="0"/>
               <a:t>gist.dat</a:t>
             </a:r>
-            <a:endParaRPr lang="en-US" dirty="0"/>
           </a:p>
         </p:txBody>
       </p:sp>
@@ -4971,14 +4570,9 @@
           <a:p>
             <a:pPr algn="ctr"/>
             <a:r>
-              <a:rPr lang="de-AT" sz="1200" dirty="0"/>
-              <a:t>Neat Solvent </a:t>
-            </a:r>
-            <a:r>
-              <a:rPr lang="de-AT" sz="1200" dirty="0" err="1"/>
-              <a:t>Trajectory</a:t>
-            </a:r>
-            <a:endParaRPr lang="en-US" sz="1200" dirty="0"/>
+              <a:rPr lang="en-US" sz="1200" noProof="0" dirty="0"/>
+              <a:t>Neat Solvent Trajectory</a:t>
+            </a:r>
           </a:p>
         </p:txBody>
       </p:sp>
@@ -5026,18 +4620,13 @@
           <a:p>
             <a:pPr algn="ctr"/>
             <a:r>
-              <a:rPr lang="de-AT" sz="1000" dirty="0">
+              <a:rPr lang="en-US" sz="1000" noProof="0" dirty="0">
                 <a:solidFill>
                   <a:schemeClr val="tx1"/>
                 </a:solidFill>
               </a:rPr>
               <a:t>Minimization &amp; Equilibration</a:t>
             </a:r>
-            <a:endParaRPr lang="en-US" sz="1000" dirty="0">
-              <a:solidFill>
-                <a:schemeClr val="tx1"/>
-              </a:solidFill>
-            </a:endParaRPr>
           </a:p>
         </p:txBody>
       </p:sp>
@@ -5082,42 +4671,9 @@
           <a:p>
             <a:pPr algn="ctr"/>
             <a:r>
-              <a:rPr lang="de-AT" sz="1000" dirty="0"/>
-              <a:t>Save </a:t>
-            </a:r>
-            <a:r>
-              <a:rPr lang="de-AT" sz="1000" dirty="0" err="1"/>
-              <a:t>solute</a:t>
-            </a:r>
-            <a:r>
-              <a:rPr lang="de-AT" sz="1000" dirty="0"/>
-              <a:t> </a:t>
-            </a:r>
-            <a:r>
-              <a:rPr lang="de-AT" sz="1000" dirty="0" err="1"/>
-              <a:t>coordinates</a:t>
-            </a:r>
-            <a:r>
-              <a:rPr lang="de-AT" sz="1000" dirty="0"/>
-              <a:t> </a:t>
-            </a:r>
-            <a:r>
-              <a:rPr lang="de-AT" sz="1000" dirty="0" err="1"/>
-              <a:t>of</a:t>
-            </a:r>
-            <a:r>
-              <a:rPr lang="de-AT" sz="1000" dirty="0"/>
-              <a:t> </a:t>
-            </a:r>
-            <a:r>
-              <a:rPr lang="de-AT" sz="1000" dirty="0" err="1"/>
-              <a:t>first</a:t>
-            </a:r>
-            <a:r>
-              <a:rPr lang="de-AT" sz="1000" dirty="0"/>
-              <a:t> frame</a:t>
-            </a:r>
-            <a:endParaRPr lang="en-US" sz="1000" dirty="0"/>
+              <a:rPr lang="en-US" sz="1000" noProof="0" dirty="0"/>
+              <a:t>Save solute coordinates of first frame</a:t>
+            </a:r>
           </a:p>
         </p:txBody>
       </p:sp>
@@ -5166,15 +4722,14 @@
           <a:p>
             <a:pPr algn="ctr"/>
             <a:r>
-              <a:rPr lang="de-AT" sz="1200" dirty="0"/>
+              <a:rPr lang="en-US" sz="1200" noProof="0" dirty="0"/>
               <a:t>gist.pdb</a:t>
             </a:r>
-            <a:endParaRPr lang="en-US" sz="1200" dirty="0"/>
-          </a:p>
-        </p:txBody>
-      </p:sp>
-      <mc:AlternateContent xmlns:mc="http://schemas.openxmlformats.org/markup-compatibility/2006" xmlns:a14="http://schemas.microsoft.com/office/drawing/2010/main">
-        <mc:Choice Requires="a14">
+          </a:p>
+        </p:txBody>
+      </p:sp>
+      <mc:AlternateContent xmlns:mc="http://schemas.openxmlformats.org/markup-compatibility/2006">
+        <mc:Choice xmlns:a14="http://schemas.microsoft.com/office/drawing/2010/main" Requires="a14">
           <p:sp>
             <p:nvSpPr>
               <p:cNvPr id="45" name="Parallelogram 44">
@@ -5222,7 +4777,7 @@
               <a:lstStyle/>
               <a:p>
                 <a:pPr algn="ctr"/>
-                <a:endParaRPr lang="de-AT" sz="1200" b="0" dirty="0"/>
+                <a:endParaRPr lang="en-US" sz="1200" b="0" noProof="0" dirty="0"/>
               </a:p>
               <a:p>
                 <a:pPr algn="ctr"/>
@@ -5235,14 +4790,14 @@
                       <m:sSub>
                         <m:sSubPr>
                           <m:ctrlPr>
-                            <a:rPr lang="de-AT" sz="1200" b="0" i="1" smtClean="0">
+                            <a:rPr lang="en-US" sz="1200" b="0" i="1" noProof="0" smtClean="0">
                               <a:latin typeface="Cambria Math" panose="02040503050406030204" pitchFamily="18" charset="0"/>
                             </a:rPr>
                           </m:ctrlPr>
                         </m:sSubPr>
                         <m:e>
                           <m:r>
-                            <a:rPr lang="de-AT" sz="1200" b="0" i="1" smtClean="0">
+                            <a:rPr lang="en-US" sz="1200" b="0" i="1" noProof="0" smtClean="0">
                               <a:latin typeface="Cambria Math" panose="02040503050406030204" pitchFamily="18" charset="0"/>
                             </a:rPr>
                             <m:t>𝐸</m:t>
@@ -5250,19 +4805,19 @@
                         </m:e>
                         <m:sub>
                           <m:r>
-                            <a:rPr lang="de-AT" sz="1200" b="0" i="1" smtClean="0">
+                            <a:rPr lang="en-US" sz="1200" b="0" i="1" noProof="0" smtClean="0">
                               <a:latin typeface="Cambria Math" panose="02040503050406030204" pitchFamily="18" charset="0"/>
                             </a:rPr>
                             <m:t>𝑤𝑤</m:t>
                           </m:r>
                           <m:r>
-                            <a:rPr lang="de-AT" sz="1200" b="0" i="1" smtClean="0">
+                            <a:rPr lang="en-US" sz="1200" b="0" i="1" noProof="0" smtClean="0">
                               <a:latin typeface="Cambria Math" panose="02040503050406030204" pitchFamily="18" charset="0"/>
                             </a:rPr>
                             <m:t>, </m:t>
                           </m:r>
                           <m:r>
-                            <a:rPr lang="de-AT" sz="1200" b="0" i="1" smtClean="0">
+                            <a:rPr lang="en-US" sz="1200" b="0" i="1" noProof="0" smtClean="0">
                               <a:latin typeface="Cambria Math" panose="02040503050406030204" pitchFamily="18" charset="0"/>
                             </a:rPr>
                             <m:t>𝑟𝑒𝑓</m:t>
@@ -5272,16 +4827,16 @@
                     </m:oMath>
                   </m:oMathPara>
                 </a14:m>
-                <a:endParaRPr lang="de-AT" sz="1200" b="0" dirty="0"/>
+                <a:endParaRPr lang="en-US" sz="1200" b="0" noProof="0" dirty="0"/>
               </a:p>
               <a:p>
                 <a:pPr algn="ctr"/>
-                <a:endParaRPr lang="en-US" sz="1200" dirty="0"/>
+                <a:endParaRPr lang="en-US" sz="1200" noProof="0" dirty="0"/>
               </a:p>
             </p:txBody>
           </p:sp>
         </mc:Choice>
-        <mc:Fallback xmlns="">
+        <mc:Fallback>
           <p:sp>
             <p:nvSpPr>
               <p:cNvPr id="45" name="Parallelogram 44">
@@ -5331,8 +4886,8 @@
           </p:sp>
         </mc:Fallback>
       </mc:AlternateContent>
-      <mc:AlternateContent xmlns:mc="http://schemas.openxmlformats.org/markup-compatibility/2006" xmlns:a14="http://schemas.microsoft.com/office/drawing/2010/main">
-        <mc:Choice Requires="a14">
+      <mc:AlternateContent xmlns:mc="http://schemas.openxmlformats.org/markup-compatibility/2006">
+        <mc:Choice xmlns:a14="http://schemas.microsoft.com/office/drawing/2010/main" Requires="a14">
           <p:sp>
             <p:nvSpPr>
               <p:cNvPr id="46" name="Parallelogram 45">
@@ -5389,14 +4944,14 @@
                       <m:sSub>
                         <m:sSubPr>
                           <m:ctrlPr>
-                            <a:rPr lang="de-AT" sz="1200" b="0" i="1" smtClean="0">
+                            <a:rPr lang="en-US" sz="1200" b="0" i="1" noProof="0" smtClean="0">
                               <a:latin typeface="Cambria Math" panose="02040503050406030204" pitchFamily="18" charset="0"/>
                             </a:rPr>
                           </m:ctrlPr>
                         </m:sSubPr>
                         <m:e>
                           <m:r>
-                            <a:rPr lang="de-AT" sz="1200" b="0" i="1" smtClean="0">
+                            <a:rPr lang="en-US" sz="1200" b="0" i="1" noProof="0" smtClean="0">
                               <a:latin typeface="Cambria Math" panose="02040503050406030204" pitchFamily="18" charset="0"/>
                             </a:rPr>
                             <m:t>𝜌</m:t>
@@ -5404,7 +4959,7 @@
                         </m:e>
                         <m:sub>
                           <m:r>
-                            <a:rPr lang="de-AT" sz="1200" b="0" i="1" smtClean="0">
+                            <a:rPr lang="en-US" sz="1200" b="0" i="1" noProof="0" smtClean="0">
                               <a:latin typeface="Cambria Math" panose="02040503050406030204" pitchFamily="18" charset="0"/>
                             </a:rPr>
                             <m:t>0</m:t>
@@ -5414,12 +4969,12 @@
                     </m:oMath>
                   </m:oMathPara>
                 </a14:m>
-                <a:endParaRPr lang="de-AT" sz="1200" b="0" dirty="0"/>
+                <a:endParaRPr lang="en-US" sz="1200" b="0" noProof="0" dirty="0"/>
               </a:p>
             </p:txBody>
           </p:sp>
         </mc:Choice>
-        <mc:Fallback xmlns="">
+        <mc:Fallback>
           <p:sp>
             <p:nvSpPr>
               <p:cNvPr id="46" name="Parallelogram 45">
@@ -5512,18 +5067,9 @@
           <a:p>
             <a:pPr algn="ctr"/>
             <a:r>
-              <a:rPr lang="de-AT" sz="1200" dirty="0" err="1"/>
-              <a:t>Solute</a:t>
-            </a:r>
-            <a:r>
-              <a:rPr lang="de-AT" sz="1200" dirty="0"/>
-              <a:t> </a:t>
-            </a:r>
-            <a:r>
-              <a:rPr lang="de-AT" sz="1200" dirty="0" err="1"/>
-              <a:t>structure</a:t>
-            </a:r>
-            <a:endParaRPr lang="en-US" sz="1200" dirty="0"/>
+              <a:rPr lang="en-US" sz="1200" noProof="0" dirty="0"/>
+              <a:t>Solute structure</a:t>
+            </a:r>
           </a:p>
         </p:txBody>
       </p:sp>
@@ -6155,13 +5701,13 @@
           <a:p>
             <a:pPr algn="ctr"/>
             <a:r>
-              <a:rPr lang="de-AT" sz="800" b="1" dirty="0"/>
+              <a:rPr lang="en-US" sz="800" b="1" noProof="0" dirty="0"/>
               <a:t>Optional</a:t>
             </a:r>
           </a:p>
           <a:p>
             <a:pPr algn="ctr"/>
-            <a:endParaRPr lang="de-AT" sz="800" b="1" dirty="0"/>
+            <a:endParaRPr lang="en-US" sz="800" b="1" noProof="0" dirty="0"/>
           </a:p>
         </p:txBody>
       </p:sp>
@@ -6206,74 +5752,9 @@
           <a:p>
             <a:pPr algn="ctr"/>
             <a:r>
-              <a:rPr lang="de-AT" sz="1000" dirty="0" err="1"/>
-              <a:t>Define</a:t>
-            </a:r>
-            <a:r>
-              <a:rPr lang="de-AT" sz="1000" dirty="0"/>
-              <a:t> </a:t>
-            </a:r>
-            <a:r>
-              <a:rPr lang="de-AT" sz="1000" dirty="0" err="1"/>
-              <a:t>grid</a:t>
-            </a:r>
-            <a:r>
-              <a:rPr lang="de-AT" sz="1000" dirty="0"/>
-              <a:t> </a:t>
-            </a:r>
-            <a:r>
-              <a:rPr lang="de-AT" sz="1000" dirty="0" err="1"/>
-              <a:t>center</a:t>
-            </a:r>
-            <a:r>
-              <a:rPr lang="de-AT" sz="1000" dirty="0"/>
-              <a:t> </a:t>
-            </a:r>
-            <a:r>
-              <a:rPr lang="de-AT" sz="1000" dirty="0" err="1"/>
-              <a:t>if</a:t>
-            </a:r>
-            <a:r>
-              <a:rPr lang="de-AT" sz="1000" dirty="0"/>
-              <a:t> </a:t>
-            </a:r>
-            <a:r>
-              <a:rPr lang="de-AT" sz="1000" dirty="0" err="1"/>
-              <a:t>solute</a:t>
-            </a:r>
-            <a:r>
-              <a:rPr lang="de-AT" sz="1000" dirty="0"/>
-              <a:t>/</a:t>
-            </a:r>
-            <a:r>
-              <a:rPr lang="de-AT" sz="1000" dirty="0" err="1"/>
-              <a:t>region</a:t>
-            </a:r>
-            <a:r>
-              <a:rPr lang="de-AT" sz="1000" dirty="0"/>
-              <a:t> </a:t>
-            </a:r>
-            <a:r>
-              <a:rPr lang="de-AT" sz="1000" dirty="0" err="1"/>
-              <a:t>is</a:t>
-            </a:r>
-            <a:r>
-              <a:rPr lang="de-AT" sz="1000" dirty="0"/>
-              <a:t> not </a:t>
-            </a:r>
-            <a:r>
-              <a:rPr lang="de-AT" sz="1000" dirty="0" err="1"/>
-              <a:t>centered</a:t>
-            </a:r>
-            <a:r>
-              <a:rPr lang="de-AT" sz="1000" dirty="0"/>
-              <a:t> on </a:t>
-            </a:r>
-            <a:r>
-              <a:rPr lang="de-AT" sz="1000" dirty="0" err="1"/>
-              <a:t>origin</a:t>
-            </a:r>
-            <a:endParaRPr lang="en-US" sz="1000" dirty="0"/>
+              <a:rPr lang="en-US" sz="1000" noProof="0" dirty="0"/>
+              <a:t>Define grid center if solute/region is not centered on origin</a:t>
+            </a:r>
           </a:p>
         </p:txBody>
       </p:sp>
@@ -6476,7 +5957,7 @@
           </a:bodyPr>
           <a:lstStyle/>
           <a:p>
-            <a:endParaRPr lang="en-US"/>
+            <a:endParaRPr lang="en-US" noProof="0" dirty="0"/>
           </a:p>
         </p:txBody>
       </p:sp>
@@ -6510,8 +5991,8 @@
           <a:chExt cx="0" cy="0"/>
         </a:xfrm>
       </p:grpSpPr>
-      <mc:AlternateContent xmlns:mc="http://schemas.openxmlformats.org/markup-compatibility/2006" xmlns:a14="http://schemas.microsoft.com/office/drawing/2010/main">
-        <mc:Choice Requires="a14">
+      <mc:AlternateContent xmlns:mc="http://schemas.openxmlformats.org/markup-compatibility/2006">
+        <mc:Choice xmlns:a14="http://schemas.microsoft.com/office/drawing/2010/main" Requires="a14">
           <p:sp>
             <p:nvSpPr>
               <p:cNvPr id="22" name="TextBox 21">
@@ -6527,7 +6008,7 @@
             <p:spPr>
               <a:xfrm>
                 <a:off x="4656316" y="764495"/>
-                <a:ext cx="2208520" cy="7524560"/>
+                <a:ext cx="2208520" cy="7536871"/>
               </a:xfrm>
               <a:prstGeom prst="rect">
                 <a:avLst/>
@@ -6545,16 +6026,8 @@
               <a:lstStyle/>
               <a:p>
                 <a:r>
-                  <a:rPr lang="de-AT" sz="1200" b="1" dirty="0"/>
-                  <a:t>4a. </a:t>
-                </a:r>
-                <a:r>
-                  <a:rPr lang="de-AT" sz="1200" b="1" dirty="0" err="1"/>
-                  <a:t>Postprocess</a:t>
-                </a:r>
-                <a:r>
-                  <a:rPr lang="de-AT" sz="1200" b="1" dirty="0"/>
-                  <a:t> &amp; Analysis</a:t>
+                  <a:rPr lang="en-US" sz="1200" b="1" noProof="0" dirty="0"/>
+                  <a:t>4a. Postprocess &amp; Analysis</a:t>
                 </a:r>
               </a:p>
               <a:p>
@@ -6563,26 +6036,22 @@
                   <a:buChar char="q"/>
                 </a:pPr>
                 <a:r>
-                  <a:rPr lang="de-AT" sz="1200" dirty="0" err="1"/>
-                  <a:t>Determine</a:t>
-                </a:r>
-                <a:r>
-                  <a:rPr lang="de-AT" sz="1200" dirty="0"/>
-                  <a:t> </a:t>
+                  <a:rPr lang="en-US" sz="1200" noProof="0" dirty="0"/>
+                  <a:t>Determine </a:t>
                 </a:r>
                 <a14:m>
                   <m:oMath xmlns:m="http://schemas.openxmlformats.org/officeDocument/2006/math">
                     <m:sSub>
                       <m:sSubPr>
                         <m:ctrlPr>
-                          <a:rPr lang="de-AT" sz="1200" i="1" smtClean="0">
+                          <a:rPr lang="en-US" sz="1200" i="1" noProof="0" smtClean="0">
                             <a:latin typeface="Cambria Math" panose="02040503050406030204" pitchFamily="18" charset="0"/>
                           </a:rPr>
                         </m:ctrlPr>
                       </m:sSubPr>
                       <m:e>
                         <m:r>
-                          <a:rPr lang="de-AT" sz="1200" b="0" i="1" smtClean="0">
+                          <a:rPr lang="en-US" sz="1200" b="0" i="1" noProof="0" smtClean="0">
                             <a:latin typeface="Cambria Math" panose="02040503050406030204" pitchFamily="18" charset="0"/>
                           </a:rPr>
                           <m:t>𝐸</m:t>
@@ -6590,19 +6059,19 @@
                       </m:e>
                       <m:sub>
                         <m:r>
-                          <a:rPr lang="de-AT" sz="1200" b="0" i="1" smtClean="0">
+                          <a:rPr lang="en-US" sz="1200" b="0" i="1" noProof="0" smtClean="0">
                             <a:latin typeface="Cambria Math" panose="02040503050406030204" pitchFamily="18" charset="0"/>
                           </a:rPr>
                           <m:t>𝑤𝑤</m:t>
                         </m:r>
                         <m:r>
-                          <a:rPr lang="de-AT" sz="1200" b="0" i="1" smtClean="0">
+                          <a:rPr lang="en-US" sz="1200" b="0" i="1" noProof="0" smtClean="0">
                             <a:latin typeface="Cambria Math" panose="02040503050406030204" pitchFamily="18" charset="0"/>
                           </a:rPr>
                           <m:t>, </m:t>
                         </m:r>
                         <m:r>
-                          <a:rPr lang="de-AT" sz="1200" b="0" i="1" smtClean="0">
+                          <a:rPr lang="en-US" sz="1200" b="0" i="1" noProof="0" smtClean="0">
                             <a:latin typeface="Cambria Math" panose="02040503050406030204" pitchFamily="18" charset="0"/>
                           </a:rPr>
                           <m:t>𝑟𝑒𝑓</m:t>
@@ -6612,160 +6081,16 @@
                   </m:oMath>
                 </a14:m>
                 <a:br>
-                  <a:rPr lang="de-AT" sz="1200" dirty="0"/>
+                  <a:rPr lang="en-US" sz="1200" noProof="0" dirty="0"/>
                 </a:br>
                 <a:r>
-                  <a:rPr lang="de-AT" sz="1000" dirty="0"/>
-                  <a:t>Use </a:t>
-                </a:r>
-                <a:r>
-                  <a:rPr lang="de-AT" sz="1000" dirty="0" err="1"/>
-                  <a:t>tabulated</a:t>
-                </a:r>
-                <a:r>
-                  <a:rPr lang="de-AT" sz="1000" dirty="0"/>
-                  <a:t> </a:t>
-                </a:r>
-                <a:r>
-                  <a:rPr lang="de-AT" sz="1000" dirty="0" err="1"/>
-                  <a:t>value</a:t>
-                </a:r>
-                <a:r>
-                  <a:rPr lang="de-AT" sz="1000" dirty="0"/>
-                  <a:t>, </a:t>
-                </a:r>
-                <a:r>
-                  <a:rPr lang="de-AT" sz="1000" dirty="0" err="1"/>
-                  <a:t>calculate</a:t>
-                </a:r>
-                <a:r>
-                  <a:rPr lang="de-AT" sz="1000" dirty="0"/>
-                  <a:t> </a:t>
-                </a:r>
-                <a:r>
-                  <a:rPr lang="de-AT" sz="1000" dirty="0" err="1"/>
-                  <a:t>from</a:t>
-                </a:r>
-                <a:r>
-                  <a:rPr lang="de-AT" sz="1000" dirty="0"/>
-                  <a:t> </a:t>
-                </a:r>
-                <a:r>
-                  <a:rPr lang="de-AT" sz="1000" dirty="0" err="1"/>
-                  <a:t>reference</a:t>
-                </a:r>
-                <a:r>
-                  <a:rPr lang="de-AT" sz="1000" dirty="0"/>
-                  <a:t> </a:t>
-                </a:r>
-                <a:r>
-                  <a:rPr lang="de-AT" sz="1000" dirty="0" err="1"/>
-                  <a:t>simulation</a:t>
-                </a:r>
-                <a:r>
-                  <a:rPr lang="de-AT" sz="1000" dirty="0"/>
-                  <a:t> </a:t>
-                </a:r>
-                <a:r>
-                  <a:rPr lang="de-AT" sz="1000" dirty="0" err="1"/>
-                  <a:t>or</a:t>
-                </a:r>
-                <a:r>
-                  <a:rPr lang="de-AT" sz="1000" dirty="0"/>
-                  <a:t> </a:t>
-                </a:r>
-                <a:r>
-                  <a:rPr lang="de-AT" sz="1000" dirty="0" err="1"/>
-                  <a:t>autoreference</a:t>
-                </a:r>
-                <a:r>
-                  <a:rPr lang="de-AT" sz="1000" dirty="0"/>
-                  <a:t> </a:t>
-                </a:r>
-                <a:r>
-                  <a:rPr lang="de-AT" sz="1000" dirty="0" err="1"/>
-                  <a:t>from</a:t>
-                </a:r>
-                <a:r>
-                  <a:rPr lang="de-AT" sz="1000" dirty="0"/>
-                  <a:t> </a:t>
-                </a:r>
-                <a:r>
-                  <a:rPr lang="de-AT" sz="1000" dirty="0" err="1"/>
-                  <a:t>outer</a:t>
-                </a:r>
-                <a:r>
-                  <a:rPr lang="de-AT" sz="1000" dirty="0"/>
-                  <a:t> </a:t>
-                </a:r>
-                <a:r>
-                  <a:rPr lang="de-AT" sz="1000" dirty="0" err="1"/>
-                  <a:t>grid</a:t>
-                </a:r>
-                <a:r>
-                  <a:rPr lang="de-AT" sz="1000" dirty="0"/>
-                  <a:t> </a:t>
-                </a:r>
-                <a:r>
-                  <a:rPr lang="de-AT" sz="1000" dirty="0" err="1"/>
-                  <a:t>voxels</a:t>
-                </a:r>
-                <a:r>
-                  <a:rPr lang="de-AT" sz="1000" dirty="0"/>
-                  <a:t>, </a:t>
-                </a:r>
-                <a:r>
-                  <a:rPr lang="de-AT" sz="1000" dirty="0" err="1"/>
-                  <a:t>if</a:t>
-                </a:r>
-                <a:r>
-                  <a:rPr lang="de-AT" sz="1000" dirty="0"/>
-                  <a:t> </a:t>
-                </a:r>
-                <a:r>
-                  <a:rPr lang="de-AT" sz="1000" dirty="0" err="1"/>
-                  <a:t>the</a:t>
-                </a:r>
-                <a:r>
-                  <a:rPr lang="de-AT" sz="1000" dirty="0"/>
-                  <a:t> </a:t>
-                </a:r>
-                <a:r>
-                  <a:rPr lang="de-AT" sz="1000" dirty="0" err="1"/>
-                  <a:t>grid</a:t>
-                </a:r>
-                <a:r>
-                  <a:rPr lang="de-AT" sz="1000" dirty="0"/>
-                  <a:t> </a:t>
-                </a:r>
-                <a:r>
-                  <a:rPr lang="de-AT" sz="1000" dirty="0" err="1"/>
-                  <a:t>is</a:t>
-                </a:r>
-                <a:r>
-                  <a:rPr lang="de-AT" sz="1000" dirty="0"/>
-                  <a:t> large </a:t>
-                </a:r>
-                <a:r>
-                  <a:rPr lang="de-AT" sz="1000" dirty="0" err="1"/>
-                  <a:t>enough</a:t>
-                </a:r>
-                <a:r>
-                  <a:rPr lang="de-AT" sz="1000" dirty="0"/>
-                  <a:t> (&gt; 3 solvent </a:t>
-                </a:r>
-                <a:r>
-                  <a:rPr lang="de-AT" sz="1000" dirty="0" err="1"/>
-                  <a:t>layers</a:t>
-                </a:r>
-                <a:r>
-                  <a:rPr lang="de-AT" sz="1000" dirty="0"/>
-                  <a:t>)</a:t>
+                  <a:rPr lang="en-US" sz="1000" noProof="0" dirty="0"/>
+                  <a:t>Use tabulated value, calculate from reference simulation or auto-reference from outer grid voxels, if the grid is large enough (&gt; 3 solvent layers)</a:t>
                 </a:r>
                 <a:br>
-                  <a:rPr lang="de-AT" sz="1000" dirty="0"/>
+                  <a:rPr lang="en-US" sz="1000" noProof="0" dirty="0"/>
                 </a:br>
-                <a:endParaRPr lang="de-AT" sz="1000" dirty="0"/>
+                <a:endParaRPr lang="en-US" sz="1000" noProof="0" dirty="0"/>
               </a:p>
               <a:p>
                 <a:pPr marL="171450" indent="-171450">
@@ -6773,160 +6098,67 @@
                   <a:buChar char="q"/>
                 </a:pPr>
                 <a:r>
-                  <a:rPr lang="de-AT" sz="1200" dirty="0"/>
-                  <a:t>Load gist.dat </a:t>
-                </a:r>
-                <a:r>
-                  <a:rPr lang="de-AT" sz="1200" dirty="0" err="1"/>
-                  <a:t>with</a:t>
-                </a:r>
-                <a:r>
-                  <a:rPr lang="de-AT" sz="1200" dirty="0"/>
-                  <a:t> </a:t>
-                </a:r>
-                <a:r>
-                  <a:rPr lang="de-AT" sz="1200" dirty="0" err="1"/>
-                  <a:t>gisttools</a:t>
+                  <a:rPr lang="en-US" sz="1200" noProof="0" dirty="0"/>
+                  <a:t>Load gist.dat with gisttools</a:t>
                 </a:r>
                 <a:br>
-                  <a:rPr lang="de-AT" sz="1000" dirty="0"/>
+                  <a:rPr lang="en-US" sz="1000" dirty="0"/>
                 </a:br>
                 <a:r>
-                  <a:rPr lang="de-AT" sz="1000" dirty="0"/>
-                  <a:t>Preset </a:t>
+                  <a:rPr lang="en-US" sz="1000" dirty="0"/>
+                  <a:t>A pdb structure of the solute without water is necessary for this. Preset </a:t>
                 </a:r>
+                <a14:m>
+                  <m:oMath xmlns:m="http://schemas.openxmlformats.org/officeDocument/2006/math">
+                    <m:sSub>
+                      <m:sSubPr>
+                        <m:ctrlPr>
+                          <a:rPr lang="en-US" sz="1000" i="1">
+                            <a:latin typeface="Cambria Math" panose="02040503050406030204" pitchFamily="18" charset="0"/>
+                          </a:rPr>
+                        </m:ctrlPr>
+                      </m:sSubPr>
+                      <m:e>
+                        <m:r>
+                          <a:rPr lang="en-US" sz="1000" i="1">
+                            <a:latin typeface="Cambria Math" panose="02040503050406030204" pitchFamily="18" charset="0"/>
+                          </a:rPr>
+                          <m:t>𝐸</m:t>
+                        </m:r>
+                      </m:e>
+                      <m:sub>
+                        <m:r>
+                          <a:rPr lang="en-US" sz="1000" i="1">
+                            <a:latin typeface="Cambria Math" panose="02040503050406030204" pitchFamily="18" charset="0"/>
+                          </a:rPr>
+                          <m:t>𝑤𝑤</m:t>
+                        </m:r>
+                        <m:r>
+                          <a:rPr lang="en-US" sz="1000" i="1">
+                            <a:latin typeface="Cambria Math" panose="02040503050406030204" pitchFamily="18" charset="0"/>
+                          </a:rPr>
+                          <m:t>, </m:t>
+                        </m:r>
+                        <m:r>
+                          <a:rPr lang="en-US" sz="1000" i="1">
+                            <a:latin typeface="Cambria Math" panose="02040503050406030204" pitchFamily="18" charset="0"/>
+                          </a:rPr>
+                          <m:t>𝑟𝑒𝑓</m:t>
+                        </m:r>
+                      </m:sub>
+                    </m:sSub>
+                    <m:r>
+                      <a:rPr lang="en-US" sz="1000" i="1">
+                        <a:latin typeface="Cambria Math" panose="02040503050406030204" pitchFamily="18" charset="0"/>
+                      </a:rPr>
+                      <m:t> </m:t>
+                    </m:r>
+                  </m:oMath>
+                </a14:m>
                 <a:r>
-                  <a:rPr lang="de-AT" sz="1000" dirty="0" err="1"/>
-                  <a:t>Eww,ref</a:t>
+                  <a:rPr lang="en-US" sz="1000" noProof="0" dirty="0"/>
+                  <a:t>or use the auto-referencing. </a:t>
                 </a:r>
-                <a:r>
-                  <a:rPr lang="de-AT" sz="1000" dirty="0"/>
-                  <a:t> </a:t>
-                </a:r>
-                <a:r>
-                  <a:rPr lang="de-AT" sz="1000" dirty="0" err="1"/>
-                  <a:t>or</a:t>
-                </a:r>
-                <a:r>
-                  <a:rPr lang="de-AT" sz="1000" dirty="0"/>
-                  <a:t> </a:t>
-                </a:r>
-                <a:r>
-                  <a:rPr lang="de-AT" sz="1000" dirty="0" err="1"/>
-                  <a:t>use</a:t>
-                </a:r>
-                <a:r>
-                  <a:rPr lang="de-AT" sz="1000" dirty="0"/>
-                  <a:t> </a:t>
-                </a:r>
-                <a:r>
-                  <a:rPr lang="de-AT" sz="1000" dirty="0" err="1"/>
-                  <a:t>the</a:t>
-                </a:r>
-                <a:r>
-                  <a:rPr lang="de-AT" sz="1000" dirty="0"/>
-                  <a:t> </a:t>
-                </a:r>
-                <a:r>
-                  <a:rPr lang="de-AT" sz="1000" dirty="0" err="1"/>
-                  <a:t>autoreferencing</a:t>
-                </a:r>
-                <a:r>
-                  <a:rPr lang="de-AT" sz="1000" dirty="0"/>
-                  <a:t>. A </a:t>
-                </a:r>
-                <a:r>
-                  <a:rPr lang="de-AT" sz="1000" dirty="0" err="1"/>
-                  <a:t>pdb</a:t>
-                </a:r>
-                <a:r>
-                  <a:rPr lang="de-AT" sz="1000" dirty="0"/>
-                  <a:t> </a:t>
-                </a:r>
-                <a:r>
-                  <a:rPr lang="de-AT" sz="1000" dirty="0" err="1"/>
-                  <a:t>structure</a:t>
-                </a:r>
-                <a:r>
-                  <a:rPr lang="de-AT" sz="1000" dirty="0"/>
-                  <a:t> </a:t>
-                </a:r>
-                <a:r>
-                  <a:rPr lang="de-AT" sz="1000" dirty="0" err="1"/>
-                  <a:t>of</a:t>
-                </a:r>
-                <a:r>
-                  <a:rPr lang="de-AT" sz="1000" dirty="0"/>
-                  <a:t> </a:t>
-                </a:r>
-                <a:r>
-                  <a:rPr lang="de-AT" sz="1000" dirty="0" err="1"/>
-                  <a:t>the</a:t>
-                </a:r>
-                <a:r>
-                  <a:rPr lang="de-AT" sz="1000" dirty="0"/>
-                  <a:t> </a:t>
-                </a:r>
-                <a:r>
-                  <a:rPr lang="de-AT" sz="1000" dirty="0" err="1"/>
-                  <a:t>solute</a:t>
-                </a:r>
-                <a:r>
-                  <a:rPr lang="de-AT" sz="1000" dirty="0"/>
-                  <a:t> </a:t>
-                </a:r>
-                <a:r>
-                  <a:rPr lang="de-AT" sz="1000" dirty="0" err="1"/>
-                  <a:t>without</a:t>
-                </a:r>
-                <a:r>
-                  <a:rPr lang="de-AT" sz="1000" dirty="0"/>
-                  <a:t> </a:t>
-                </a:r>
-                <a:r>
-                  <a:rPr lang="de-AT" sz="1000" dirty="0" err="1"/>
-                  <a:t>water</a:t>
-                </a:r>
-                <a:r>
-                  <a:rPr lang="de-AT" sz="1000" dirty="0"/>
-                  <a:t> </a:t>
-                </a:r>
-                <a:r>
-                  <a:rPr lang="de-AT" sz="1000" dirty="0" err="1"/>
-                  <a:t>is</a:t>
-                </a:r>
-                <a:r>
-                  <a:rPr lang="de-AT" sz="1000" dirty="0"/>
-                  <a:t> </a:t>
-                </a:r>
-                <a:r>
-                  <a:rPr lang="de-AT" sz="1000" dirty="0" err="1"/>
-                  <a:t>necessary</a:t>
-                </a:r>
-                <a:r>
-                  <a:rPr lang="de-AT" sz="1000" dirty="0"/>
-                  <a:t> </a:t>
-                </a:r>
-                <a:r>
-                  <a:rPr lang="de-AT" sz="1000" dirty="0" err="1"/>
-                  <a:t>for</a:t>
-                </a:r>
-                <a:r>
-                  <a:rPr lang="de-AT" sz="1000" dirty="0"/>
-                  <a:t> </a:t>
-                </a:r>
-                <a:r>
-                  <a:rPr lang="de-AT" sz="1000" dirty="0" err="1"/>
-                  <a:t>this</a:t>
-                </a:r>
-                <a:r>
-                  <a:rPr lang="de-AT" sz="1000" dirty="0"/>
-                  <a:t>.</a:t>
-                </a:r>
-                <a:br>
-                  <a:rPr lang="de-AT" sz="1000" dirty="0"/>
-                </a:br>
-                <a:endParaRPr lang="de-AT" sz="1000" dirty="0"/>
               </a:p>
               <a:p>
                 <a:pPr marL="171450" indent="-171450">
@@ -6934,13 +6166,13 @@
                   <a:buChar char="q"/>
                 </a:pPr>
                 <a:r>
-                  <a:rPr lang="de-AT" sz="1200" dirty="0"/>
+                  <a:rPr lang="en-US" sz="1200" noProof="0" dirty="0"/>
                   <a:t>Check convergence of thermodynamic properties – integrated values should approach a fixed value with distance from the region of interest (see Figure 4)</a:t>
                 </a:r>
                 <a:br>
-                  <a:rPr lang="de-AT" sz="1200" dirty="0"/>
+                  <a:rPr lang="en-US" sz="1200" noProof="0" dirty="0"/>
                 </a:br>
-                <a:endParaRPr lang="de-AT" sz="1200" dirty="0"/>
+                <a:endParaRPr lang="en-US" sz="1200" noProof="0" dirty="0"/>
               </a:p>
               <a:p>
                 <a:pPr marL="171450" indent="-171450">
@@ -6948,41 +6180,41 @@
                   <a:buChar char="q"/>
                 </a:pPr>
                 <a:r>
-                  <a:rPr lang="de-AT" sz="1200" dirty="0"/>
+                  <a:rPr lang="en-US" sz="1200" noProof="0" dirty="0"/>
                   <a:t>Optional: edit voxel data</a:t>
                 </a:r>
                 <a:br>
-                  <a:rPr lang="de-AT" sz="1000" dirty="0"/>
+                  <a:rPr lang="en-US" sz="1000" noProof="0" dirty="0"/>
                 </a:br>
                 <a:r>
-                  <a:rPr lang="de-AT" sz="1000" dirty="0"/>
+                  <a:rPr lang="en-US" sz="1000" noProof="0" dirty="0"/>
                   <a:t>For example, apply the empirical entropy correction  factor of 0.6.</a:t>
                 </a:r>
                 <a:br>
-                  <a:rPr lang="de-AT" sz="1000" dirty="0"/>
+                  <a:rPr lang="en-US" sz="1000" noProof="0" dirty="0"/>
                 </a:br>
-                <a:endParaRPr lang="de-AT" sz="1000" dirty="0"/>
+                <a:endParaRPr lang="en-US" sz="1000" noProof="0" dirty="0"/>
               </a:p>
               <a:p>
                 <a:pPr marL="171450" indent="-171450">
                   <a:buFont typeface="Wingdings" panose="05000000000000000000" pitchFamily="2" charset="2"/>
                   <a:buChar char="q"/>
                 </a:pPr>
-                <a:endParaRPr lang="de-AT" sz="1000" dirty="0"/>
+                <a:endParaRPr lang="en-US" sz="1000" noProof="0" dirty="0"/>
               </a:p>
               <a:p>
                 <a:pPr marL="171450" indent="-171450">
                   <a:buFont typeface="Wingdings" panose="05000000000000000000" pitchFamily="2" charset="2"/>
                   <a:buChar char="q"/>
                 </a:pPr>
-                <a:endParaRPr lang="de-AT" sz="1000" dirty="0"/>
+                <a:endParaRPr lang="en-US" sz="1000" noProof="0" dirty="0"/>
               </a:p>
               <a:p>
                 <a:pPr marL="171450" indent="-171450">
                   <a:buFont typeface="Wingdings" panose="05000000000000000000" pitchFamily="2" charset="2"/>
                   <a:buChar char="q"/>
                 </a:pPr>
-                <a:endParaRPr lang="en-US" sz="1200" dirty="0"/>
+                <a:endParaRPr lang="en-US" sz="1200" noProof="0" dirty="0"/>
               </a:p>
               <a:p>
                 <a:pPr marL="171450" indent="-171450">
@@ -6990,7 +6222,7 @@
                   <a:buChar char="q"/>
                 </a:pPr>
                 <a:r>
-                  <a:rPr lang="de-AT" sz="1200" dirty="0"/>
+                  <a:rPr lang="en-US" sz="1200" noProof="0" dirty="0"/>
                   <a:t>Use “norm“ data to compare voxel to voxel</a:t>
                 </a:r>
               </a:p>
@@ -7000,8 +6232,8 @@
                   <a:buChar char="q"/>
                 </a:pPr>
                 <a:r>
-                  <a:rPr lang="de-AT" sz="1200" dirty="0"/>
-                  <a:t>Use “dens“ data to integrate over voxels or for visualisation purposes</a:t>
+                  <a:rPr lang="en-US" sz="1200" noProof="0" dirty="0"/>
+                  <a:t>Use “dens“ data to integrate over voxels or for visualization purposes</a:t>
                 </a:r>
               </a:p>
               <a:p>
@@ -7009,15 +6241,15 @@
                   <a:buFont typeface="Wingdings" panose="05000000000000000000" pitchFamily="2" charset="2"/>
                   <a:buChar char="q"/>
                 </a:pPr>
-                <a:endParaRPr lang="de-AT" sz="1200" dirty="0"/>
+                <a:endParaRPr lang="en-US" sz="1200" noProof="0" dirty="0"/>
               </a:p>
               <a:p>
-                <a:endParaRPr lang="de-AT" sz="1200" dirty="0"/>
+                <a:endParaRPr lang="en-US" sz="1200" noProof="0" dirty="0"/>
               </a:p>
               <a:p>
                 <a:r>
-                  <a:rPr lang="de-AT" sz="1200" b="1" dirty="0"/>
-                  <a:t>4b. Visualisation (optional)</a:t>
+                  <a:rPr lang="en-US" sz="1200" b="1" noProof="0" dirty="0"/>
+                  <a:t>4b. Visualization (optional)</a:t>
                 </a:r>
               </a:p>
               <a:p>
@@ -7026,98 +6258,9 @@
                   <a:buChar char="q"/>
                 </a:pPr>
                 <a:r>
-                  <a:rPr lang="de-AT" sz="1200" dirty="0" err="1"/>
-                  <a:t>If</a:t>
+                  <a:rPr lang="en-US" sz="1200" noProof="0" dirty="0"/>
+                  <a:t>If properties were modified or newly created, output density files for visualization</a:t>
                 </a:r>
-                <a:r>
-                  <a:rPr lang="de-AT" sz="1200" dirty="0"/>
-                  <a:t> </a:t>
-                </a:r>
-                <a:r>
-                  <a:rPr lang="de-AT" sz="1200" dirty="0" err="1"/>
-                  <a:t>properties</a:t>
-                </a:r>
-                <a:r>
-                  <a:rPr lang="de-AT" sz="1200" dirty="0"/>
-                  <a:t> </a:t>
-                </a:r>
-                <a:r>
-                  <a:rPr lang="de-AT" sz="1200" dirty="0" err="1"/>
-                  <a:t>were</a:t>
-                </a:r>
-                <a:r>
-                  <a:rPr lang="de-AT" sz="1200" dirty="0"/>
-                  <a:t> </a:t>
-                </a:r>
-                <a:r>
-                  <a:rPr lang="de-AT" sz="1200" dirty="0" err="1"/>
-                  <a:t>modified</a:t>
-                </a:r>
-                <a:r>
-                  <a:rPr lang="de-AT" sz="1200" dirty="0"/>
-                  <a:t> </a:t>
-                </a:r>
-                <a:r>
-                  <a:rPr lang="de-AT" sz="1200" dirty="0" err="1"/>
-                  <a:t>or</a:t>
-                </a:r>
-                <a:r>
-                  <a:rPr lang="de-AT" sz="1200" dirty="0"/>
-                  <a:t> </a:t>
-                </a:r>
-                <a:r>
-                  <a:rPr lang="de-AT" sz="1200" dirty="0" err="1"/>
-                  <a:t>newly</a:t>
-                </a:r>
-                <a:r>
-                  <a:rPr lang="de-AT" sz="1200" dirty="0"/>
-                  <a:t> </a:t>
-                </a:r>
-                <a:r>
-                  <a:rPr lang="de-AT" sz="1200" dirty="0" err="1"/>
-                  <a:t>created</a:t>
-                </a:r>
-                <a:r>
-                  <a:rPr lang="de-AT" sz="1200" dirty="0"/>
-                  <a:t>, </a:t>
-                </a:r>
-                <a:r>
-                  <a:rPr lang="de-AT" sz="1200" dirty="0" err="1"/>
-                  <a:t>output</a:t>
-                </a:r>
-                <a:r>
-                  <a:rPr lang="de-AT" sz="1200" dirty="0"/>
-                  <a:t> </a:t>
-                </a:r>
-                <a:r>
-                  <a:rPr lang="de-AT" sz="1200" dirty="0" err="1"/>
-                  <a:t>density</a:t>
-                </a:r>
-                <a:r>
-                  <a:rPr lang="de-AT" sz="1200" dirty="0"/>
-                  <a:t> </a:t>
-                </a:r>
-                <a:r>
-                  <a:rPr lang="de-AT" sz="1200" dirty="0" err="1"/>
-                  <a:t>files</a:t>
-                </a:r>
-                <a:r>
-                  <a:rPr lang="de-AT" sz="1200" dirty="0"/>
-                  <a:t> </a:t>
-                </a:r>
-                <a:r>
-                  <a:rPr lang="de-AT" sz="1200" dirty="0" err="1"/>
-                  <a:t>for</a:t>
-                </a:r>
-                <a:r>
-                  <a:rPr lang="de-AT" sz="1200" dirty="0"/>
-                  <a:t> </a:t>
-                </a:r>
-                <a:r>
-                  <a:rPr lang="de-AT" sz="1200" dirty="0" err="1"/>
-                  <a:t>visualisation</a:t>
-                </a:r>
-                <a:endParaRPr lang="de-AT" sz="1200" dirty="0"/>
               </a:p>
               <a:p>
                 <a:pPr marL="171450" indent="-171450">
@@ -7125,56 +6268,24 @@
                   <a:buChar char="q"/>
                 </a:pPr>
                 <a:r>
-                  <a:rPr lang="de-AT" sz="1200" dirty="0" err="1"/>
-                  <a:t>Visualize</a:t>
-                </a:r>
-                <a:r>
-                  <a:rPr lang="de-AT" sz="1200" dirty="0"/>
-                  <a:t> .dx </a:t>
-                </a:r>
-                <a:r>
-                  <a:rPr lang="de-AT" sz="1200" dirty="0" err="1"/>
-                  <a:t>files</a:t>
+                  <a:rPr lang="en-US" sz="1200" noProof="0" dirty="0"/>
+                  <a:t>Visualize .dx files</a:t>
                 </a:r>
                 <a:br>
-                  <a:rPr lang="de-AT" sz="1200" dirty="0"/>
+                  <a:rPr lang="en-US" sz="1200" noProof="0" dirty="0"/>
                 </a:br>
                 <a:r>
-                  <a:rPr lang="de-AT" sz="1000" dirty="0"/>
-                  <a:t>e.g. </a:t>
-                </a:r>
-                <a:r>
-                  <a:rPr lang="de-AT" sz="1000" dirty="0" err="1"/>
-                  <a:t>with</a:t>
-                </a:r>
-                <a:r>
-                  <a:rPr lang="de-AT" sz="1000" dirty="0"/>
-                  <a:t> </a:t>
-                </a:r>
-                <a:r>
-                  <a:rPr lang="de-AT" sz="1000" dirty="0" err="1"/>
-                  <a:t>PyMOL</a:t>
-                </a:r>
-                <a:r>
-                  <a:rPr lang="de-AT" sz="1000" dirty="0"/>
-                  <a:t> </a:t>
-                </a:r>
-                <a:r>
-                  <a:rPr lang="de-AT" sz="1000" dirty="0" err="1"/>
-                  <a:t>or</a:t>
-                </a:r>
-                <a:r>
-                  <a:rPr lang="de-AT" sz="1000" dirty="0"/>
-                  <a:t> VMD</a:t>
+                  <a:rPr lang="en-US" sz="1000" noProof="0" dirty="0"/>
+                  <a:t>e.g. with PyMOL or VMD</a:t>
                 </a:r>
               </a:p>
               <a:p>
-                <a:endParaRPr lang="en-US" sz="1200" b="1" dirty="0"/>
+                <a:endParaRPr lang="en-US" sz="1200" b="1" noProof="0" dirty="0"/>
               </a:p>
             </p:txBody>
           </p:sp>
         </mc:Choice>
-        <mc:Fallback xmlns="">
+        <mc:Fallback>
           <p:sp>
             <p:nvSpPr>
               <p:cNvPr id="22" name="TextBox 21">
@@ -7192,7 +6303,7 @@
             <p:spPr>
               <a:xfrm>
                 <a:off x="4656316" y="764495"/>
-                <a:ext cx="2208520" cy="7524560"/>
+                <a:ext cx="2208520" cy="7536871"/>
               </a:xfrm>
               <a:prstGeom prst="rect">
                 <a:avLst/>
@@ -7306,10 +6417,9 @@
           <a:p>
             <a:pPr algn="ctr"/>
             <a:r>
-              <a:rPr lang="de-AT" sz="1200" dirty="0"/>
+              <a:rPr lang="en-US" sz="1200" noProof="0" dirty="0"/>
               <a:t>gist.dat</a:t>
             </a:r>
-            <a:endParaRPr lang="en-US" sz="1200" dirty="0"/>
           </a:p>
         </p:txBody>
       </p:sp>
@@ -7358,10 +6468,9 @@
           <a:p>
             <a:pPr algn="ctr"/>
             <a:r>
-              <a:rPr lang="de-AT" sz="1200" dirty="0"/>
+              <a:rPr lang="en-US" sz="1200" noProof="0" dirty="0"/>
               <a:t>gist.pdb</a:t>
             </a:r>
-            <a:endParaRPr lang="en-US" sz="1200" dirty="0"/>
           </a:p>
         </p:txBody>
       </p:sp>
@@ -7406,35 +6515,14 @@
           <a:p>
             <a:pPr algn="ctr"/>
             <a:r>
-              <a:rPr lang="de-AT" sz="1000" dirty="0"/>
-              <a:t>Load </a:t>
-            </a:r>
-            <a:r>
-              <a:rPr lang="de-AT" sz="1000" dirty="0" err="1"/>
-              <a:t>with</a:t>
-            </a:r>
-            <a:r>
-              <a:rPr lang="de-AT" sz="1000" dirty="0"/>
-              <a:t> </a:t>
-            </a:r>
-            <a:r>
-              <a:rPr lang="de-AT" sz="1000" dirty="0" err="1"/>
-              <a:t>gisttools</a:t>
-            </a:r>
-            <a:r>
-              <a:rPr lang="de-AT" sz="1000" dirty="0"/>
-              <a:t> in </a:t>
-            </a:r>
-            <a:r>
-              <a:rPr lang="de-AT" sz="1000" dirty="0" err="1"/>
-              <a:t>python</a:t>
-            </a:r>
-            <a:endParaRPr lang="en-US" sz="1000" dirty="0"/>
-          </a:p>
-        </p:txBody>
-      </p:sp>
-      <mc:AlternateContent xmlns:mc="http://schemas.openxmlformats.org/markup-compatibility/2006" xmlns:a14="http://schemas.microsoft.com/office/drawing/2010/main">
-        <mc:Choice Requires="a14">
+              <a:rPr lang="en-US" sz="1000" noProof="0" dirty="0"/>
+              <a:t>Load with gisttools in python</a:t>
+            </a:r>
+          </a:p>
+        </p:txBody>
+      </p:sp>
+      <mc:AlternateContent xmlns:mc="http://schemas.openxmlformats.org/markup-compatibility/2006">
+        <mc:Choice xmlns:a14="http://schemas.microsoft.com/office/drawing/2010/main" Requires="a14">
           <p:sp>
             <p:nvSpPr>
               <p:cNvPr id="8" name="Rectangle: Rounded Corners 7">
@@ -7476,31 +6564,15 @@
               <a:p>
                 <a:pPr algn="ctr"/>
                 <a:r>
-                  <a:rPr lang="de-AT" sz="1000" dirty="0"/>
-                  <a:t>Check </a:t>
-                </a:r>
-                <a:r>
-                  <a:rPr lang="de-AT" sz="1000" dirty="0" err="1"/>
-                  <a:t>convergence</a:t>
-                </a:r>
-                <a:r>
-                  <a:rPr lang="de-AT" sz="1000" dirty="0"/>
-                  <a:t> </a:t>
-                </a:r>
-                <a:r>
-                  <a:rPr lang="de-AT" sz="1000" dirty="0" err="1"/>
-                  <a:t>of</a:t>
-                </a:r>
-                <a:r>
-                  <a:rPr lang="de-AT" sz="1000" dirty="0"/>
-                  <a:t> </a:t>
+                  <a:rPr lang="en-US" sz="1000" noProof="0" dirty="0"/>
+                  <a:t>Check convergence of </a:t>
                 </a:r>
                 <a14:m>
                   <m:oMath xmlns:m="http://schemas.openxmlformats.org/officeDocument/2006/math">
                     <m:sSub>
                       <m:sSubPr>
                         <m:ctrlPr>
-                          <a:rPr lang="de-AT" sz="1000" b="0" i="1" smtClean="0">
+                          <a:rPr lang="en-US" sz="1000" b="0" i="1" noProof="0" smtClean="0">
                             <a:latin typeface="Cambria Math" panose="02040503050406030204" pitchFamily="18" charset="0"/>
                           </a:rPr>
                         </m:ctrlPr>
@@ -7510,13 +6582,13 @@
                           <m:rPr>
                             <m:sty m:val="p"/>
                           </m:rPr>
-                          <a:rPr lang="de-AT" sz="1000" b="0" i="0" smtClean="0">
+                          <a:rPr lang="en-US" sz="1000" b="0" i="0" noProof="0" smtClean="0">
                             <a:latin typeface="Cambria Math" panose="02040503050406030204" pitchFamily="18" charset="0"/>
                           </a:rPr>
                           <m:t>Δ</m:t>
                         </m:r>
                         <m:r>
-                          <a:rPr lang="de-AT" sz="1000" b="0" i="1" smtClean="0">
+                          <a:rPr lang="en-US" sz="1000" b="0" i="1" noProof="0" smtClean="0">
                             <a:latin typeface="Cambria Math" panose="02040503050406030204" pitchFamily="18" charset="0"/>
                           </a:rPr>
                           <m:t>𝐸</m:t>
@@ -7524,7 +6596,7 @@
                       </m:e>
                       <m:sub>
                         <m:r>
-                          <a:rPr lang="de-AT" sz="1000" b="0" i="1" smtClean="0">
+                          <a:rPr lang="en-US" sz="1000" b="0" i="1" noProof="0" smtClean="0">
                             <a:latin typeface="Cambria Math" panose="02040503050406030204" pitchFamily="18" charset="0"/>
                           </a:rPr>
                           <m:t>𝑤𝑤</m:t>
@@ -7532,7 +6604,7 @@
                       </m:sub>
                     </m:sSub>
                     <m:r>
-                      <a:rPr lang="de-AT" sz="1000" b="0" i="1" smtClean="0">
+                      <a:rPr lang="en-US" sz="1000" b="0" i="1" noProof="0" smtClean="0">
                         <a:latin typeface="Cambria Math" panose="02040503050406030204" pitchFamily="18" charset="0"/>
                       </a:rPr>
                       <m:t>, </m:t>
@@ -7540,14 +6612,14 @@
                     <m:sSub>
                       <m:sSubPr>
                         <m:ctrlPr>
-                          <a:rPr lang="de-AT" sz="1000" b="0" i="1" smtClean="0">
+                          <a:rPr lang="en-US" sz="1000" b="0" i="1" noProof="0" smtClean="0">
                             <a:latin typeface="Cambria Math" panose="02040503050406030204" pitchFamily="18" charset="0"/>
                           </a:rPr>
                         </m:ctrlPr>
                       </m:sSubPr>
                       <m:e>
                         <m:r>
-                          <a:rPr lang="de-AT" sz="1000" b="0" i="1" smtClean="0">
+                          <a:rPr lang="en-US" sz="1000" b="0" i="1" noProof="0" smtClean="0">
                             <a:latin typeface="Cambria Math" panose="02040503050406030204" pitchFamily="18" charset="0"/>
                           </a:rPr>
                           <m:t> </m:t>
@@ -7556,13 +6628,13 @@
                           <m:rPr>
                             <m:sty m:val="p"/>
                           </m:rPr>
-                          <a:rPr lang="de-AT" sz="1000" b="0" i="0" smtClean="0">
+                          <a:rPr lang="en-US" sz="1000" b="0" i="0" noProof="0" smtClean="0">
                             <a:latin typeface="Cambria Math" panose="02040503050406030204" pitchFamily="18" charset="0"/>
                           </a:rPr>
                           <m:t>Δ</m:t>
                         </m:r>
                         <m:r>
-                          <a:rPr lang="de-AT" sz="1000" b="0" i="1" smtClean="0">
+                          <a:rPr lang="en-US" sz="1000" b="0" i="1" noProof="0" smtClean="0">
                             <a:latin typeface="Cambria Math" panose="02040503050406030204" pitchFamily="18" charset="0"/>
                           </a:rPr>
                           <m:t>𝐸</m:t>
@@ -7570,7 +6642,7 @@
                       </m:e>
                       <m:sub>
                         <m:r>
-                          <a:rPr lang="de-AT" sz="1000" b="0" i="1" smtClean="0">
+                          <a:rPr lang="en-US" sz="1000" b="0" i="1" noProof="0" smtClean="0">
                             <a:latin typeface="Cambria Math" panose="02040503050406030204" pitchFamily="18" charset="0"/>
                           </a:rPr>
                           <m:t>𝑠𝑤</m:t>
@@ -7578,13 +6650,13 @@
                       </m:sub>
                     </m:sSub>
                     <m:r>
-                      <a:rPr lang="de-AT" sz="1000" b="0" i="1" smtClean="0">
+                      <a:rPr lang="en-US" sz="1000" b="0" i="1" noProof="0" smtClean="0">
                         <a:latin typeface="Cambria Math" panose="02040503050406030204" pitchFamily="18" charset="0"/>
                       </a:rPr>
                       <m:t>,  </m:t>
                     </m:r>
                     <m:r>
-                      <a:rPr lang="de-AT" sz="1000" b="0" i="1" smtClean="0">
+                      <a:rPr lang="en-US" sz="1000" b="0" i="1" noProof="0" smtClean="0">
                         <a:latin typeface="Cambria Math" panose="02040503050406030204" pitchFamily="18" charset="0"/>
                       </a:rPr>
                       <m:t>𝑇</m:t>
@@ -7593,19 +6665,19 @@
                       <m:rPr>
                         <m:sty m:val="p"/>
                       </m:rPr>
-                      <a:rPr lang="de-AT" sz="1000" b="0" i="0" smtClean="0">
+                      <a:rPr lang="en-US" sz="1000" b="0" i="0" noProof="0" smtClean="0">
                         <a:latin typeface="Cambria Math" panose="02040503050406030204" pitchFamily="18" charset="0"/>
                       </a:rPr>
                       <m:t>Δ</m:t>
                     </m:r>
                     <m:r>
-                      <a:rPr lang="de-AT" sz="1000" b="0" i="1" smtClean="0">
+                      <a:rPr lang="en-US" sz="1000" b="0" i="1" noProof="0" smtClean="0">
                         <a:latin typeface="Cambria Math" panose="02040503050406030204" pitchFamily="18" charset="0"/>
                       </a:rPr>
                       <m:t>𝑆</m:t>
                     </m:r>
                     <m:r>
-                      <a:rPr lang="de-AT" sz="1000" b="0" i="1" smtClean="0">
+                      <a:rPr lang="en-US" sz="1000" b="0" i="1" noProof="0" smtClean="0">
                         <a:latin typeface="Cambria Math" panose="02040503050406030204" pitchFamily="18" charset="0"/>
                       </a:rPr>
                       <m:t>,  </m:t>
@@ -7614,7 +6686,7 @@
                       <m:rPr>
                         <m:sty m:val="p"/>
                       </m:rPr>
-                      <a:rPr lang="de-AT" sz="1000" b="0" i="0" smtClean="0">
+                      <a:rPr lang="en-US" sz="1000" b="0" i="0" noProof="0" smtClean="0">
                         <a:latin typeface="Cambria Math" panose="02040503050406030204" pitchFamily="18" charset="0"/>
                       </a:rPr>
                       <m:t>Δ</m:t>
@@ -7622,14 +6694,14 @@
                     <m:sSub>
                       <m:sSubPr>
                         <m:ctrlPr>
-                          <a:rPr lang="de-AT" sz="1000" b="0" i="1" smtClean="0">
+                          <a:rPr lang="en-US" sz="1000" b="0" i="1" noProof="0" smtClean="0">
                             <a:latin typeface="Cambria Math" panose="02040503050406030204" pitchFamily="18" charset="0"/>
                           </a:rPr>
                         </m:ctrlPr>
                       </m:sSubPr>
                       <m:e>
                         <m:r>
-                          <a:rPr lang="en-150" sz="1000" b="0" i="1" smtClean="0">
+                          <a:rPr lang="en-US" sz="1000" b="0" i="1" noProof="0" smtClean="0">
                             <a:latin typeface="Cambria Math" panose="02040503050406030204" pitchFamily="18" charset="0"/>
                           </a:rPr>
                           <m:t>𝐴</m:t>
@@ -7637,7 +6709,7 @@
                       </m:e>
                       <m:sub>
                         <m:r>
-                          <a:rPr lang="de-AT" sz="1000" b="0" i="1" smtClean="0">
+                          <a:rPr lang="en-US" sz="1000" b="0" i="1" noProof="0" smtClean="0">
                             <a:latin typeface="Cambria Math" panose="02040503050406030204" pitchFamily="18" charset="0"/>
                           </a:rPr>
                           <m:t>𝑠𝑜𝑙𝑣</m:t>
@@ -7646,12 +6718,12 @@
                     </m:sSub>
                   </m:oMath>
                 </a14:m>
-                <a:endParaRPr lang="en-US" sz="1000" dirty="0"/>
+                <a:endParaRPr lang="en-US" sz="1000" noProof="0" dirty="0"/>
               </a:p>
             </p:txBody>
           </p:sp>
         </mc:Choice>
-        <mc:Fallback xmlns="">
+        <mc:Fallback>
           <p:sp>
             <p:nvSpPr>
               <p:cNvPr id="8" name="Rectangle: Rounded Corners 7">
@@ -7686,7 +6758,7 @@
               <a:lstStyle/>
               <a:p>
                 <a:r>
-                  <a:rPr lang="de-AT">
+                  <a:rPr lang="en-US">
                     <a:noFill/>
                   </a:rPr>
                   <a:t> </a:t>
@@ -7696,8 +6768,8 @@
           </p:sp>
         </mc:Fallback>
       </mc:AlternateContent>
-      <mc:AlternateContent xmlns:mc="http://schemas.openxmlformats.org/markup-compatibility/2006" xmlns:a14="http://schemas.microsoft.com/office/drawing/2010/main">
-        <mc:Choice Requires="a14">
+      <mc:AlternateContent xmlns:mc="http://schemas.openxmlformats.org/markup-compatibility/2006">
+        <mc:Choice xmlns:a14="http://schemas.microsoft.com/office/drawing/2010/main" Requires="a14">
           <p:sp>
             <p:nvSpPr>
               <p:cNvPr id="11" name="Parallelogram 10">
@@ -7742,7 +6814,7 @@
               <a:lstStyle/>
               <a:p>
                 <a:pPr algn="ctr"/>
-                <a:endParaRPr lang="de-AT" sz="1200" b="0" dirty="0"/>
+                <a:endParaRPr lang="en-US" sz="1200" b="0" noProof="0" dirty="0"/>
               </a:p>
               <a:p>
                 <a:pPr algn="ctr"/>
@@ -7755,14 +6827,14 @@
                       <m:sSub>
                         <m:sSubPr>
                           <m:ctrlPr>
-                            <a:rPr lang="de-AT" sz="1200" b="0" i="1" smtClean="0">
+                            <a:rPr lang="en-US" sz="1200" b="0" i="1" noProof="0" smtClean="0">
                               <a:latin typeface="Cambria Math" panose="02040503050406030204" pitchFamily="18" charset="0"/>
                             </a:rPr>
                           </m:ctrlPr>
                         </m:sSubPr>
                         <m:e>
                           <m:r>
-                            <a:rPr lang="de-AT" sz="1200" b="0" i="1" smtClean="0">
+                            <a:rPr lang="en-US" sz="1200" b="0" i="1" noProof="0" smtClean="0">
                               <a:latin typeface="Cambria Math" panose="02040503050406030204" pitchFamily="18" charset="0"/>
                             </a:rPr>
                             <m:t>𝐸</m:t>
@@ -7770,19 +6842,19 @@
                         </m:e>
                         <m:sub>
                           <m:r>
-                            <a:rPr lang="de-AT" sz="1200" b="0" i="1" smtClean="0">
+                            <a:rPr lang="en-US" sz="1200" b="0" i="1" noProof="0" smtClean="0">
                               <a:latin typeface="Cambria Math" panose="02040503050406030204" pitchFamily="18" charset="0"/>
                             </a:rPr>
                             <m:t>𝑤𝑤</m:t>
                           </m:r>
                           <m:r>
-                            <a:rPr lang="de-AT" sz="1200" b="0" i="1" smtClean="0">
+                            <a:rPr lang="en-US" sz="1200" b="0" i="1" noProof="0" smtClean="0">
                               <a:latin typeface="Cambria Math" panose="02040503050406030204" pitchFamily="18" charset="0"/>
                             </a:rPr>
                             <m:t>, </m:t>
                           </m:r>
                           <m:r>
-                            <a:rPr lang="de-AT" sz="1200" b="0" i="1" smtClean="0">
+                            <a:rPr lang="en-US" sz="1200" b="0" i="1" noProof="0" smtClean="0">
                               <a:latin typeface="Cambria Math" panose="02040503050406030204" pitchFamily="18" charset="0"/>
                             </a:rPr>
                             <m:t>𝑟𝑒𝑓</m:t>
@@ -7792,16 +6864,16 @@
                     </m:oMath>
                   </m:oMathPara>
                 </a14:m>
-                <a:endParaRPr lang="de-AT" sz="1200" b="0" dirty="0"/>
+                <a:endParaRPr lang="en-US" sz="1200" b="0" noProof="0" dirty="0"/>
               </a:p>
               <a:p>
                 <a:pPr algn="ctr"/>
-                <a:endParaRPr lang="en-US" sz="1200" dirty="0"/>
+                <a:endParaRPr lang="en-US" sz="1200" noProof="0" dirty="0"/>
               </a:p>
             </p:txBody>
           </p:sp>
         </mc:Choice>
-        <mc:Fallback xmlns="">
+        <mc:Fallback>
           <p:sp>
             <p:nvSpPr>
               <p:cNvPr id="11" name="Parallelogram 10">
@@ -7889,14 +6961,9 @@
           <a:p>
             <a:pPr algn="ctr"/>
             <a:r>
-              <a:rPr lang="de-AT" sz="1000" dirty="0" err="1"/>
-              <a:t>Converged</a:t>
-            </a:r>
-            <a:r>
-              <a:rPr lang="de-AT" sz="1000" dirty="0"/>
-              <a:t>?</a:t>
-            </a:r>
-            <a:endParaRPr lang="en-US" sz="1000" dirty="0"/>
+              <a:rPr lang="en-US" sz="1000" noProof="0" dirty="0"/>
+              <a:t>Converged?</a:t>
+            </a:r>
           </a:p>
         </p:txBody>
       </p:sp>
@@ -7945,8 +7012,8 @@
           </a:fontRef>
         </p:style>
       </p:cxnSp>
-      <mc:AlternateContent xmlns:mc="http://schemas.openxmlformats.org/markup-compatibility/2006" xmlns:a14="http://schemas.microsoft.com/office/drawing/2010/main">
-        <mc:Choice Requires="a14">
+      <mc:AlternateContent xmlns:mc="http://schemas.openxmlformats.org/markup-compatibility/2006">
+        <mc:Choice xmlns:a14="http://schemas.microsoft.com/office/drawing/2010/main" Requires="a14">
           <p:sp>
             <p:nvSpPr>
               <p:cNvPr id="17" name="Rectangle: Rounded Corners 16">
@@ -7987,11 +7054,11 @@
               <a:lstStyle/>
               <a:p>
                 <a:r>
-                  <a:rPr lang="de-AT" sz="800" dirty="0"/>
+                  <a:rPr lang="en-US" sz="800" noProof="0" dirty="0"/>
                   <a:t>Common fixes:</a:t>
                 </a:r>
                 <a:br>
-                  <a:rPr lang="de-AT" sz="800" i="1" dirty="0">
+                  <a:rPr lang="en-US" sz="800" i="1" noProof="0" dirty="0">
                     <a:latin typeface="Cambria Math" panose="02040503050406030204" pitchFamily="18" charset="0"/>
                   </a:rPr>
                 </a:br>
@@ -8000,14 +7067,14 @@
                     <m:sSub>
                       <m:sSubPr>
                         <m:ctrlPr>
-                          <a:rPr lang="de-AT" sz="800" i="1" smtClean="0">
+                          <a:rPr lang="en-US" sz="800" i="1" noProof="0" smtClean="0">
                             <a:latin typeface="Cambria Math" panose="02040503050406030204" pitchFamily="18" charset="0"/>
                           </a:rPr>
                         </m:ctrlPr>
                       </m:sSubPr>
                       <m:e>
                         <m:r>
-                          <a:rPr lang="de-AT" sz="800" i="1">
+                          <a:rPr lang="en-US" sz="800" i="1" noProof="0" smtClean="0">
                             <a:latin typeface="Cambria Math" panose="02040503050406030204" pitchFamily="18" charset="0"/>
                           </a:rPr>
                           <m:t> </m:t>
@@ -8016,13 +7083,13 @@
                           <m:rPr>
                             <m:sty m:val="p"/>
                           </m:rPr>
-                          <a:rPr lang="de-AT" sz="800">
+                          <a:rPr lang="en-US" sz="800" noProof="0" smtClean="0">
                             <a:latin typeface="Cambria Math" panose="02040503050406030204" pitchFamily="18" charset="0"/>
                           </a:rPr>
                           <m:t>Δ</m:t>
                         </m:r>
                         <m:r>
-                          <a:rPr lang="de-AT" sz="800" i="1">
+                          <a:rPr lang="en-US" sz="800" i="1" noProof="0" smtClean="0">
                             <a:latin typeface="Cambria Math" panose="02040503050406030204" pitchFamily="18" charset="0"/>
                           </a:rPr>
                           <m:t>𝐸</m:t>
@@ -8030,13 +7097,13 @@
                       </m:e>
                       <m:sub>
                         <m:r>
-                          <a:rPr lang="de-AT" sz="800" b="0" i="1" smtClean="0">
+                          <a:rPr lang="en-US" sz="800" b="0" i="1" noProof="0" smtClean="0">
                             <a:latin typeface="Cambria Math" panose="02040503050406030204" pitchFamily="18" charset="0"/>
                           </a:rPr>
                           <m:t>𝑤</m:t>
                         </m:r>
                         <m:r>
-                          <a:rPr lang="de-AT" sz="800" i="1">
+                          <a:rPr lang="en-US" sz="800" i="1" noProof="0" smtClean="0">
                             <a:latin typeface="Cambria Math" panose="02040503050406030204" pitchFamily="18" charset="0"/>
                           </a:rPr>
                           <m:t>𝑤</m:t>
@@ -8044,13 +7111,13 @@
                       </m:sub>
                     </m:sSub>
                     <m:r>
-                      <a:rPr lang="de-AT" sz="800" b="0" i="1" smtClean="0">
+                      <a:rPr lang="en-US" sz="800" b="0" i="1" noProof="0" smtClean="0">
                         <a:latin typeface="Cambria Math" panose="02040503050406030204" pitchFamily="18" charset="0"/>
                       </a:rPr>
                       <m:t>:</m:t>
                     </m:r>
                     <m:r>
-                      <a:rPr lang="de-AT" sz="800" i="1">
+                      <a:rPr lang="en-US" sz="800" i="1" noProof="0" smtClean="0">
                         <a:latin typeface="Cambria Math" panose="02040503050406030204" pitchFamily="18" charset="0"/>
                       </a:rPr>
                       <m:t> </m:t>
@@ -8058,22 +7125,22 @@
                   </m:oMath>
                 </a14:m>
                 <a:r>
-                  <a:rPr lang="de-AT" sz="800" dirty="0"/>
-                  <a:t>Change </a:t>
+                  <a:rPr lang="en-US" sz="800" noProof="0" dirty="0"/>
+                  <a:t> Change </a:t>
                 </a:r>
                 <a14:m>
                   <m:oMath xmlns:m="http://schemas.openxmlformats.org/officeDocument/2006/math">
                     <m:sSub>
                       <m:sSubPr>
                         <m:ctrlPr>
-                          <a:rPr lang="de-AT" sz="800" b="0" i="1" dirty="0" smtClean="0">
+                          <a:rPr lang="en-US" sz="800" b="0" i="1" noProof="0" smtClean="0">
                             <a:latin typeface="Cambria Math" panose="02040503050406030204" pitchFamily="18" charset="0"/>
                           </a:rPr>
                         </m:ctrlPr>
                       </m:sSubPr>
                       <m:e>
                         <m:r>
-                          <a:rPr lang="de-AT" sz="800" b="0" i="1" dirty="0" smtClean="0">
+                          <a:rPr lang="en-US" sz="800" b="0" i="1" noProof="0" smtClean="0">
                             <a:latin typeface="Cambria Math" panose="02040503050406030204" pitchFamily="18" charset="0"/>
                           </a:rPr>
                           <m:t>𝐸</m:t>
@@ -8081,19 +7148,19 @@
                       </m:e>
                       <m:sub>
                         <m:r>
-                          <a:rPr lang="de-AT" sz="800" b="0" i="1" dirty="0" smtClean="0">
+                          <a:rPr lang="en-US" sz="800" b="0" i="1" noProof="0" smtClean="0">
                             <a:latin typeface="Cambria Math" panose="02040503050406030204" pitchFamily="18" charset="0"/>
                           </a:rPr>
                           <m:t>𝑤𝑤</m:t>
                         </m:r>
                         <m:r>
-                          <a:rPr lang="de-AT" sz="800" b="0" i="1" dirty="0" smtClean="0">
+                          <a:rPr lang="en-US" sz="800" b="0" i="1" noProof="0" smtClean="0">
                             <a:latin typeface="Cambria Math" panose="02040503050406030204" pitchFamily="18" charset="0"/>
                           </a:rPr>
                           <m:t>, </m:t>
                         </m:r>
                         <m:r>
-                          <a:rPr lang="de-AT" sz="800" b="0" i="1" dirty="0" smtClean="0">
+                          <a:rPr lang="en-US" sz="800" b="0" i="1" noProof="0" smtClean="0">
                             <a:latin typeface="Cambria Math" panose="02040503050406030204" pitchFamily="18" charset="0"/>
                           </a:rPr>
                           <m:t>𝑟𝑒𝑓</m:t>
@@ -8102,13 +7169,13 @@
                     </m:sSub>
                   </m:oMath>
                 </a14:m>
-                <a:endParaRPr lang="de-AT" sz="800" dirty="0"/>
+                <a:endParaRPr lang="en-US" sz="800" noProof="0" dirty="0"/>
               </a:p>
               <a:p>
                 <a14:m>
                   <m:oMath xmlns:m="http://schemas.openxmlformats.org/officeDocument/2006/math">
                     <m:r>
-                      <a:rPr lang="de-AT" sz="800" b="0" i="1" smtClean="0">
+                      <a:rPr lang="en-US" sz="800" b="0" i="1" noProof="0" smtClean="0">
                         <a:latin typeface="Cambria Math" panose="02040503050406030204" pitchFamily="18" charset="0"/>
                       </a:rPr>
                       <m:t>𝑇</m:t>
@@ -8117,43 +7184,35 @@
                       <m:rPr>
                         <m:sty m:val="p"/>
                       </m:rPr>
-                      <a:rPr lang="de-AT" sz="800" b="0" i="0" smtClean="0">
+                      <a:rPr lang="en-US" sz="800" b="0" i="0" noProof="0" smtClean="0">
                         <a:latin typeface="Cambria Math" panose="02040503050406030204" pitchFamily="18" charset="0"/>
                       </a:rPr>
                       <m:t>Δ</m:t>
                     </m:r>
                     <m:r>
-                      <a:rPr lang="de-AT" sz="800" b="0" i="1" smtClean="0">
+                      <a:rPr lang="en-US" sz="800" b="0" i="1" noProof="0" smtClean="0">
                         <a:latin typeface="Cambria Math" panose="02040503050406030204" pitchFamily="18" charset="0"/>
                       </a:rPr>
                       <m:t>𝑆</m:t>
                     </m:r>
                     <m:r>
-                      <a:rPr lang="de-AT" sz="800" b="0" i="1" smtClean="0">
+                      <a:rPr lang="en-US" sz="800" b="0" i="1" noProof="0" smtClean="0">
                         <a:latin typeface="Cambria Math" panose="02040503050406030204" pitchFamily="18" charset="0"/>
                       </a:rPr>
                       <m:t>:</m:t>
                     </m:r>
                     <m:r>
-                      <m:rPr>
-                        <m:sty m:val="p"/>
-                      </m:rPr>
-                      <a:rPr lang="de-AT" sz="800" b="0" i="0" smtClean="0">
+                      <a:rPr lang="de-AT" sz="800" b="0" i="0" noProof="0" smtClean="0">
                         <a:latin typeface="Cambria Math" panose="02040503050406030204" pitchFamily="18" charset="0"/>
                       </a:rPr>
-                      <m:t>r</m:t>
+                      <m:t> </m:t>
                     </m:r>
                   </m:oMath>
                 </a14:m>
                 <a:r>
-                  <a:rPr lang="de-AT" sz="800" dirty="0"/>
-                  <a:t>eference </a:t>
+                  <a:rPr lang="en-US" sz="800" noProof="0" dirty="0"/>
+                  <a:t> reference entropy</a:t>
                 </a:r>
-                <a:r>
-                  <a:rPr lang="de-AT" sz="800" dirty="0" err="1"/>
-                  <a:t>entropy</a:t>
-                </a:r>
-                <a:endParaRPr lang="de-AT" sz="800" dirty="0"/>
               </a:p>
               <a:p>
                 <a14:m>
@@ -8161,14 +7220,14 @@
                     <m:sSub>
                       <m:sSubPr>
                         <m:ctrlPr>
-                          <a:rPr lang="de-AT" sz="800" b="0" i="1" smtClean="0">
+                          <a:rPr lang="en-US" sz="800" b="0" i="1" noProof="0" smtClean="0">
                             <a:latin typeface="Cambria Math" panose="02040503050406030204" pitchFamily="18" charset="0"/>
                           </a:rPr>
                         </m:ctrlPr>
                       </m:sSubPr>
                       <m:e>
                         <m:r>
-                          <a:rPr lang="de-AT" sz="800" b="0" i="1" smtClean="0">
+                          <a:rPr lang="en-US" sz="800" b="0" i="1" noProof="0" smtClean="0">
                             <a:latin typeface="Cambria Math" panose="02040503050406030204" pitchFamily="18" charset="0"/>
                           </a:rPr>
                           <m:t> </m:t>
@@ -8177,13 +7236,13 @@
                           <m:rPr>
                             <m:sty m:val="p"/>
                           </m:rPr>
-                          <a:rPr lang="de-AT" sz="800" b="0" i="0" smtClean="0">
+                          <a:rPr lang="en-US" sz="800" b="0" i="0" noProof="0" smtClean="0">
                             <a:latin typeface="Cambria Math" panose="02040503050406030204" pitchFamily="18" charset="0"/>
                           </a:rPr>
                           <m:t>Δ</m:t>
                         </m:r>
                         <m:r>
-                          <a:rPr lang="de-AT" sz="800" b="0" i="1" smtClean="0">
+                          <a:rPr lang="en-US" sz="800" b="0" i="1" noProof="0" smtClean="0">
                             <a:latin typeface="Cambria Math" panose="02040503050406030204" pitchFamily="18" charset="0"/>
                           </a:rPr>
                           <m:t>𝐸</m:t>
@@ -8191,7 +7250,7 @@
                       </m:e>
                       <m:sub>
                         <m:r>
-                          <a:rPr lang="de-AT" sz="800" b="0" i="1" smtClean="0">
+                          <a:rPr lang="en-US" sz="800" b="0" i="1" noProof="0" smtClean="0">
                             <a:latin typeface="Cambria Math" panose="02040503050406030204" pitchFamily="18" charset="0"/>
                           </a:rPr>
                           <m:t>𝑠𝑤</m:t>
@@ -8201,19 +7260,14 @@
                   </m:oMath>
                 </a14:m>
                 <a:r>
-                  <a:rPr lang="de-AT" sz="800" dirty="0"/>
-                  <a:t>: More  </a:t>
+                  <a:rPr lang="en-US" sz="800" noProof="0" dirty="0"/>
+                  <a:t>:  More  sampling</a:t>
                 </a:r>
-                <a:r>
-                  <a:rPr lang="en-150" sz="800" dirty="0"/>
-                  <a:t>sampling</a:t>
-                </a:r>
-                <a:endParaRPr lang="en-US" sz="800" dirty="0"/>
               </a:p>
             </p:txBody>
           </p:sp>
         </mc:Choice>
-        <mc:Fallback xmlns="">
+        <mc:Fallback>
           <p:sp>
             <p:nvSpPr>
               <p:cNvPr id="17" name="Rectangle: Rounded Corners 16">
@@ -8323,10 +7377,9 @@
             <a:p>
               <a:pPr algn="ctr"/>
               <a:r>
-                <a:rPr lang="de-AT" sz="1200" dirty="0"/>
-                <a:t>“norm“ data</a:t>
+                <a:rPr lang="en-US" sz="1200" noProof="0" dirty="0"/>
+                <a:t>"norm" data</a:t>
               </a:r>
-              <a:endParaRPr lang="en-US" sz="1200" dirty="0"/>
             </a:p>
           </p:txBody>
         </p:sp>
@@ -8375,10 +7428,9 @@
             <a:p>
               <a:pPr algn="ctr"/>
               <a:r>
-                <a:rPr lang="de-AT" sz="1200" dirty="0"/>
-                <a:t>“dens“ data</a:t>
+                <a:rPr lang="en-US" sz="1200" noProof="0" dirty="0"/>
+                <a:t>"dens" data</a:t>
               </a:r>
-              <a:endParaRPr lang="en-US" sz="1200" dirty="0"/>
             </a:p>
           </p:txBody>
         </p:sp>
@@ -8427,26 +7479,9 @@
           <a:p>
             <a:pPr algn="ctr"/>
             <a:r>
-              <a:rPr lang="de-AT" sz="1000" dirty="0" err="1"/>
-              <a:t>Compare</a:t>
-            </a:r>
-            <a:r>
-              <a:rPr lang="de-AT" sz="1000" dirty="0"/>
-              <a:t> </a:t>
-            </a:r>
-            <a:r>
-              <a:rPr lang="de-AT" sz="1000" dirty="0" err="1"/>
-              <a:t>voxels</a:t>
-            </a:r>
-            <a:r>
-              <a:rPr lang="de-AT" sz="1000" dirty="0"/>
-              <a:t> on a per-solvent </a:t>
-            </a:r>
-            <a:r>
-              <a:rPr lang="de-AT" sz="1000" dirty="0" err="1"/>
-              <a:t>basis</a:t>
-            </a:r>
-            <a:endParaRPr lang="en-US" sz="1000" dirty="0"/>
+              <a:rPr lang="en-US" sz="1000" noProof="0" dirty="0"/>
+              <a:t>Compare voxels on a per-solvent basis</a:t>
+            </a:r>
           </a:p>
         </p:txBody>
       </p:sp>
@@ -8494,66 +7529,9 @@
           <a:p>
             <a:pPr algn="ctr"/>
             <a:r>
-              <a:rPr lang="de-AT" sz="1000" dirty="0" err="1"/>
-              <a:t>Integrate</a:t>
-            </a:r>
-            <a:r>
-              <a:rPr lang="de-AT" sz="1000" dirty="0"/>
-              <a:t> </a:t>
-            </a:r>
-            <a:r>
-              <a:rPr lang="de-AT" sz="1000" dirty="0" err="1"/>
-              <a:t>over</a:t>
-            </a:r>
-            <a:r>
-              <a:rPr lang="de-AT" sz="1000" dirty="0"/>
-              <a:t> </a:t>
-            </a:r>
-            <a:r>
-              <a:rPr lang="de-AT" sz="1000" dirty="0" err="1"/>
-              <a:t>grid</a:t>
-            </a:r>
-            <a:r>
-              <a:rPr lang="de-AT" sz="1000" dirty="0"/>
-              <a:t> </a:t>
-            </a:r>
-            <a:r>
-              <a:rPr lang="de-AT" sz="1000" dirty="0" err="1"/>
-              <a:t>volumes</a:t>
-            </a:r>
-            <a:r>
-              <a:rPr lang="de-AT" sz="1000" dirty="0"/>
-              <a:t> </a:t>
-            </a:r>
-            <a:r>
-              <a:rPr lang="de-AT" sz="1000" dirty="0" err="1"/>
-              <a:t>to</a:t>
-            </a:r>
-            <a:r>
-              <a:rPr lang="de-AT" sz="1000" dirty="0"/>
-              <a:t> </a:t>
-            </a:r>
-            <a:r>
-              <a:rPr lang="de-AT" sz="1000" dirty="0" err="1"/>
-              <a:t>calculate</a:t>
-            </a:r>
-            <a:r>
-              <a:rPr lang="de-AT" sz="1000" dirty="0"/>
-              <a:t> </a:t>
-            </a:r>
-            <a:r>
-              <a:rPr lang="de-AT" sz="1000" dirty="0" err="1"/>
-              <a:t>thermodynamic</a:t>
-            </a:r>
-            <a:r>
-              <a:rPr lang="de-AT" sz="1000" dirty="0"/>
-              <a:t> </a:t>
-            </a:r>
-            <a:r>
-              <a:rPr lang="de-AT" sz="1000" dirty="0" err="1"/>
-              <a:t>data</a:t>
-            </a:r>
-            <a:endParaRPr lang="en-US" sz="1000" dirty="0"/>
+              <a:rPr lang="en-US" sz="1000" noProof="0" dirty="0"/>
+              <a:t>Integrate over grid volumes to calculate thermodynamic data</a:t>
+            </a:r>
           </a:p>
         </p:txBody>
       </p:sp>
@@ -8601,14 +7579,9 @@
           <a:p>
             <a:pPr algn="ctr"/>
             <a:r>
-              <a:rPr lang="de-AT" sz="1000" dirty="0"/>
-              <a:t>Output .dx </a:t>
-            </a:r>
-            <a:r>
-              <a:rPr lang="de-AT" sz="1000" dirty="0" err="1"/>
-              <a:t>files</a:t>
-            </a:r>
-            <a:endParaRPr lang="en-US" sz="1000" dirty="0"/>
+              <a:rPr lang="en-US" sz="1000" noProof="0" dirty="0"/>
+              <a:t>Output .dx files</a:t>
+            </a:r>
           </a:p>
         </p:txBody>
       </p:sp>
@@ -8660,10 +7633,9 @@
           <a:p>
             <a:pPr algn="ctr"/>
             <a:r>
-              <a:rPr lang="de-AT" sz="1200" dirty="0" err="1"/>
+              <a:rPr lang="en-US" sz="1200" noProof="0" dirty="0"/>
               <a:t>Isosurfaces</a:t>
             </a:r>
-            <a:endParaRPr lang="en-US" sz="1200" dirty="0"/>
           </a:p>
         </p:txBody>
       </p:sp>
@@ -8715,10 +7687,9 @@
           <a:p>
             <a:pPr algn="ctr"/>
             <a:r>
-              <a:rPr lang="de-AT" sz="1200" dirty="0" err="1"/>
+              <a:rPr lang="en-US" sz="1200" noProof="0" dirty="0"/>
               <a:t>Volumes</a:t>
             </a:r>
-            <a:endParaRPr lang="en-US" sz="1200" dirty="0"/>
           </a:p>
         </p:txBody>
       </p:sp>
@@ -8770,14 +7741,9 @@
           <a:p>
             <a:pPr algn="ctr"/>
             <a:r>
-              <a:rPr lang="de-AT" sz="1200" dirty="0"/>
-              <a:t>Mesh </a:t>
-            </a:r>
-            <a:r>
-              <a:rPr lang="de-AT" sz="1200" dirty="0" err="1"/>
-              <a:t>grids</a:t>
-            </a:r>
-            <a:endParaRPr lang="en-US" sz="1200" dirty="0"/>
+              <a:rPr lang="en-US" sz="1200" noProof="0" dirty="0"/>
+              <a:t>Mesh grids</a:t>
+            </a:r>
           </a:p>
         </p:txBody>
       </p:sp>
@@ -8825,38 +7791,9 @@
           <a:p>
             <a:pPr algn="ctr"/>
             <a:r>
-              <a:rPr lang="de-AT" sz="1000" dirty="0"/>
-              <a:t>Load .dx </a:t>
-            </a:r>
-            <a:r>
-              <a:rPr lang="de-AT" sz="1000" dirty="0" err="1"/>
-              <a:t>files</a:t>
-            </a:r>
-            <a:r>
-              <a:rPr lang="de-AT" sz="1000" dirty="0"/>
-              <a:t> </a:t>
-            </a:r>
-            <a:r>
-              <a:rPr lang="de-AT" sz="1000" dirty="0" err="1"/>
-              <a:t>into</a:t>
-            </a:r>
-            <a:r>
-              <a:rPr lang="de-AT" sz="1000" dirty="0"/>
-              <a:t> </a:t>
-            </a:r>
-            <a:r>
-              <a:rPr lang="de-AT" sz="1000" dirty="0" err="1"/>
-              <a:t>visualisation</a:t>
-            </a:r>
-            <a:r>
-              <a:rPr lang="de-AT" sz="1000" dirty="0"/>
-              <a:t> </a:t>
-            </a:r>
-            <a:r>
-              <a:rPr lang="de-AT" sz="1000" dirty="0" err="1"/>
-              <a:t>software</a:t>
-            </a:r>
-            <a:endParaRPr lang="en-US" sz="1000" dirty="0"/>
+              <a:rPr lang="en-US" sz="1000" noProof="0" dirty="0"/>
+              <a:t>Load .dx files into visualization software</a:t>
+            </a:r>
           </a:p>
         </p:txBody>
       </p:sp>
@@ -8904,26 +7841,9 @@
           <a:p>
             <a:pPr algn="ctr"/>
             <a:r>
-              <a:rPr lang="de-AT" sz="1000" dirty="0" err="1"/>
-              <a:t>Visualize</a:t>
-            </a:r>
-            <a:r>
-              <a:rPr lang="de-AT" sz="1000" dirty="0"/>
-              <a:t> </a:t>
-            </a:r>
-            <a:r>
-              <a:rPr lang="de-AT" sz="1000" dirty="0" err="1"/>
-              <a:t>thermodynamic</a:t>
-            </a:r>
-            <a:r>
-              <a:rPr lang="de-AT" sz="1000" dirty="0"/>
-              <a:t> </a:t>
-            </a:r>
-            <a:r>
-              <a:rPr lang="de-AT" sz="1000" dirty="0" err="1"/>
-              <a:t>densities</a:t>
-            </a:r>
-            <a:endParaRPr lang="en-US" sz="1000" dirty="0"/>
+              <a:rPr lang="en-US" sz="1000" noProof="0" dirty="0"/>
+              <a:t>Visualize thermodynamic densities</a:t>
+            </a:r>
           </a:p>
         </p:txBody>
       </p:sp>
@@ -8971,22 +7891,9 @@
           <a:p>
             <a:pPr algn="ctr"/>
             <a:r>
-              <a:rPr lang="de-AT" sz="1000" dirty="0"/>
-              <a:t>Edit </a:t>
-            </a:r>
-            <a:r>
-              <a:rPr lang="de-AT" sz="1000" dirty="0" err="1"/>
-              <a:t>voxel</a:t>
-            </a:r>
-            <a:r>
-              <a:rPr lang="de-AT" sz="1000" dirty="0"/>
-              <a:t> </a:t>
-            </a:r>
-            <a:r>
-              <a:rPr lang="de-AT" sz="1000" dirty="0" err="1"/>
-              <a:t>data</a:t>
-            </a:r>
-            <a:endParaRPr lang="en-US" sz="1000" dirty="0"/>
+              <a:rPr lang="en-US" sz="1000" noProof="0" dirty="0"/>
+              <a:t>Edit voxel data</a:t>
+            </a:r>
           </a:p>
         </p:txBody>
       </p:sp>
@@ -9765,10 +8672,9 @@
             <a:lstStyle/>
             <a:p>
               <a:r>
-                <a:rPr lang="de-AT" sz="1000" b="1" dirty="0"/>
+                <a:rPr lang="en-US" sz="1000" b="1" noProof="0" dirty="0"/>
                 <a:t>optional</a:t>
               </a:r>
-              <a:endParaRPr lang="en-US" sz="1000" b="1" dirty="0"/>
             </a:p>
           </p:txBody>
         </p:sp>
@@ -9802,10 +8708,9 @@
           <a:lstStyle/>
           <a:p>
             <a:r>
-              <a:rPr lang="de-AT" sz="1000" b="1" dirty="0" err="1"/>
+              <a:rPr lang="en-US" sz="1000" b="1" noProof="0" dirty="0"/>
               <a:t>yes</a:t>
             </a:r>
-            <a:endParaRPr lang="en-US" sz="1000" b="1" dirty="0"/>
           </a:p>
         </p:txBody>
       </p:sp>
@@ -9838,10 +8743,9 @@
           <a:lstStyle/>
           <a:p>
             <a:r>
-              <a:rPr lang="de-AT" sz="1000" b="1" dirty="0" err="1"/>
+              <a:rPr lang="en-US" sz="1000" b="1" noProof="0" dirty="0"/>
               <a:t>no</a:t>
             </a:r>
-            <a:endParaRPr lang="en-US" sz="1000" b="1" dirty="0"/>
           </a:p>
         </p:txBody>
       </p:sp>
@@ -9893,10 +8797,9 @@
           <a:p>
             <a:pPr algn="ctr"/>
             <a:r>
-              <a:rPr lang="de-AT" sz="1200" dirty="0" err="1"/>
+              <a:rPr lang="en-US" sz="1200" noProof="0" dirty="0"/>
               <a:t>Isodots</a:t>
             </a:r>
-            <a:endParaRPr lang="en-US" sz="1200" dirty="0"/>
           </a:p>
         </p:txBody>
       </p:sp>

</xml_diff>